<commit_message>
Highlight deterministic reliability, cost efficiency and adoption
</commit_message>
<xml_diff>
--- a/submission/SpitchAI-Build-Arena-Submission.pptx
+++ b/submission/SpitchAI-Build-Arena-Submission.pptx
@@ -2,19 +2,19 @@
 <file path=ppt/presentation.xml><?xml version="1.0" encoding="utf-8"?>
 <p:presentation xmlns:p="http://schemas.openxmlformats.org/presentationml/2006/main">
   <p:sldMasterIdLst>
-    <p:sldMasterId xmlns:r="http://schemas.openxmlformats.org/officeDocument/2006/relationships" id="2147483648" r:id="R6e3664e682ac483f"/>
+    <p:sldMasterId xmlns:r="http://schemas.openxmlformats.org/officeDocument/2006/relationships" id="2147483648" r:id="R97bc6ef72289470d"/>
   </p:sldMasterIdLst>
   <p:notesMasterIdLst>
-    <p:notesMasterId xmlns:r="http://schemas.openxmlformats.org/officeDocument/2006/relationships" r:id="Rfe66575642ed402e"/>
+    <p:notesMasterId xmlns:r="http://schemas.openxmlformats.org/officeDocument/2006/relationships" r:id="R97d9589df3ee4e91"/>
   </p:notesMasterIdLst>
   <p:sldIdLst>
-    <p:sldId xmlns:r="http://schemas.openxmlformats.org/officeDocument/2006/relationships" id="256" r:id="Rcf58067498ed4d86"/>
-    <p:sldId xmlns:r="http://schemas.openxmlformats.org/officeDocument/2006/relationships" id="257" r:id="R462cbe950ba04091"/>
-    <p:sldId xmlns:r="http://schemas.openxmlformats.org/officeDocument/2006/relationships" id="258" r:id="R3b53e1aaef624b6c"/>
-    <p:sldId xmlns:r="http://schemas.openxmlformats.org/officeDocument/2006/relationships" id="259" r:id="R1d31d99057be4935"/>
-    <p:sldId xmlns:r="http://schemas.openxmlformats.org/officeDocument/2006/relationships" id="260" r:id="R41b9ee5c527d4a6b"/>
-    <p:sldId xmlns:r="http://schemas.openxmlformats.org/officeDocument/2006/relationships" id="261" r:id="Rc853740e339045ce"/>
-    <p:sldId xmlns:r="http://schemas.openxmlformats.org/officeDocument/2006/relationships" id="262" r:id="Rb556164c15f044e0"/>
+    <p:sldId xmlns:r="http://schemas.openxmlformats.org/officeDocument/2006/relationships" id="256" r:id="R236b05bd9c8f4566"/>
+    <p:sldId xmlns:r="http://schemas.openxmlformats.org/officeDocument/2006/relationships" id="257" r:id="R5b5e2137dc71408c"/>
+    <p:sldId xmlns:r="http://schemas.openxmlformats.org/officeDocument/2006/relationships" id="258" r:id="R767eeff60d074568"/>
+    <p:sldId xmlns:r="http://schemas.openxmlformats.org/officeDocument/2006/relationships" id="259" r:id="Rab7edd2e8dde4e33"/>
+    <p:sldId xmlns:r="http://schemas.openxmlformats.org/officeDocument/2006/relationships" id="260" r:id="R6a0572a375104f73"/>
+    <p:sldId xmlns:r="http://schemas.openxmlformats.org/officeDocument/2006/relationships" id="261" r:id="Rbcbf580bc0e745e4"/>
+    <p:sldId xmlns:r="http://schemas.openxmlformats.org/officeDocument/2006/relationships" id="262" r:id="Rf60eef10db564d2a"/>
   </p:sldIdLst>
   <p:sldSz cx="12192000" cy="6858000"/>
   <p:notesSz cx="6858000" cy="9144000"/>
@@ -798,7 +798,7 @@
           <a:lstStyle xmlns:a="http://schemas.openxmlformats.org/drawingml/2006/main"/>
           <a:p xmlns:a="http://schemas.openxmlformats.org/drawingml/2006/main">
             <a:r>
-              <a:t>The hackathon scope centers on the compiler, a curated module catalog, restricted task expressions, an ElevenLabs real-time test experience, web publishing and session traces. The full demonstration also includes phone integration or a documented simulation when no number is available, as permitted by the official track. A changed supported requirement should yield changed computational behavior without manual application-specific backend edits. Broader module coverage and isolated generation form the expansion path. Evaluation will measure build success, computational correctness, latency and total usage cost.</a:t>
+              <a:t>Impact hypothesis: for supported calculations and rules, tested deterministic operations provide repeatable outputs for the same inputs and versioned dependencies. The conversational layer and requirement planning still use probabilistic models. Reliability depends on correct modules, validated inputs and handling external failures. Compiling reusable workflows can reduce repeated LLM reasoning calls for those computations. Total cost still includes planning, voice usage, transport, tool execution and infrastructure, so the cost advantage requires benchmarking. More predictable behavior and understandable costs can help users trust and adopt the system; adoption requires user testing. The feasible MVP uses a curated module catalog, restricted task expressions and shared execution infrastructure. Validate result correctness, total usage cost and adoption rather than claiming measured improvements. Full demonstration includes the ElevenLabs voice agent, publishing, session traces and the phone integration or permitted simulation.</a:t>
             </a:r>
           </a:p>
         </p:txBody>
@@ -3311,12 +3311,12 @@
   </p:cSld>
   <p:clrMap bg1="lt1" tx1="dk1" bg2="lt2" tx2="dk2" accent1="accent1" accent2="accent2" accent3="accent3" accent4="accent4" accent5="accent5" accent6="accent6" hlink="hlink" folHlink="folHlink"/>
   <p:sldLayoutIdLst>
-    <p:sldLayoutId xmlns:r="http://schemas.openxmlformats.org/officeDocument/2006/relationships" id="2147483649" r:id="R1d263cb00914444f"/>
-    <p:sldLayoutId xmlns:r="http://schemas.openxmlformats.org/officeDocument/2006/relationships" id="2147483650" r:id="Rcf10803bd91f442d"/>
-    <p:sldLayoutId xmlns:r="http://schemas.openxmlformats.org/officeDocument/2006/relationships" id="2147483651" r:id="R7f5b896234354faa"/>
-    <p:sldLayoutId xmlns:r="http://schemas.openxmlformats.org/officeDocument/2006/relationships" id="2147483652" r:id="Rf2df0dfd5b3948c8"/>
-    <p:sldLayoutId xmlns:r="http://schemas.openxmlformats.org/officeDocument/2006/relationships" id="2147483653" r:id="Rcc58180edfdc4f44"/>
-    <p:sldLayoutId xmlns:r="http://schemas.openxmlformats.org/officeDocument/2006/relationships" id="2147483654" r:id="Re9d96ba1254947e4"/>
+    <p:sldLayoutId xmlns:r="http://schemas.openxmlformats.org/officeDocument/2006/relationships" id="2147483649" r:id="R8408421f0fa44d2b"/>
+    <p:sldLayoutId xmlns:r="http://schemas.openxmlformats.org/officeDocument/2006/relationships" id="2147483650" r:id="Rf8006c26314c4568"/>
+    <p:sldLayoutId xmlns:r="http://schemas.openxmlformats.org/officeDocument/2006/relationships" id="2147483651" r:id="R94969bd30613410c"/>
+    <p:sldLayoutId xmlns:r="http://schemas.openxmlformats.org/officeDocument/2006/relationships" id="2147483652" r:id="R149de3a180ee40ab"/>
+    <p:sldLayoutId xmlns:r="http://schemas.openxmlformats.org/officeDocument/2006/relationships" id="2147483653" r:id="Raa238d1d824949e3"/>
+    <p:sldLayoutId xmlns:r="http://schemas.openxmlformats.org/officeDocument/2006/relationships" id="2147483654" r:id="Reedf58ef7a564872"/>
   </p:sldLayoutIdLst>
   <p:txStyles>
     <p:titleStyle>
@@ -4036,7 +4036,7 @@
           <p:nvPr/>
         </p:nvPicPr>
         <p:blipFill>
-          <a:blip xmlns:r="http://schemas.openxmlformats.org/officeDocument/2006/relationships" xmlns:a="http://schemas.openxmlformats.org/drawingml/2006/main" r:embed="Ra9199cf6f52045a5"/>
+          <a:blip xmlns:r="http://schemas.openxmlformats.org/officeDocument/2006/relationships" xmlns:a="http://schemas.openxmlformats.org/drawingml/2006/main" r:embed="R6b16093717be4a2e"/>
           <a:stretch xmlns:a="http://schemas.openxmlformats.org/drawingml/2006/main"/>
         </p:blipFill>
         <p:spPr>
@@ -4746,7 +4746,7 @@
           <p:nvPr/>
         </p:nvPicPr>
         <p:blipFill>
-          <a:blip xmlns:r="http://schemas.openxmlformats.org/officeDocument/2006/relationships" xmlns:a="http://schemas.openxmlformats.org/drawingml/2006/main" r:embed="R6232a482e3314ab1"/>
+          <a:blip xmlns:r="http://schemas.openxmlformats.org/officeDocument/2006/relationships" xmlns:a="http://schemas.openxmlformats.org/drawingml/2006/main" r:embed="R43565ca63f3242d0"/>
           <a:stretch xmlns:a="http://schemas.openxmlformats.org/drawingml/2006/main"/>
         </p:blipFill>
         <p:spPr>
@@ -12762,7 +12762,7 @@
           <p:nvPr/>
         </p:nvPicPr>
         <p:blipFill>
-          <a:blip xmlns:r="http://schemas.openxmlformats.org/officeDocument/2006/relationships" xmlns:a="http://schemas.openxmlformats.org/drawingml/2006/main" r:embed="R61457288c110494b"/>
+          <a:blip xmlns:r="http://schemas.openxmlformats.org/officeDocument/2006/relationships" xmlns:a="http://schemas.openxmlformats.org/drawingml/2006/main" r:embed="R1ba9f33aece64704"/>
           <a:stretch xmlns:a="http://schemas.openxmlformats.org/drawingml/2006/main"/>
         </p:blipFill>
         <p:spPr>
@@ -12949,10 +12949,10 @@
           <p:nvPr/>
         </p:nvPicPr>
         <p:blipFill>
-          <a:blip xmlns:r="http://schemas.openxmlformats.org/officeDocument/2006/relationships" xmlns:a="http://schemas.openxmlformats.org/drawingml/2006/main" r:embed="R7f0b37c60e9f421e">
+          <a:blip xmlns:r="http://schemas.openxmlformats.org/officeDocument/2006/relationships" xmlns:a="http://schemas.openxmlformats.org/drawingml/2006/main" r:embed="R9500b479a2a845b9">
             <a:extLst>
               <a:ext uri="{96DAC541-7B7A-43D3-8B79-37D633B846F1}">
-                <asvg:svgBlip xmlns:asvg="http://schemas.microsoft.com/office/drawing/2016/SVG/main" r:embed="R05ecdbb7df5842a2"/>
+                <asvg:svgBlip xmlns:asvg="http://schemas.microsoft.com/office/drawing/2016/SVG/main" r:embed="Rc07d91f3927f4057"/>
               </a:ext>
             </a:extLst>
           </a:blip>
@@ -12983,7 +12983,7 @@
           <p:nvPr/>
         </p:nvPicPr>
         <p:blipFill>
-          <a:blip xmlns:r="http://schemas.openxmlformats.org/officeDocument/2006/relationships" xmlns:a="http://schemas.openxmlformats.org/drawingml/2006/main" r:embed="R45ffd95e4f1248cd"/>
+          <a:blip xmlns:r="http://schemas.openxmlformats.org/officeDocument/2006/relationships" xmlns:a="http://schemas.openxmlformats.org/drawingml/2006/main" r:embed="Rece89d1e187d4e21"/>
           <a:stretch xmlns:a="http://schemas.openxmlformats.org/drawingml/2006/main"/>
         </p:blipFill>
         <p:spPr>
@@ -16740,70 +16740,70 @@
           <a:bodyPr xmlns:a="http://schemas.openxmlformats.org/drawingml/2006/main" lIns="0" tIns="0" rIns="0" bIns="0"/>
           <a:lstStyle xmlns:a="http://schemas.openxmlformats.org/drawingml/2006/main">
             <a:defPPr>
-              <a:defRPr sz="4575" b="1">
+              <a:defRPr sz="4275" b="1">
                 <a:solidFill>
                   <a:srgbClr val="FFFFFF"/>
                 </a:solidFill>
               </a:defRPr>
             </a:defPPr>
             <a:lvl1pPr>
-              <a:defRPr sz="4575" b="1">
+              <a:defRPr sz="4275" b="1">
                 <a:solidFill>
                   <a:srgbClr val="FFFFFF"/>
                 </a:solidFill>
               </a:defRPr>
             </a:lvl1pPr>
             <a:lvl2pPr>
-              <a:defRPr sz="4575" b="1">
+              <a:defRPr sz="4275" b="1">
                 <a:solidFill>
                   <a:srgbClr val="FFFFFF"/>
                 </a:solidFill>
               </a:defRPr>
             </a:lvl2pPr>
             <a:lvl3pPr>
-              <a:defRPr sz="4575" b="1">
+              <a:defRPr sz="4275" b="1">
                 <a:solidFill>
                   <a:srgbClr val="FFFFFF"/>
                 </a:solidFill>
               </a:defRPr>
             </a:lvl3pPr>
             <a:lvl4pPr>
-              <a:defRPr sz="4575" b="1">
+              <a:defRPr sz="4275" b="1">
                 <a:solidFill>
                   <a:srgbClr val="FFFFFF"/>
                 </a:solidFill>
               </a:defRPr>
             </a:lvl4pPr>
             <a:lvl5pPr>
-              <a:defRPr sz="4575" b="1">
+              <a:defRPr sz="4275" b="1">
                 <a:solidFill>
                   <a:srgbClr val="FFFFFF"/>
                 </a:solidFill>
               </a:defRPr>
             </a:lvl5pPr>
             <a:lvl6pPr>
-              <a:defRPr sz="4575" b="1">
+              <a:defRPr sz="4275" b="1">
                 <a:solidFill>
                   <a:srgbClr val="FFFFFF"/>
                 </a:solidFill>
               </a:defRPr>
             </a:lvl6pPr>
             <a:lvl7pPr>
-              <a:defRPr sz="4575" b="1">
+              <a:defRPr sz="4275" b="1">
                 <a:solidFill>
                   <a:srgbClr val="FFFFFF"/>
                 </a:solidFill>
               </a:defRPr>
             </a:lvl7pPr>
             <a:lvl8pPr>
-              <a:defRPr sz="4575" b="1">
+              <a:defRPr sz="4275" b="1">
                 <a:solidFill>
                   <a:srgbClr val="FFFFFF"/>
                 </a:solidFill>
               </a:defRPr>
             </a:lvl8pPr>
             <a:lvl9pPr>
-              <a:defRPr sz="4575" b="1">
+              <a:defRPr sz="4275" b="1">
                 <a:solidFill>
                   <a:srgbClr val="FFFFFF"/>
                 </a:solidFill>
@@ -16812,36 +16812,36 @@
           </a:lstStyle>
           <a:p xmlns:a="http://schemas.openxmlformats.org/drawingml/2006/main">
             <a:pPr>
-              <a:defRPr sz="4575" b="1">
+              <a:defRPr sz="4275" b="1">
                 <a:solidFill>
                   <a:srgbClr val="FFFFFF"/>
                 </a:solidFill>
               </a:defRPr>
             </a:pPr>
             <a:r>
-              <a:rPr sz="4575" b="1">
+              <a:rPr sz="4275" b="1">
                 <a:solidFill>
                   <a:srgbClr val="FFFFFF"/>
                 </a:solidFill>
               </a:rPr>
-              <a:t>Big vision.</a:t>
+              <a:t>Deterministic execution.</a:t>
             </a:r>
           </a:p>
           <a:p xmlns:a="http://schemas.openxmlformats.org/drawingml/2006/main">
             <a:pPr>
-              <a:defRPr sz="4575" b="1">
+              <a:defRPr sz="4275" b="1">
                 <a:solidFill>
                   <a:srgbClr val="FFFFFF"/>
                 </a:solidFill>
               </a:defRPr>
             </a:pPr>
             <a:r>
-              <a:rPr sz="4575" b="1">
+              <a:rPr sz="4275" b="1">
                 <a:solidFill>
                   <a:srgbClr val="FFFFFF"/>
                 </a:solidFill>
               </a:rPr>
-              <a:t>A focused hackathon build</a:t>
+              <a:t>More dependable voice agents</a:t>
             </a:r>
           </a:p>
         </p:txBody>
@@ -17116,7 +17116,7 @@
                   <a:srgbClr val="FFFFFF"/>
                 </a:solidFill>
               </a:rPr>
-              <a:t>Compile</a:t>
+              <a:t>Reliability</a:t>
             </a:r>
           </a:p>
         </p:txBody>
@@ -17237,7 +17237,7 @@
                   <a:srgbClr val="FFFFFF"/>
                 </a:solidFill>
               </a:rPr>
-              <a:t>A request becomes a typed</a:t>
+              <a:t>Tested rules make supported</a:t>
             </a:r>
           </a:p>
           <a:p xmlns:a="http://schemas.openxmlformats.org/drawingml/2006/main">
@@ -17254,7 +17254,7 @@
                   <a:srgbClr val="FFFFFF"/>
                 </a:solidFill>
               </a:rPr>
-              <a:t>execution plan and tool APIs.</a:t>
+              <a:t>computations repeatable.</a:t>
             </a:r>
           </a:p>
         </p:txBody>
@@ -17529,7 +17529,7 @@
                   <a:srgbClr val="FFFFFF"/>
                 </a:solidFill>
               </a:rPr>
-              <a:t>Connect</a:t>
+              <a:t>Cost efficiency</a:t>
             </a:r>
           </a:p>
         </p:txBody>
@@ -17650,7 +17650,7 @@
                   <a:srgbClr val="FFFFFF"/>
                 </a:solidFill>
               </a:rPr>
-              <a:t>ElevenLabs calls the tools</a:t>
+              <a:t>Reusable workflows reduce</a:t>
             </a:r>
           </a:p>
           <a:p xmlns:a="http://schemas.openxmlformats.org/drawingml/2006/main">
@@ -17667,7 +17667,7 @@
                   <a:srgbClr val="FFFFFF"/>
                 </a:solidFill>
               </a:rPr>
-              <a:t>during a live conversation.</a:t>
+              <a:t>repeated LLM reasoning calls.</a:t>
             </a:r>
           </a:p>
         </p:txBody>
@@ -17942,7 +17942,7 @@
                   <a:srgbClr val="FFFFFF"/>
                 </a:solidFill>
               </a:rPr>
-              <a:t>Prove</a:t>
+              <a:t>Easier adoption</a:t>
             </a:r>
           </a:p>
         </p:txBody>
@@ -18063,7 +18063,7 @@
                   <a:srgbClr val="FFFFFF"/>
                 </a:solidFill>
               </a:rPr>
-              <a:t>A changed requirement</a:t>
+              <a:t>Predictable outcomes and</a:t>
             </a:r>
           </a:p>
           <a:p xmlns:a="http://schemas.openxmlformats.org/drawingml/2006/main">
@@ -18080,7 +18080,7 @@
                   <a:srgbClr val="FFFFFF"/>
                 </a:solidFill>
               </a:rPr>
-              <a:t>produces a changed backend.</a:t>
+              <a:t>clearer costs can build trust.</a:t>
             </a:r>
           </a:p>
         </p:txBody>
@@ -18201,7 +18201,7 @@
                   <a:srgbClr val="FFFFFF"/>
                 </a:solidFill>
               </a:rPr>
-              <a:t>HACKATHON SCOPE</a:t>
+              <a:t>FEASIBLE MVP</a:t>
             </a:r>
           </a:p>
         </p:txBody>
@@ -18322,7 +18322,7 @@
                   <a:srgbClr val="FFFFFF"/>
                 </a:solidFill>
               </a:rPr>
-              <a:t>Curated modules, task expressions, web deployment and session traces</a:t>
+              <a:t>Curated modules and task expressions run on shared execution infrastructure.</a:t>
             </a:r>
           </a:p>
         </p:txBody>
@@ -18443,7 +18443,7 @@
                   <a:srgbClr val="FFFFFF"/>
                 </a:solidFill>
               </a:rPr>
-              <a:t>Goal: help people build useful voice agents without writing backend code</a:t>
+              <a:t>Benefits to validate: result correctness, total usage cost and user adoption</a:t>
             </a:r>
           </a:p>
         </p:txBody>

</xml_diff>

<commit_message>
Add illustrative cost savings and capability infographic
</commit_message>
<xml_diff>
--- a/submission/SpitchAI-Build-Arena-Submission.pptx
+++ b/submission/SpitchAI-Build-Arena-Submission.pptx
@@ -2,19 +2,19 @@
 <file path=ppt/presentation.xml><?xml version="1.0" encoding="utf-8"?>
 <p:presentation xmlns:p="http://schemas.openxmlformats.org/presentationml/2006/main">
   <p:sldMasterIdLst>
-    <p:sldMasterId xmlns:r="http://schemas.openxmlformats.org/officeDocument/2006/relationships" id="2147483648" r:id="R97bc6ef72289470d"/>
+    <p:sldMasterId xmlns:r="http://schemas.openxmlformats.org/officeDocument/2006/relationships" id="2147483648" r:id="R6192e1055631417d"/>
   </p:sldMasterIdLst>
   <p:notesMasterIdLst>
-    <p:notesMasterId xmlns:r="http://schemas.openxmlformats.org/officeDocument/2006/relationships" r:id="R97d9589df3ee4e91"/>
+    <p:notesMasterId xmlns:r="http://schemas.openxmlformats.org/officeDocument/2006/relationships" r:id="R881c680e45ac43ec"/>
   </p:notesMasterIdLst>
   <p:sldIdLst>
-    <p:sldId xmlns:r="http://schemas.openxmlformats.org/officeDocument/2006/relationships" id="256" r:id="R236b05bd9c8f4566"/>
-    <p:sldId xmlns:r="http://schemas.openxmlformats.org/officeDocument/2006/relationships" id="257" r:id="R5b5e2137dc71408c"/>
-    <p:sldId xmlns:r="http://schemas.openxmlformats.org/officeDocument/2006/relationships" id="258" r:id="R767eeff60d074568"/>
-    <p:sldId xmlns:r="http://schemas.openxmlformats.org/officeDocument/2006/relationships" id="259" r:id="Rab7edd2e8dde4e33"/>
-    <p:sldId xmlns:r="http://schemas.openxmlformats.org/officeDocument/2006/relationships" id="260" r:id="R6a0572a375104f73"/>
-    <p:sldId xmlns:r="http://schemas.openxmlformats.org/officeDocument/2006/relationships" id="261" r:id="Rbcbf580bc0e745e4"/>
-    <p:sldId xmlns:r="http://schemas.openxmlformats.org/officeDocument/2006/relationships" id="262" r:id="Rf60eef10db564d2a"/>
+    <p:sldId xmlns:r="http://schemas.openxmlformats.org/officeDocument/2006/relationships" id="256" r:id="R0ae7542d1843429a"/>
+    <p:sldId xmlns:r="http://schemas.openxmlformats.org/officeDocument/2006/relationships" id="257" r:id="R9bd8d61c055243ac"/>
+    <p:sldId xmlns:r="http://schemas.openxmlformats.org/officeDocument/2006/relationships" id="258" r:id="Re2fa3ed688514acb"/>
+    <p:sldId xmlns:r="http://schemas.openxmlformats.org/officeDocument/2006/relationships" id="259" r:id="R7bf1d11a4f0c4da8"/>
+    <p:sldId xmlns:r="http://schemas.openxmlformats.org/officeDocument/2006/relationships" id="260" r:id="R291e62ce2a4540c8"/>
+    <p:sldId xmlns:r="http://schemas.openxmlformats.org/officeDocument/2006/relationships" id="261" r:id="Rb236e0483f174364"/>
+    <p:sldId xmlns:r="http://schemas.openxmlformats.org/officeDocument/2006/relationships" id="262" r:id="Re23fb469543043af"/>
   </p:sldIdLst>
   <p:sldSz cx="12192000" cy="6858000"/>
   <p:notesSz cx="6858000" cy="9144000"/>
@@ -798,7 +798,7 @@
           <a:lstStyle xmlns:a="http://schemas.openxmlformats.org/drawingml/2006/main"/>
           <a:p xmlns:a="http://schemas.openxmlformats.org/drawingml/2006/main">
             <a:r>
-              <a:t>Impact hypothesis: for supported calculations and rules, tested deterministic operations provide repeatable outputs for the same inputs and versioned dependencies. The conversational layer and requirement planning still use probabilistic models. Reliability depends on correct modules, validated inputs and handling external failures. Compiling reusable workflows can reduce repeated LLM reasoning calls for those computations. Total cost still includes planning, voice usage, transport, tool execution and infrastructure, so the cost advantage requires benchmarking. More predictable behavior and understandable costs can help users trust and adopt the system; adoption requires user testing. The feasible MVP uses a curated module catalog, restricted task expressions and shared execution infrastructure. Validate result correctness, total usage cost and adoption rather than claiming measured improvements. Full demonstration includes the ElevenLabs voice agent, publishing, session traces and the phone integration or permitted simulation.</a:t>
+              <a:t>Illustrative planning model, not a product benchmark or market statistic. Baseline normalized total usage cost = 100 units: 70 units fixed voice/transport/other costs plus 30 units for repeated LLM reasoning. Assume supported deterministic operations replace 60% of the LLM spend, leaving 12 units, while incremental execution costs add 3 units. Compiled total = 70+12+3=85, so saving = (100-85)/100 = 15%. These are explicit assumed cost shares, not current provider prices. Savings vary by task mix, call length, token usage, model, deployment and module cost, and could be lower or negative. The four planned capability types are interpretation, calculation, validation and external action. This illustrates a configured agent with broader executable scope, not four times greater intelligence or a claim that competitors lack these tools. Tested deterministic computations can support repeatability, but input interpretation and generation remain probabilistic and tools can fail. Trust and adoption remain hypotheses for user testing. Initial feasibility comes from curated modules and task expressions on a shared runtime.</a:t>
             </a:r>
           </a:p>
         </p:txBody>
@@ -3311,12 +3311,12 @@
   </p:cSld>
   <p:clrMap bg1="lt1" tx1="dk1" bg2="lt2" tx2="dk2" accent1="accent1" accent2="accent2" accent3="accent3" accent4="accent4" accent5="accent5" accent6="accent6" hlink="hlink" folHlink="folHlink"/>
   <p:sldLayoutIdLst>
-    <p:sldLayoutId xmlns:r="http://schemas.openxmlformats.org/officeDocument/2006/relationships" id="2147483649" r:id="R8408421f0fa44d2b"/>
-    <p:sldLayoutId xmlns:r="http://schemas.openxmlformats.org/officeDocument/2006/relationships" id="2147483650" r:id="Rf8006c26314c4568"/>
-    <p:sldLayoutId xmlns:r="http://schemas.openxmlformats.org/officeDocument/2006/relationships" id="2147483651" r:id="R94969bd30613410c"/>
-    <p:sldLayoutId xmlns:r="http://schemas.openxmlformats.org/officeDocument/2006/relationships" id="2147483652" r:id="R149de3a180ee40ab"/>
-    <p:sldLayoutId xmlns:r="http://schemas.openxmlformats.org/officeDocument/2006/relationships" id="2147483653" r:id="Raa238d1d824949e3"/>
-    <p:sldLayoutId xmlns:r="http://schemas.openxmlformats.org/officeDocument/2006/relationships" id="2147483654" r:id="Reedf58ef7a564872"/>
+    <p:sldLayoutId xmlns:r="http://schemas.openxmlformats.org/officeDocument/2006/relationships" id="2147483649" r:id="R459b440391a94e17"/>
+    <p:sldLayoutId xmlns:r="http://schemas.openxmlformats.org/officeDocument/2006/relationships" id="2147483650" r:id="R3bd8ad80cca24167"/>
+    <p:sldLayoutId xmlns:r="http://schemas.openxmlformats.org/officeDocument/2006/relationships" id="2147483651" r:id="R00e79dfa21a34aeb"/>
+    <p:sldLayoutId xmlns:r="http://schemas.openxmlformats.org/officeDocument/2006/relationships" id="2147483652" r:id="R9f8a0f485cb447ec"/>
+    <p:sldLayoutId xmlns:r="http://schemas.openxmlformats.org/officeDocument/2006/relationships" id="2147483653" r:id="Rb03f5a6610084ab4"/>
+    <p:sldLayoutId xmlns:r="http://schemas.openxmlformats.org/officeDocument/2006/relationships" id="2147483654" r:id="R2247f99c84454601"/>
   </p:sldLayoutIdLst>
   <p:txStyles>
     <p:titleStyle>
@@ -3843,6 +3843,169 @@
 </a:theme>
 </file>
 
+<file path=ppt/slides/charts/chart1.xml><?xml version="1.0" encoding="utf-8"?>
+<c:chartSpace xmlns:c="http://schemas.openxmlformats.org/drawingml/2006/chart">
+  <c:lang val="en-US"/>
+  <c:chart>
+    <c:plotArea>
+      <c:barChart>
+        <c:barDir val="bar"/>
+        <c:grouping val="clustered"/>
+        <c:varyColors val="0"/>
+        <c:ser>
+          <c:idx val="0"/>
+          <c:order val="0"/>
+          <c:tx>
+            <c:v>Total cost index</c:v>
+          </c:tx>
+          <c:spPr>
+            <a:solidFill xmlns:a="http://schemas.openxmlformats.org/drawingml/2006/main">
+              <a:srgbClr val="FFFFFF"/>
+            </a:solidFill>
+          </c:spPr>
+          <c:invertIfNegative val="0"/>
+          <c:cat>
+            <c:strLit>
+              <c:ptCount val="2"/>
+              <c:pt idx="0">
+                <c:v>Baseline</c:v>
+              </c:pt>
+              <c:pt idx="1">
+                <c:v>Compiled</c:v>
+              </c:pt>
+            </c:strLit>
+          </c:cat>
+          <c:val>
+            <c:numLit>
+              <c:formatCode>General</c:formatCode>
+              <c:ptCount val="2"/>
+              <c:pt idx="0">
+                <c:v>100</c:v>
+              </c:pt>
+              <c:pt idx="1">
+                <c:v>85</c:v>
+              </c:pt>
+            </c:numLit>
+          </c:val>
+        </c:ser>
+        <c:dLbls>
+          <c:txPr>
+            <a:bodyPr xmlns:a="http://schemas.openxmlformats.org/drawingml/2006/main" anchorCtr="1"/>
+            <a:lstStyle xmlns:a="http://schemas.openxmlformats.org/drawingml/2006/main"/>
+            <a:p xmlns:a="http://schemas.openxmlformats.org/drawingml/2006/main">
+              <a:pPr>
+                <a:defRPr sz="1500" b="1">
+                  <a:solidFill>
+                    <a:srgbClr val="FFFFFF"/>
+                  </a:solidFill>
+                </a:defRPr>
+              </a:pPr>
+            </a:p>
+          </c:txPr>
+          <c:dLblPos val="outEnd"/>
+          <c:showLegendKey val="0"/>
+          <c:showVal val="1"/>
+          <c:showCatName val="0"/>
+          <c:showSerName val="0"/>
+          <c:showPercent val="0"/>
+          <c:showBubbleSize val="0"/>
+          <c:showLeaderLines val="0"/>
+        </c:dLbls>
+        <c:gapWidth val="85"/>
+        <c:axId val="48650112"/>
+        <c:axId val="48672768"/>
+      </c:barChart>
+      <c:catAx>
+        <c:axId val="48650112"/>
+        <c:scaling>
+          <c:orientation val="minMax"/>
+        </c:scaling>
+        <c:delete val="0"/>
+        <c:axPos val="l"/>
+        <c:numFmt formatCode="General"/>
+        <c:majorTickMark val="none"/>
+        <c:minorTickMark val="none"/>
+        <c:spPr>
+          <a:ln xmlns:a="http://schemas.openxmlformats.org/drawingml/2006/main" w="0">
+            <a:noFill/>
+            <a:prstDash val="solid"/>
+          </a:ln>
+        </c:spPr>
+        <c:txPr>
+          <a:bodyPr xmlns:a="http://schemas.openxmlformats.org/drawingml/2006/main" anchorCtr="1"/>
+          <a:lstStyle xmlns:a="http://schemas.openxmlformats.org/drawingml/2006/main"/>
+          <a:p xmlns:a="http://schemas.openxmlformats.org/drawingml/2006/main">
+            <a:pPr>
+              <a:defRPr sz="1500">
+                <a:solidFill>
+                  <a:srgbClr val="FFFFFF"/>
+                </a:solidFill>
+              </a:defRPr>
+            </a:pPr>
+          </a:p>
+        </c:txPr>
+        <c:crossAx val="48672768"/>
+      </c:catAx>
+      <c:valAx>
+        <c:axId val="48672768"/>
+        <c:scaling>
+          <c:orientation val="minMax"/>
+          <c:max val="115"/>
+          <c:min val="0"/>
+        </c:scaling>
+        <c:delete val="1"/>
+        <c:axPos val="b"/>
+        <c:numFmt formatCode="General"/>
+        <c:majorTickMark val="none"/>
+        <c:minorTickMark val="none"/>
+        <c:spPr>
+          <a:ln xmlns:a="http://schemas.openxmlformats.org/drawingml/2006/main" w="9525">
+            <a:solidFill>
+              <a:srgbClr val="D4D4D4"/>
+            </a:solidFill>
+            <a:prstDash val="solid"/>
+          </a:ln>
+        </c:spPr>
+        <c:txPr>
+          <a:bodyPr xmlns:a="http://schemas.openxmlformats.org/drawingml/2006/main" anchorCtr="1"/>
+          <a:lstStyle xmlns:a="http://schemas.openxmlformats.org/drawingml/2006/main"/>
+          <a:p xmlns:a="http://schemas.openxmlformats.org/drawingml/2006/main">
+            <a:pPr>
+              <a:defRPr>
+                <a:solidFill>
+                  <a:srgbClr val="666666"/>
+                </a:solidFill>
+              </a:defRPr>
+            </a:pPr>
+          </a:p>
+        </c:txPr>
+        <c:crossAx val="48650112"/>
+        <c:crossBetween val="between"/>
+      </c:valAx>
+      <c:spPr>
+        <a:solidFill xmlns:a="http://schemas.openxmlformats.org/drawingml/2006/main">
+          <a:srgbClr val="F25037"/>
+        </a:solidFill>
+        <a:ln xmlns:a="http://schemas.openxmlformats.org/drawingml/2006/main" w="0">
+          <a:noFill/>
+          <a:prstDash val="solid"/>
+        </a:ln>
+      </c:spPr>
+    </c:plotArea>
+    <c:plotVisOnly val="1"/>
+  </c:chart>
+  <c:spPr>
+    <a:solidFill xmlns:a="http://schemas.openxmlformats.org/drawingml/2006/main">
+      <a:srgbClr val="F25037"/>
+    </a:solidFill>
+    <a:ln xmlns:a="http://schemas.openxmlformats.org/drawingml/2006/main" w="0">
+      <a:noFill/>
+      <a:prstDash val="solid"/>
+    </a:ln>
+  </c:spPr>
+</c:chartSpace>
+</file>
+
 <file path=ppt/slides/slide1.xml><?xml version="1.0" encoding="utf-8"?>
 <p:sld xmlns:p="http://schemas.openxmlformats.org/presentationml/2006/main">
   <p:cSld>
@@ -4036,7 +4199,7 @@
           <p:nvPr/>
         </p:nvPicPr>
         <p:blipFill>
-          <a:blip xmlns:r="http://schemas.openxmlformats.org/officeDocument/2006/relationships" xmlns:a="http://schemas.openxmlformats.org/drawingml/2006/main" r:embed="R6b16093717be4a2e"/>
+          <a:blip xmlns:r="http://schemas.openxmlformats.org/officeDocument/2006/relationships" xmlns:a="http://schemas.openxmlformats.org/drawingml/2006/main" r:embed="R8fffbc5d884646fb"/>
           <a:stretch xmlns:a="http://schemas.openxmlformats.org/drawingml/2006/main"/>
         </p:blipFill>
         <p:spPr>
@@ -4746,7 +4909,7 @@
           <p:nvPr/>
         </p:nvPicPr>
         <p:blipFill>
-          <a:blip xmlns:r="http://schemas.openxmlformats.org/officeDocument/2006/relationships" xmlns:a="http://schemas.openxmlformats.org/drawingml/2006/main" r:embed="R43565ca63f3242d0"/>
+          <a:blip xmlns:r="http://schemas.openxmlformats.org/officeDocument/2006/relationships" xmlns:a="http://schemas.openxmlformats.org/drawingml/2006/main" r:embed="R1fdc74750ac64d18"/>
           <a:stretch xmlns:a="http://schemas.openxmlformats.org/drawingml/2006/main"/>
         </p:blipFill>
         <p:spPr>
@@ -12762,7 +12925,7 @@
           <p:nvPr/>
         </p:nvPicPr>
         <p:blipFill>
-          <a:blip xmlns:r="http://schemas.openxmlformats.org/officeDocument/2006/relationships" xmlns:a="http://schemas.openxmlformats.org/drawingml/2006/main" r:embed="R1ba9f33aece64704"/>
+          <a:blip xmlns:r="http://schemas.openxmlformats.org/officeDocument/2006/relationships" xmlns:a="http://schemas.openxmlformats.org/drawingml/2006/main" r:embed="R5a0f2e393e814273"/>
           <a:stretch xmlns:a="http://schemas.openxmlformats.org/drawingml/2006/main"/>
         </p:blipFill>
         <p:spPr>
@@ -12949,10 +13112,10 @@
           <p:nvPr/>
         </p:nvPicPr>
         <p:blipFill>
-          <a:blip xmlns:r="http://schemas.openxmlformats.org/officeDocument/2006/relationships" xmlns:a="http://schemas.openxmlformats.org/drawingml/2006/main" r:embed="R9500b479a2a845b9">
+          <a:blip xmlns:r="http://schemas.openxmlformats.org/officeDocument/2006/relationships" xmlns:a="http://schemas.openxmlformats.org/drawingml/2006/main" r:embed="Rc76b97e2b4c24df2">
             <a:extLst>
               <a:ext uri="{96DAC541-7B7A-43D3-8B79-37D633B846F1}">
-                <asvg:svgBlip xmlns:asvg="http://schemas.microsoft.com/office/drawing/2016/SVG/main" r:embed="Rc07d91f3927f4057"/>
+                <asvg:svgBlip xmlns:asvg="http://schemas.microsoft.com/office/drawing/2016/SVG/main" r:embed="R676b5b3a09f44359"/>
               </a:ext>
             </a:extLst>
           </a:blip>
@@ -12983,7 +13146,7 @@
           <p:nvPr/>
         </p:nvPicPr>
         <p:blipFill>
-          <a:blip xmlns:r="http://schemas.openxmlformats.org/officeDocument/2006/relationships" xmlns:a="http://schemas.openxmlformats.org/drawingml/2006/main" r:embed="Rece89d1e187d4e21"/>
+          <a:blip xmlns:r="http://schemas.openxmlformats.org/officeDocument/2006/relationships" xmlns:a="http://schemas.openxmlformats.org/drawingml/2006/main" r:embed="R4f96cb04749d4bc0"/>
           <a:stretch xmlns:a="http://schemas.openxmlformats.org/drawingml/2006/main"/>
         </p:blipFill>
         <p:spPr>
@@ -16331,30 +16494,32 @@
           <p:cNvPr id="2" name="">
             <a:extLst xmlns:a="http://schemas.openxmlformats.org/drawingml/2006/main">
               <a:ext uri="{FF2B5EF4-FFF2-40B4-BE49-F238E27FC236}">
-                <a16:creationId xmlns:a16="http://schemas.microsoft.com/office/drawing/2014/main" id="{C2DB4AEC-F5F4-4299-BF6C-C05D0A87C237}"/>
+                <a16:creationId xmlns:a16="http://schemas.microsoft.com/office/drawing/2014/main" id="{7C574315-6C9C-4274-8410-81E121AB35FB}"/>
               </a:ext>
             </a:extLst>
           </p:cNvPr>
           <p:cNvCxnSpPr>
-            <a:stCxn xmlns:a="http://schemas.openxmlformats.org/drawingml/2006/main" id="11" idx="6"/>
-            <a:endCxn xmlns:a="http://schemas.openxmlformats.org/drawingml/2006/main" id="15" idx="2"/>
+            <a:stCxn xmlns:a="http://schemas.openxmlformats.org/drawingml/2006/main" id="13" idx="3"/>
+            <a:endCxn xmlns:a="http://schemas.openxmlformats.org/drawingml/2006/main" id="19" idx="1"/>
           </p:cNvCxnSpPr>
           <p:nvPr/>
         </p:nvCxnSpPr>
         <p:spPr>
           <a:xfrm xmlns:a="http://schemas.openxmlformats.org/drawingml/2006/main">
-            <a:off x="5181600" y="3286125"/>
-            <a:ext cx="3162300" cy="0"/>
+            <a:off x="8382000" y="4795838"/>
+            <a:ext cx="1143000" cy="795338"/>
           </a:xfrm>
-          <a:prstGeom xmlns:a="http://schemas.openxmlformats.org/drawingml/2006/main" prst="straightConnector1">
-            <a:avLst/>
+          <a:prstGeom xmlns:a="http://schemas.openxmlformats.org/drawingml/2006/main" prst="bentConnector3">
+            <a:avLst>
+              <a:gd name="adj1" fmla="val 50000"/>
+            </a:avLst>
           </a:prstGeom>
-          <a:ln xmlns:a="http://schemas.openxmlformats.org/drawingml/2006/main" w="19050">
+          <a:ln xmlns:a="http://schemas.openxmlformats.org/drawingml/2006/main" w="14288">
             <a:solidFill>
               <a:srgbClr val="FFFFFF"/>
             </a:solidFill>
             <a:prstDash val="solid"/>
-            <a:tailEnd type="arrow" w="med" len="med"/>
+            <a:tailEnd type="arrow" w="sm" len="sm"/>
           </a:ln>
         </p:spPr>
       </p:cxnSp>
@@ -16363,36 +16528,72 @@
           <p:cNvPr id="3" name="">
             <a:extLst xmlns:a="http://schemas.openxmlformats.org/drawingml/2006/main">
               <a:ext uri="{FF2B5EF4-FFF2-40B4-BE49-F238E27FC236}">
-                <a16:creationId xmlns:a16="http://schemas.microsoft.com/office/drawing/2014/main" id="{7A350AC8-1FF9-4B11-AF81-945BEE07ECD0}"/>
+                <a16:creationId xmlns:a16="http://schemas.microsoft.com/office/drawing/2014/main" id="{EA4F93F5-F0AC-495A-B863-B3F043F721A5}"/>
               </a:ext>
             </a:extLst>
           </p:cNvPr>
           <p:cNvCxnSpPr>
-            <a:stCxn xmlns:a="http://schemas.openxmlformats.org/drawingml/2006/main" id="7" idx="6"/>
-            <a:endCxn xmlns:a="http://schemas.openxmlformats.org/drawingml/2006/main" id="11" idx="2"/>
+            <a:stCxn xmlns:a="http://schemas.openxmlformats.org/drawingml/2006/main" id="13" idx="3"/>
+            <a:endCxn xmlns:a="http://schemas.openxmlformats.org/drawingml/2006/main" id="17" idx="1"/>
           </p:cNvCxnSpPr>
           <p:nvPr/>
         </p:nvCxnSpPr>
         <p:spPr>
           <a:xfrm xmlns:a="http://schemas.openxmlformats.org/drawingml/2006/main">
-            <a:off x="1314450" y="3286125"/>
-            <a:ext cx="3162300" cy="0"/>
+            <a:off x="8382000" y="4795838"/>
+            <a:ext cx="1143000" cy="185738"/>
           </a:xfrm>
-          <a:prstGeom xmlns:a="http://schemas.openxmlformats.org/drawingml/2006/main" prst="straightConnector1">
-            <a:avLst/>
+          <a:prstGeom xmlns:a="http://schemas.openxmlformats.org/drawingml/2006/main" prst="bentConnector3">
+            <a:avLst>
+              <a:gd name="adj1" fmla="val 50000"/>
+            </a:avLst>
           </a:prstGeom>
-          <a:ln xmlns:a="http://schemas.openxmlformats.org/drawingml/2006/main" w="19050">
+          <a:ln xmlns:a="http://schemas.openxmlformats.org/drawingml/2006/main" w="14288">
             <a:solidFill>
               <a:srgbClr val="FFFFFF"/>
             </a:solidFill>
             <a:prstDash val="solid"/>
-            <a:tailEnd type="arrow" w="med" len="med"/>
+            <a:tailEnd type="arrow" w="sm" len="sm"/>
+          </a:ln>
+        </p:spPr>
+      </p:cxnSp>
+      <p:cxnSp>
+        <p:nvCxnSpPr>
+          <p:cNvPr id="4" name="">
+            <a:extLst xmlns:a="http://schemas.openxmlformats.org/drawingml/2006/main">
+              <a:ext uri="{FF2B5EF4-FFF2-40B4-BE49-F238E27FC236}">
+                <a16:creationId xmlns:a16="http://schemas.microsoft.com/office/drawing/2014/main" id="{160765C2-3095-4E7A-8C7C-BA7304D151F8}"/>
+              </a:ext>
+            </a:extLst>
+          </p:cNvPr>
+          <p:cNvCxnSpPr>
+            <a:stCxn xmlns:a="http://schemas.openxmlformats.org/drawingml/2006/main" id="13" idx="3"/>
+            <a:endCxn xmlns:a="http://schemas.openxmlformats.org/drawingml/2006/main" id="15" idx="1"/>
+          </p:cNvCxnSpPr>
+          <p:nvPr/>
+        </p:nvCxnSpPr>
+        <p:spPr>
+          <a:xfrm xmlns:a="http://schemas.openxmlformats.org/drawingml/2006/main" flipV="1">
+            <a:off x="8382000" y="4371975"/>
+            <a:ext cx="1143000" cy="423863"/>
+          </a:xfrm>
+          <a:prstGeom xmlns:a="http://schemas.openxmlformats.org/drawingml/2006/main" prst="bentConnector3">
+            <a:avLst>
+              <a:gd name="adj1" fmla="val 50000"/>
+            </a:avLst>
+          </a:prstGeom>
+          <a:ln xmlns:a="http://schemas.openxmlformats.org/drawingml/2006/main" w="14288">
+            <a:solidFill>
+              <a:srgbClr val="FFFFFF"/>
+            </a:solidFill>
+            <a:prstDash val="solid"/>
+            <a:tailEnd type="arrow" w="sm" len="sm"/>
           </a:ln>
         </p:spPr>
       </p:cxnSp>
       <p:sp>
         <p:nvSpPr>
-          <p:cNvPr id="4" name="section">
+          <p:cNvPr id="5" name="section">
             <a:extLst xmlns:a="http://schemas.openxmlformats.org/drawingml/2006/main">
               <a:ext uri="{FF2B5EF4-FFF2-40B4-BE49-F238E27FC236}">
                 <a16:creationId xmlns:a16="http://schemas.microsoft.com/office/drawing/2014/main" id="{27EC04EE-B828-4E42-906C-6E6C811AFCD0}"/>
@@ -16551,7 +16752,7 @@
       </p:sp>
       <p:sp>
         <p:nvSpPr>
-          <p:cNvPr id="5" name="slide-number">
+          <p:cNvPr id="6" name="slide-number">
             <a:extLst xmlns:a="http://schemas.openxmlformats.org/drawingml/2006/main">
               <a:ext uri="{FF2B5EF4-FFF2-40B4-BE49-F238E27FC236}">
                 <a16:creationId xmlns:a16="http://schemas.microsoft.com/office/drawing/2014/main" id="{B64ADBDE-3461-446E-9229-95DEE1D21324}"/>
@@ -16710,10 +16911,10 @@
       </p:sp>
       <p:sp>
         <p:nvSpPr>
-          <p:cNvPr id="6" name="headline">
+          <p:cNvPr id="7" name="headline">
             <a:extLst xmlns:a="http://schemas.openxmlformats.org/drawingml/2006/main">
               <a:ext uri="{FF2B5EF4-FFF2-40B4-BE49-F238E27FC236}">
-                <a16:creationId xmlns:a16="http://schemas.microsoft.com/office/drawing/2014/main" id="{6EBC34E1-1442-45FE-B84C-D1EB949813B3}"/>
+                <a16:creationId xmlns:a16="http://schemas.microsoft.com/office/drawing/2014/main" id="{C44D4A65-C63B-43BA-8F4F-F291895D9B53}"/>
               </a:ext>
             </a:extLst>
           </p:cNvPr>
@@ -16724,8 +16925,8 @@
         </p:nvSpPr>
         <p:spPr>
           <a:xfrm xmlns:a="http://schemas.openxmlformats.org/drawingml/2006/main">
-            <a:off x="609600" y="1057275"/>
-            <a:ext cx="10972800" cy="1476375"/>
+            <a:off x="609600" y="1009650"/>
+            <a:ext cx="10972800" cy="1333500"/>
           </a:xfrm>
           <a:prstGeom xmlns:a="http://schemas.openxmlformats.org/drawingml/2006/main" prst="rect">
             <a:avLst/>
@@ -16740,70 +16941,70 @@
           <a:bodyPr xmlns:a="http://schemas.openxmlformats.org/drawingml/2006/main" lIns="0" tIns="0" rIns="0" bIns="0"/>
           <a:lstStyle xmlns:a="http://schemas.openxmlformats.org/drawingml/2006/main">
             <a:defPPr>
-              <a:defRPr sz="4275" b="1">
+              <a:defRPr sz="4200" b="1">
                 <a:solidFill>
                   <a:srgbClr val="FFFFFF"/>
                 </a:solidFill>
               </a:defRPr>
             </a:defPPr>
             <a:lvl1pPr>
-              <a:defRPr sz="4275" b="1">
+              <a:defRPr sz="4200" b="1">
                 <a:solidFill>
                   <a:srgbClr val="FFFFFF"/>
                 </a:solidFill>
               </a:defRPr>
             </a:lvl1pPr>
             <a:lvl2pPr>
-              <a:defRPr sz="4275" b="1">
+              <a:defRPr sz="4200" b="1">
                 <a:solidFill>
                   <a:srgbClr val="FFFFFF"/>
                 </a:solidFill>
               </a:defRPr>
             </a:lvl2pPr>
             <a:lvl3pPr>
-              <a:defRPr sz="4275" b="1">
+              <a:defRPr sz="4200" b="1">
                 <a:solidFill>
                   <a:srgbClr val="FFFFFF"/>
                 </a:solidFill>
               </a:defRPr>
             </a:lvl3pPr>
             <a:lvl4pPr>
-              <a:defRPr sz="4275" b="1">
+              <a:defRPr sz="4200" b="1">
                 <a:solidFill>
                   <a:srgbClr val="FFFFFF"/>
                 </a:solidFill>
               </a:defRPr>
             </a:lvl4pPr>
             <a:lvl5pPr>
-              <a:defRPr sz="4275" b="1">
+              <a:defRPr sz="4200" b="1">
                 <a:solidFill>
                   <a:srgbClr val="FFFFFF"/>
                 </a:solidFill>
               </a:defRPr>
             </a:lvl5pPr>
             <a:lvl6pPr>
-              <a:defRPr sz="4275" b="1">
+              <a:defRPr sz="4200" b="1">
                 <a:solidFill>
                   <a:srgbClr val="FFFFFF"/>
                 </a:solidFill>
               </a:defRPr>
             </a:lvl6pPr>
             <a:lvl7pPr>
-              <a:defRPr sz="4275" b="1">
+              <a:defRPr sz="4200" b="1">
                 <a:solidFill>
                   <a:srgbClr val="FFFFFF"/>
                 </a:solidFill>
               </a:defRPr>
             </a:lvl7pPr>
             <a:lvl8pPr>
-              <a:defRPr sz="4275" b="1">
+              <a:defRPr sz="4200" b="1">
                 <a:solidFill>
                   <a:srgbClr val="FFFFFF"/>
                 </a:solidFill>
               </a:defRPr>
             </a:lvl8pPr>
             <a:lvl9pPr>
-              <a:defRPr sz="4275" b="1">
+              <a:defRPr sz="4200" b="1">
                 <a:solidFill>
                   <a:srgbClr val="FFFFFF"/>
                 </a:solidFill>
@@ -16812,46 +17013,46 @@
           </a:lstStyle>
           <a:p xmlns:a="http://schemas.openxmlformats.org/drawingml/2006/main">
             <a:pPr>
-              <a:defRPr sz="4275" b="1">
+              <a:defRPr sz="4200" b="1">
                 <a:solidFill>
                   <a:srgbClr val="FFFFFF"/>
                 </a:solidFill>
               </a:defRPr>
             </a:pPr>
             <a:r>
-              <a:rPr sz="4275" b="1">
+              <a:rPr sz="4200" b="1">
                 <a:solidFill>
                   <a:srgbClr val="FFFFFF"/>
                 </a:solidFill>
               </a:rPr>
-              <a:t>Deterministic execution.</a:t>
+              <a:t>Projected efficiency.</a:t>
             </a:r>
           </a:p>
           <a:p xmlns:a="http://schemas.openxmlformats.org/drawingml/2006/main">
             <a:pPr>
-              <a:defRPr sz="4275" b="1">
+              <a:defRPr sz="4200" b="1">
                 <a:solidFill>
                   <a:srgbClr val="FFFFFF"/>
                 </a:solidFill>
               </a:defRPr>
             </a:pPr>
             <a:r>
-              <a:rPr sz="4275" b="1">
+              <a:rPr sz="4200" b="1">
                 <a:solidFill>
                   <a:srgbClr val="FFFFFF"/>
                 </a:solidFill>
               </a:rPr>
-              <a:t>More dependable voice agents</a:t>
+              <a:t>Broader execution capability</a:t>
             </a:r>
           </a:p>
         </p:txBody>
       </p:sp>
       <p:sp>
         <p:nvSpPr>
-          <p:cNvPr id="7" name="milestone-0">
+          <p:cNvPr id="8" name="saving-value">
             <a:extLst xmlns:a="http://schemas.openxmlformats.org/drawingml/2006/main">
               <a:ext uri="{FF2B5EF4-FFF2-40B4-BE49-F238E27FC236}">
-                <a16:creationId xmlns:a16="http://schemas.microsoft.com/office/drawing/2014/main" id="{BB0150DA-2325-46B6-AF60-EE033FBCED0A}"/>
+                <a16:creationId xmlns:a16="http://schemas.microsoft.com/office/drawing/2014/main" id="{2C267552-1361-4C8F-A9EA-D616452DFC6B}"/>
               </a:ext>
             </a:extLst>
           </p:cNvPr>
@@ -16862,41 +17063,8 @@
         </p:nvSpPr>
         <p:spPr>
           <a:xfrm xmlns:a="http://schemas.openxmlformats.org/drawingml/2006/main">
-            <a:off x="609600" y="2933700"/>
-            <a:ext cx="704850" cy="704850"/>
-          </a:xfrm>
-          <a:prstGeom xmlns:a="http://schemas.openxmlformats.org/drawingml/2006/main" prst="ellipse">
-            <a:avLst/>
-          </a:prstGeom>
-          <a:solidFill xmlns:a="http://schemas.openxmlformats.org/drawingml/2006/main">
-            <a:srgbClr val="FFFFFF"/>
-          </a:solidFill>
-          <a:ln xmlns:a="http://schemas.openxmlformats.org/drawingml/2006/main" w="9525">
-            <a:solidFill>
-              <a:srgbClr val="FFFFFF"/>
-            </a:solidFill>
-            <a:prstDash val="solid"/>
-          </a:ln>
-        </p:spPr>
-      </p:sp>
-      <p:sp>
-        <p:nvSpPr>
-          <p:cNvPr id="8" name="milestone-number-0">
-            <a:extLst xmlns:a="http://schemas.openxmlformats.org/drawingml/2006/main">
-              <a:ext uri="{FF2B5EF4-FFF2-40B4-BE49-F238E27FC236}">
-                <a16:creationId xmlns:a16="http://schemas.microsoft.com/office/drawing/2014/main" id="{4A9E2A8B-41F5-4F66-A0B2-803A1EFCCAC5}"/>
-              </a:ext>
-            </a:extLst>
-          </p:cNvPr>
-          <p:cNvSpPr>
-            <a:spLocks xmlns:a="http://schemas.openxmlformats.org/drawingml/2006/main" noGrp="1"/>
-          </p:cNvSpPr>
-          <p:nvPr/>
-        </p:nvSpPr>
-        <p:spPr>
-          <a:xfrm xmlns:a="http://schemas.openxmlformats.org/drawingml/2006/main">
-            <a:off x="752475" y="3095625"/>
-            <a:ext cx="523875" cy="381000"/>
+            <a:off x="609600" y="2495550"/>
+            <a:ext cx="4286250" cy="1066800"/>
           </a:xfrm>
           <a:prstGeom xmlns:a="http://schemas.openxmlformats.org/drawingml/2006/main" prst="rect">
             <a:avLst/>
@@ -16911,101 +17079,101 @@
           <a:bodyPr xmlns:a="http://schemas.openxmlformats.org/drawingml/2006/main" lIns="0" tIns="0" rIns="0" bIns="0"/>
           <a:lstStyle xmlns:a="http://schemas.openxmlformats.org/drawingml/2006/main">
             <a:defPPr>
-              <a:defRPr sz="2175" b="1">
-                <a:solidFill>
-                  <a:srgbClr val="F25037"/>
+              <a:defRPr sz="7950" b="1">
+                <a:solidFill>
+                  <a:srgbClr val="FFFFFF"/>
                 </a:solidFill>
               </a:defRPr>
             </a:defPPr>
             <a:lvl1pPr>
-              <a:defRPr sz="2175" b="1">
-                <a:solidFill>
-                  <a:srgbClr val="F25037"/>
+              <a:defRPr sz="7950" b="1">
+                <a:solidFill>
+                  <a:srgbClr val="FFFFFF"/>
                 </a:solidFill>
               </a:defRPr>
             </a:lvl1pPr>
             <a:lvl2pPr>
-              <a:defRPr sz="2175" b="1">
-                <a:solidFill>
-                  <a:srgbClr val="F25037"/>
+              <a:defRPr sz="7950" b="1">
+                <a:solidFill>
+                  <a:srgbClr val="FFFFFF"/>
                 </a:solidFill>
               </a:defRPr>
             </a:lvl2pPr>
             <a:lvl3pPr>
-              <a:defRPr sz="2175" b="1">
-                <a:solidFill>
-                  <a:srgbClr val="F25037"/>
+              <a:defRPr sz="7950" b="1">
+                <a:solidFill>
+                  <a:srgbClr val="FFFFFF"/>
                 </a:solidFill>
               </a:defRPr>
             </a:lvl3pPr>
             <a:lvl4pPr>
-              <a:defRPr sz="2175" b="1">
-                <a:solidFill>
-                  <a:srgbClr val="F25037"/>
+              <a:defRPr sz="7950" b="1">
+                <a:solidFill>
+                  <a:srgbClr val="FFFFFF"/>
                 </a:solidFill>
               </a:defRPr>
             </a:lvl4pPr>
             <a:lvl5pPr>
-              <a:defRPr sz="2175" b="1">
-                <a:solidFill>
-                  <a:srgbClr val="F25037"/>
+              <a:defRPr sz="7950" b="1">
+                <a:solidFill>
+                  <a:srgbClr val="FFFFFF"/>
                 </a:solidFill>
               </a:defRPr>
             </a:lvl5pPr>
             <a:lvl6pPr>
-              <a:defRPr sz="2175" b="1">
-                <a:solidFill>
-                  <a:srgbClr val="F25037"/>
+              <a:defRPr sz="7950" b="1">
+                <a:solidFill>
+                  <a:srgbClr val="FFFFFF"/>
                 </a:solidFill>
               </a:defRPr>
             </a:lvl6pPr>
             <a:lvl7pPr>
-              <a:defRPr sz="2175" b="1">
-                <a:solidFill>
-                  <a:srgbClr val="F25037"/>
+              <a:defRPr sz="7950" b="1">
+                <a:solidFill>
+                  <a:srgbClr val="FFFFFF"/>
                 </a:solidFill>
               </a:defRPr>
             </a:lvl7pPr>
             <a:lvl8pPr>
-              <a:defRPr sz="2175" b="1">
-                <a:solidFill>
-                  <a:srgbClr val="F25037"/>
+              <a:defRPr sz="7950" b="1">
+                <a:solidFill>
+                  <a:srgbClr val="FFFFFF"/>
                 </a:solidFill>
               </a:defRPr>
             </a:lvl8pPr>
             <a:lvl9pPr>
-              <a:defRPr sz="2175" b="1">
-                <a:solidFill>
-                  <a:srgbClr val="F25037"/>
+              <a:defRPr sz="7950" b="1">
+                <a:solidFill>
+                  <a:srgbClr val="FFFFFF"/>
                 </a:solidFill>
               </a:defRPr>
             </a:lvl9pPr>
           </a:lstStyle>
           <a:p xmlns:a="http://schemas.openxmlformats.org/drawingml/2006/main">
             <a:pPr>
-              <a:defRPr sz="2175" b="1">
-                <a:solidFill>
-                  <a:srgbClr val="F25037"/>
+              <a:defRPr sz="7950" b="1">
+                <a:solidFill>
+                  <a:srgbClr val="FFFFFF"/>
                 </a:solidFill>
               </a:defRPr>
             </a:pPr>
             <a:r>
-              <a:rPr sz="2175" b="1">
-                <a:solidFill>
-                  <a:srgbClr val="F25037"/>
+              <a:rPr sz="7950" b="1">
+                <a:solidFill>
+                  <a:srgbClr val="FFFFFF"/>
                 </a:solidFill>
               </a:rPr>
-              <a:t>01</a:t>
+              <a:t>15%</a:t>
             </a:r>
           </a:p>
         </p:txBody>
       </p:sp>
       <p:sp>
         <p:nvSpPr>
-          <p:cNvPr id="9" name="milestone-title-0">
+          <p:cNvPr id="9" name="saving-label">
             <a:extLst xmlns:a="http://schemas.openxmlformats.org/drawingml/2006/main">
               <a:ext uri="{FF2B5EF4-FFF2-40B4-BE49-F238E27FC236}">
-                <a16:creationId xmlns:a16="http://schemas.microsoft.com/office/drawing/2014/main" id="{3E790E26-8CE4-4C12-866C-F7B262B21017}"/>
+                <a16:creationId xmlns:a16="http://schemas.microsoft.com/office/drawing/2014/main" id="{11151AB9-68F6-40C3-97E8-E98906DB3F1E}"/>
               </a:ext>
             </a:extLst>
           </p:cNvPr>
@@ -17016,1214 +17184,8 @@
         </p:nvSpPr>
         <p:spPr>
           <a:xfrm xmlns:a="http://schemas.openxmlformats.org/drawingml/2006/main">
-            <a:off x="609600" y="3952875"/>
-            <a:ext cx="3143250" cy="428625"/>
-          </a:xfrm>
-          <a:prstGeom xmlns:a="http://schemas.openxmlformats.org/drawingml/2006/main" prst="rect">
-            <a:avLst/>
-          </a:prstGeom>
-          <a:noFill xmlns:a="http://schemas.openxmlformats.org/drawingml/2006/main"/>
-          <a:ln xmlns:a="http://schemas.openxmlformats.org/drawingml/2006/main" w="0">
-            <a:noFill/>
-            <a:prstDash val="solid"/>
-          </a:ln>
-        </p:spPr>
-        <p:txBody>
-          <a:bodyPr xmlns:a="http://schemas.openxmlformats.org/drawingml/2006/main" lIns="0" tIns="0" rIns="0" bIns="0"/>
-          <a:lstStyle xmlns:a="http://schemas.openxmlformats.org/drawingml/2006/main">
-            <a:defPPr>
-              <a:defRPr sz="2550" b="1">
-                <a:solidFill>
-                  <a:srgbClr val="FFFFFF"/>
-                </a:solidFill>
-              </a:defRPr>
-            </a:defPPr>
-            <a:lvl1pPr>
-              <a:defRPr sz="2550" b="1">
-                <a:solidFill>
-                  <a:srgbClr val="FFFFFF"/>
-                </a:solidFill>
-              </a:defRPr>
-            </a:lvl1pPr>
-            <a:lvl2pPr>
-              <a:defRPr sz="2550" b="1">
-                <a:solidFill>
-                  <a:srgbClr val="FFFFFF"/>
-                </a:solidFill>
-              </a:defRPr>
-            </a:lvl2pPr>
-            <a:lvl3pPr>
-              <a:defRPr sz="2550" b="1">
-                <a:solidFill>
-                  <a:srgbClr val="FFFFFF"/>
-                </a:solidFill>
-              </a:defRPr>
-            </a:lvl3pPr>
-            <a:lvl4pPr>
-              <a:defRPr sz="2550" b="1">
-                <a:solidFill>
-                  <a:srgbClr val="FFFFFF"/>
-                </a:solidFill>
-              </a:defRPr>
-            </a:lvl4pPr>
-            <a:lvl5pPr>
-              <a:defRPr sz="2550" b="1">
-                <a:solidFill>
-                  <a:srgbClr val="FFFFFF"/>
-                </a:solidFill>
-              </a:defRPr>
-            </a:lvl5pPr>
-            <a:lvl6pPr>
-              <a:defRPr sz="2550" b="1">
-                <a:solidFill>
-                  <a:srgbClr val="FFFFFF"/>
-                </a:solidFill>
-              </a:defRPr>
-            </a:lvl6pPr>
-            <a:lvl7pPr>
-              <a:defRPr sz="2550" b="1">
-                <a:solidFill>
-                  <a:srgbClr val="FFFFFF"/>
-                </a:solidFill>
-              </a:defRPr>
-            </a:lvl7pPr>
-            <a:lvl8pPr>
-              <a:defRPr sz="2550" b="1">
-                <a:solidFill>
-                  <a:srgbClr val="FFFFFF"/>
-                </a:solidFill>
-              </a:defRPr>
-            </a:lvl8pPr>
-            <a:lvl9pPr>
-              <a:defRPr sz="2550" b="1">
-                <a:solidFill>
-                  <a:srgbClr val="FFFFFF"/>
-                </a:solidFill>
-              </a:defRPr>
-            </a:lvl9pPr>
-          </a:lstStyle>
-          <a:p xmlns:a="http://schemas.openxmlformats.org/drawingml/2006/main">
-            <a:pPr>
-              <a:defRPr sz="2550" b="1">
-                <a:solidFill>
-                  <a:srgbClr val="FFFFFF"/>
-                </a:solidFill>
-              </a:defRPr>
-            </a:pPr>
-            <a:r>
-              <a:rPr sz="2550" b="1">
-                <a:solidFill>
-                  <a:srgbClr val="FFFFFF"/>
-                </a:solidFill>
-              </a:rPr>
-              <a:t>Reliability</a:t>
-            </a:r>
-          </a:p>
-        </p:txBody>
-      </p:sp>
-      <p:sp>
-        <p:nvSpPr>
-          <p:cNvPr id="10" name="milestone-body-0">
-            <a:extLst xmlns:a="http://schemas.openxmlformats.org/drawingml/2006/main">
-              <a:ext uri="{FF2B5EF4-FFF2-40B4-BE49-F238E27FC236}">
-                <a16:creationId xmlns:a16="http://schemas.microsoft.com/office/drawing/2014/main" id="{302E6B5C-7A91-49F2-A94B-B92EA29C69C4}"/>
-              </a:ext>
-            </a:extLst>
-          </p:cNvPr>
-          <p:cNvSpPr>
-            <a:spLocks xmlns:a="http://schemas.openxmlformats.org/drawingml/2006/main" noGrp="1"/>
-          </p:cNvSpPr>
-          <p:nvPr/>
-        </p:nvSpPr>
-        <p:spPr>
-          <a:xfrm xmlns:a="http://schemas.openxmlformats.org/drawingml/2006/main">
-            <a:off x="609600" y="4505325"/>
-            <a:ext cx="3209925" cy="781050"/>
-          </a:xfrm>
-          <a:prstGeom xmlns:a="http://schemas.openxmlformats.org/drawingml/2006/main" prst="rect">
-            <a:avLst/>
-          </a:prstGeom>
-          <a:noFill xmlns:a="http://schemas.openxmlformats.org/drawingml/2006/main"/>
-          <a:ln xmlns:a="http://schemas.openxmlformats.org/drawingml/2006/main" w="0">
-            <a:noFill/>
-            <a:prstDash val="solid"/>
-          </a:ln>
-        </p:spPr>
-        <p:txBody>
-          <a:bodyPr xmlns:a="http://schemas.openxmlformats.org/drawingml/2006/main" lIns="0" tIns="0" rIns="0" bIns="0"/>
-          <a:lstStyle xmlns:a="http://schemas.openxmlformats.org/drawingml/2006/main">
-            <a:defPPr>
-              <a:defRPr sz="1725" b="0">
-                <a:solidFill>
-                  <a:srgbClr val="FFFFFF"/>
-                </a:solidFill>
-              </a:defRPr>
-            </a:defPPr>
-            <a:lvl1pPr>
-              <a:defRPr sz="1725" b="0">
-                <a:solidFill>
-                  <a:srgbClr val="FFFFFF"/>
-                </a:solidFill>
-              </a:defRPr>
-            </a:lvl1pPr>
-            <a:lvl2pPr>
-              <a:defRPr sz="1725" b="0">
-                <a:solidFill>
-                  <a:srgbClr val="FFFFFF"/>
-                </a:solidFill>
-              </a:defRPr>
-            </a:lvl2pPr>
-            <a:lvl3pPr>
-              <a:defRPr sz="1725" b="0">
-                <a:solidFill>
-                  <a:srgbClr val="FFFFFF"/>
-                </a:solidFill>
-              </a:defRPr>
-            </a:lvl3pPr>
-            <a:lvl4pPr>
-              <a:defRPr sz="1725" b="0">
-                <a:solidFill>
-                  <a:srgbClr val="FFFFFF"/>
-                </a:solidFill>
-              </a:defRPr>
-            </a:lvl4pPr>
-            <a:lvl5pPr>
-              <a:defRPr sz="1725" b="0">
-                <a:solidFill>
-                  <a:srgbClr val="FFFFFF"/>
-                </a:solidFill>
-              </a:defRPr>
-            </a:lvl5pPr>
-            <a:lvl6pPr>
-              <a:defRPr sz="1725" b="0">
-                <a:solidFill>
-                  <a:srgbClr val="FFFFFF"/>
-                </a:solidFill>
-              </a:defRPr>
-            </a:lvl6pPr>
-            <a:lvl7pPr>
-              <a:defRPr sz="1725" b="0">
-                <a:solidFill>
-                  <a:srgbClr val="FFFFFF"/>
-                </a:solidFill>
-              </a:defRPr>
-            </a:lvl7pPr>
-            <a:lvl8pPr>
-              <a:defRPr sz="1725" b="0">
-                <a:solidFill>
-                  <a:srgbClr val="FFFFFF"/>
-                </a:solidFill>
-              </a:defRPr>
-            </a:lvl8pPr>
-            <a:lvl9pPr>
-              <a:defRPr sz="1725" b="0">
-                <a:solidFill>
-                  <a:srgbClr val="FFFFFF"/>
-                </a:solidFill>
-              </a:defRPr>
-            </a:lvl9pPr>
-          </a:lstStyle>
-          <a:p xmlns:a="http://schemas.openxmlformats.org/drawingml/2006/main">
-            <a:pPr>
-              <a:defRPr sz="1725" b="0">
-                <a:solidFill>
-                  <a:srgbClr val="FFFFFF"/>
-                </a:solidFill>
-              </a:defRPr>
-            </a:pPr>
-            <a:r>
-              <a:rPr sz="1725" b="0">
-                <a:solidFill>
-                  <a:srgbClr val="FFFFFF"/>
-                </a:solidFill>
-              </a:rPr>
-              <a:t>Tested rules make supported</a:t>
-            </a:r>
-          </a:p>
-          <a:p xmlns:a="http://schemas.openxmlformats.org/drawingml/2006/main">
-            <a:pPr>
-              <a:defRPr sz="1725" b="0">
-                <a:solidFill>
-                  <a:srgbClr val="FFFFFF"/>
-                </a:solidFill>
-              </a:defRPr>
-            </a:pPr>
-            <a:r>
-              <a:rPr sz="1725" b="0">
-                <a:solidFill>
-                  <a:srgbClr val="FFFFFF"/>
-                </a:solidFill>
-              </a:rPr>
-              <a:t>computations repeatable.</a:t>
-            </a:r>
-          </a:p>
-        </p:txBody>
-      </p:sp>
-      <p:sp>
-        <p:nvSpPr>
-          <p:cNvPr id="11" name="milestone-1">
-            <a:extLst xmlns:a="http://schemas.openxmlformats.org/drawingml/2006/main">
-              <a:ext uri="{FF2B5EF4-FFF2-40B4-BE49-F238E27FC236}">
-                <a16:creationId xmlns:a16="http://schemas.microsoft.com/office/drawing/2014/main" id="{30321284-F3F2-4F88-B349-7DB41BD04B22}"/>
-              </a:ext>
-            </a:extLst>
-          </p:cNvPr>
-          <p:cNvSpPr>
-            <a:spLocks xmlns:a="http://schemas.openxmlformats.org/drawingml/2006/main" noGrp="1"/>
-          </p:cNvSpPr>
-          <p:nvPr/>
-        </p:nvSpPr>
-        <p:spPr>
-          <a:xfrm xmlns:a="http://schemas.openxmlformats.org/drawingml/2006/main">
-            <a:off x="4476750" y="2933700"/>
-            <a:ext cx="704850" cy="704850"/>
-          </a:xfrm>
-          <a:prstGeom xmlns:a="http://schemas.openxmlformats.org/drawingml/2006/main" prst="ellipse">
-            <a:avLst/>
-          </a:prstGeom>
-          <a:solidFill xmlns:a="http://schemas.openxmlformats.org/drawingml/2006/main">
-            <a:srgbClr val="FFFFFF"/>
-          </a:solidFill>
-          <a:ln xmlns:a="http://schemas.openxmlformats.org/drawingml/2006/main" w="9525">
-            <a:solidFill>
-              <a:srgbClr val="FFFFFF"/>
-            </a:solidFill>
-            <a:prstDash val="solid"/>
-          </a:ln>
-        </p:spPr>
-      </p:sp>
-      <p:sp>
-        <p:nvSpPr>
-          <p:cNvPr id="12" name="milestone-number-1">
-            <a:extLst xmlns:a="http://schemas.openxmlformats.org/drawingml/2006/main">
-              <a:ext uri="{FF2B5EF4-FFF2-40B4-BE49-F238E27FC236}">
-                <a16:creationId xmlns:a16="http://schemas.microsoft.com/office/drawing/2014/main" id="{05F60329-2057-4BF9-A6C3-2B358B8C85D3}"/>
-              </a:ext>
-            </a:extLst>
-          </p:cNvPr>
-          <p:cNvSpPr>
-            <a:spLocks xmlns:a="http://schemas.openxmlformats.org/drawingml/2006/main" noGrp="1"/>
-          </p:cNvSpPr>
-          <p:nvPr/>
-        </p:nvSpPr>
-        <p:spPr>
-          <a:xfrm xmlns:a="http://schemas.openxmlformats.org/drawingml/2006/main">
-            <a:off x="4619625" y="3095625"/>
-            <a:ext cx="523875" cy="381000"/>
-          </a:xfrm>
-          <a:prstGeom xmlns:a="http://schemas.openxmlformats.org/drawingml/2006/main" prst="rect">
-            <a:avLst/>
-          </a:prstGeom>
-          <a:noFill xmlns:a="http://schemas.openxmlformats.org/drawingml/2006/main"/>
-          <a:ln xmlns:a="http://schemas.openxmlformats.org/drawingml/2006/main" w="0">
-            <a:noFill/>
-            <a:prstDash val="solid"/>
-          </a:ln>
-        </p:spPr>
-        <p:txBody>
-          <a:bodyPr xmlns:a="http://schemas.openxmlformats.org/drawingml/2006/main" lIns="0" tIns="0" rIns="0" bIns="0"/>
-          <a:lstStyle xmlns:a="http://schemas.openxmlformats.org/drawingml/2006/main">
-            <a:defPPr>
-              <a:defRPr sz="2175" b="1">
-                <a:solidFill>
-                  <a:srgbClr val="F25037"/>
-                </a:solidFill>
-              </a:defRPr>
-            </a:defPPr>
-            <a:lvl1pPr>
-              <a:defRPr sz="2175" b="1">
-                <a:solidFill>
-                  <a:srgbClr val="F25037"/>
-                </a:solidFill>
-              </a:defRPr>
-            </a:lvl1pPr>
-            <a:lvl2pPr>
-              <a:defRPr sz="2175" b="1">
-                <a:solidFill>
-                  <a:srgbClr val="F25037"/>
-                </a:solidFill>
-              </a:defRPr>
-            </a:lvl2pPr>
-            <a:lvl3pPr>
-              <a:defRPr sz="2175" b="1">
-                <a:solidFill>
-                  <a:srgbClr val="F25037"/>
-                </a:solidFill>
-              </a:defRPr>
-            </a:lvl3pPr>
-            <a:lvl4pPr>
-              <a:defRPr sz="2175" b="1">
-                <a:solidFill>
-                  <a:srgbClr val="F25037"/>
-                </a:solidFill>
-              </a:defRPr>
-            </a:lvl4pPr>
-            <a:lvl5pPr>
-              <a:defRPr sz="2175" b="1">
-                <a:solidFill>
-                  <a:srgbClr val="F25037"/>
-                </a:solidFill>
-              </a:defRPr>
-            </a:lvl5pPr>
-            <a:lvl6pPr>
-              <a:defRPr sz="2175" b="1">
-                <a:solidFill>
-                  <a:srgbClr val="F25037"/>
-                </a:solidFill>
-              </a:defRPr>
-            </a:lvl6pPr>
-            <a:lvl7pPr>
-              <a:defRPr sz="2175" b="1">
-                <a:solidFill>
-                  <a:srgbClr val="F25037"/>
-                </a:solidFill>
-              </a:defRPr>
-            </a:lvl7pPr>
-            <a:lvl8pPr>
-              <a:defRPr sz="2175" b="1">
-                <a:solidFill>
-                  <a:srgbClr val="F25037"/>
-                </a:solidFill>
-              </a:defRPr>
-            </a:lvl8pPr>
-            <a:lvl9pPr>
-              <a:defRPr sz="2175" b="1">
-                <a:solidFill>
-                  <a:srgbClr val="F25037"/>
-                </a:solidFill>
-              </a:defRPr>
-            </a:lvl9pPr>
-          </a:lstStyle>
-          <a:p xmlns:a="http://schemas.openxmlformats.org/drawingml/2006/main">
-            <a:pPr>
-              <a:defRPr sz="2175" b="1">
-                <a:solidFill>
-                  <a:srgbClr val="F25037"/>
-                </a:solidFill>
-              </a:defRPr>
-            </a:pPr>
-            <a:r>
-              <a:rPr sz="2175" b="1">
-                <a:solidFill>
-                  <a:srgbClr val="F25037"/>
-                </a:solidFill>
-              </a:rPr>
-              <a:t>02</a:t>
-            </a:r>
-          </a:p>
-        </p:txBody>
-      </p:sp>
-      <p:sp>
-        <p:nvSpPr>
-          <p:cNvPr id="13" name="milestone-title-1">
-            <a:extLst xmlns:a="http://schemas.openxmlformats.org/drawingml/2006/main">
-              <a:ext uri="{FF2B5EF4-FFF2-40B4-BE49-F238E27FC236}">
-                <a16:creationId xmlns:a16="http://schemas.microsoft.com/office/drawing/2014/main" id="{DC9B90A2-9828-475B-9656-3AB20E647C74}"/>
-              </a:ext>
-            </a:extLst>
-          </p:cNvPr>
-          <p:cNvSpPr>
-            <a:spLocks xmlns:a="http://schemas.openxmlformats.org/drawingml/2006/main" noGrp="1"/>
-          </p:cNvSpPr>
-          <p:nvPr/>
-        </p:nvSpPr>
-        <p:spPr>
-          <a:xfrm xmlns:a="http://schemas.openxmlformats.org/drawingml/2006/main">
-            <a:off x="4476750" y="3952875"/>
-            <a:ext cx="3143250" cy="428625"/>
-          </a:xfrm>
-          <a:prstGeom xmlns:a="http://schemas.openxmlformats.org/drawingml/2006/main" prst="rect">
-            <a:avLst/>
-          </a:prstGeom>
-          <a:noFill xmlns:a="http://schemas.openxmlformats.org/drawingml/2006/main"/>
-          <a:ln xmlns:a="http://schemas.openxmlformats.org/drawingml/2006/main" w="0">
-            <a:noFill/>
-            <a:prstDash val="solid"/>
-          </a:ln>
-        </p:spPr>
-        <p:txBody>
-          <a:bodyPr xmlns:a="http://schemas.openxmlformats.org/drawingml/2006/main" lIns="0" tIns="0" rIns="0" bIns="0"/>
-          <a:lstStyle xmlns:a="http://schemas.openxmlformats.org/drawingml/2006/main">
-            <a:defPPr>
-              <a:defRPr sz="2550" b="1">
-                <a:solidFill>
-                  <a:srgbClr val="FFFFFF"/>
-                </a:solidFill>
-              </a:defRPr>
-            </a:defPPr>
-            <a:lvl1pPr>
-              <a:defRPr sz="2550" b="1">
-                <a:solidFill>
-                  <a:srgbClr val="FFFFFF"/>
-                </a:solidFill>
-              </a:defRPr>
-            </a:lvl1pPr>
-            <a:lvl2pPr>
-              <a:defRPr sz="2550" b="1">
-                <a:solidFill>
-                  <a:srgbClr val="FFFFFF"/>
-                </a:solidFill>
-              </a:defRPr>
-            </a:lvl2pPr>
-            <a:lvl3pPr>
-              <a:defRPr sz="2550" b="1">
-                <a:solidFill>
-                  <a:srgbClr val="FFFFFF"/>
-                </a:solidFill>
-              </a:defRPr>
-            </a:lvl3pPr>
-            <a:lvl4pPr>
-              <a:defRPr sz="2550" b="1">
-                <a:solidFill>
-                  <a:srgbClr val="FFFFFF"/>
-                </a:solidFill>
-              </a:defRPr>
-            </a:lvl4pPr>
-            <a:lvl5pPr>
-              <a:defRPr sz="2550" b="1">
-                <a:solidFill>
-                  <a:srgbClr val="FFFFFF"/>
-                </a:solidFill>
-              </a:defRPr>
-            </a:lvl5pPr>
-            <a:lvl6pPr>
-              <a:defRPr sz="2550" b="1">
-                <a:solidFill>
-                  <a:srgbClr val="FFFFFF"/>
-                </a:solidFill>
-              </a:defRPr>
-            </a:lvl6pPr>
-            <a:lvl7pPr>
-              <a:defRPr sz="2550" b="1">
-                <a:solidFill>
-                  <a:srgbClr val="FFFFFF"/>
-                </a:solidFill>
-              </a:defRPr>
-            </a:lvl7pPr>
-            <a:lvl8pPr>
-              <a:defRPr sz="2550" b="1">
-                <a:solidFill>
-                  <a:srgbClr val="FFFFFF"/>
-                </a:solidFill>
-              </a:defRPr>
-            </a:lvl8pPr>
-            <a:lvl9pPr>
-              <a:defRPr sz="2550" b="1">
-                <a:solidFill>
-                  <a:srgbClr val="FFFFFF"/>
-                </a:solidFill>
-              </a:defRPr>
-            </a:lvl9pPr>
-          </a:lstStyle>
-          <a:p xmlns:a="http://schemas.openxmlformats.org/drawingml/2006/main">
-            <a:pPr>
-              <a:defRPr sz="2550" b="1">
-                <a:solidFill>
-                  <a:srgbClr val="FFFFFF"/>
-                </a:solidFill>
-              </a:defRPr>
-            </a:pPr>
-            <a:r>
-              <a:rPr sz="2550" b="1">
-                <a:solidFill>
-                  <a:srgbClr val="FFFFFF"/>
-                </a:solidFill>
-              </a:rPr>
-              <a:t>Cost efficiency</a:t>
-            </a:r>
-          </a:p>
-        </p:txBody>
-      </p:sp>
-      <p:sp>
-        <p:nvSpPr>
-          <p:cNvPr id="14" name="milestone-body-1">
-            <a:extLst xmlns:a="http://schemas.openxmlformats.org/drawingml/2006/main">
-              <a:ext uri="{FF2B5EF4-FFF2-40B4-BE49-F238E27FC236}">
-                <a16:creationId xmlns:a16="http://schemas.microsoft.com/office/drawing/2014/main" id="{B345BF79-47D5-4D04-A137-699C873202D1}"/>
-              </a:ext>
-            </a:extLst>
-          </p:cNvPr>
-          <p:cNvSpPr>
-            <a:spLocks xmlns:a="http://schemas.openxmlformats.org/drawingml/2006/main" noGrp="1"/>
-          </p:cNvSpPr>
-          <p:nvPr/>
-        </p:nvSpPr>
-        <p:spPr>
-          <a:xfrm xmlns:a="http://schemas.openxmlformats.org/drawingml/2006/main">
-            <a:off x="4476750" y="4505325"/>
-            <a:ext cx="3209925" cy="781050"/>
-          </a:xfrm>
-          <a:prstGeom xmlns:a="http://schemas.openxmlformats.org/drawingml/2006/main" prst="rect">
-            <a:avLst/>
-          </a:prstGeom>
-          <a:noFill xmlns:a="http://schemas.openxmlformats.org/drawingml/2006/main"/>
-          <a:ln xmlns:a="http://schemas.openxmlformats.org/drawingml/2006/main" w="0">
-            <a:noFill/>
-            <a:prstDash val="solid"/>
-          </a:ln>
-        </p:spPr>
-        <p:txBody>
-          <a:bodyPr xmlns:a="http://schemas.openxmlformats.org/drawingml/2006/main" lIns="0" tIns="0" rIns="0" bIns="0"/>
-          <a:lstStyle xmlns:a="http://schemas.openxmlformats.org/drawingml/2006/main">
-            <a:defPPr>
-              <a:defRPr sz="1725" b="0">
-                <a:solidFill>
-                  <a:srgbClr val="FFFFFF"/>
-                </a:solidFill>
-              </a:defRPr>
-            </a:defPPr>
-            <a:lvl1pPr>
-              <a:defRPr sz="1725" b="0">
-                <a:solidFill>
-                  <a:srgbClr val="FFFFFF"/>
-                </a:solidFill>
-              </a:defRPr>
-            </a:lvl1pPr>
-            <a:lvl2pPr>
-              <a:defRPr sz="1725" b="0">
-                <a:solidFill>
-                  <a:srgbClr val="FFFFFF"/>
-                </a:solidFill>
-              </a:defRPr>
-            </a:lvl2pPr>
-            <a:lvl3pPr>
-              <a:defRPr sz="1725" b="0">
-                <a:solidFill>
-                  <a:srgbClr val="FFFFFF"/>
-                </a:solidFill>
-              </a:defRPr>
-            </a:lvl3pPr>
-            <a:lvl4pPr>
-              <a:defRPr sz="1725" b="0">
-                <a:solidFill>
-                  <a:srgbClr val="FFFFFF"/>
-                </a:solidFill>
-              </a:defRPr>
-            </a:lvl4pPr>
-            <a:lvl5pPr>
-              <a:defRPr sz="1725" b="0">
-                <a:solidFill>
-                  <a:srgbClr val="FFFFFF"/>
-                </a:solidFill>
-              </a:defRPr>
-            </a:lvl5pPr>
-            <a:lvl6pPr>
-              <a:defRPr sz="1725" b="0">
-                <a:solidFill>
-                  <a:srgbClr val="FFFFFF"/>
-                </a:solidFill>
-              </a:defRPr>
-            </a:lvl6pPr>
-            <a:lvl7pPr>
-              <a:defRPr sz="1725" b="0">
-                <a:solidFill>
-                  <a:srgbClr val="FFFFFF"/>
-                </a:solidFill>
-              </a:defRPr>
-            </a:lvl7pPr>
-            <a:lvl8pPr>
-              <a:defRPr sz="1725" b="0">
-                <a:solidFill>
-                  <a:srgbClr val="FFFFFF"/>
-                </a:solidFill>
-              </a:defRPr>
-            </a:lvl8pPr>
-            <a:lvl9pPr>
-              <a:defRPr sz="1725" b="0">
-                <a:solidFill>
-                  <a:srgbClr val="FFFFFF"/>
-                </a:solidFill>
-              </a:defRPr>
-            </a:lvl9pPr>
-          </a:lstStyle>
-          <a:p xmlns:a="http://schemas.openxmlformats.org/drawingml/2006/main">
-            <a:pPr>
-              <a:defRPr sz="1725" b="0">
-                <a:solidFill>
-                  <a:srgbClr val="FFFFFF"/>
-                </a:solidFill>
-              </a:defRPr>
-            </a:pPr>
-            <a:r>
-              <a:rPr sz="1725" b="0">
-                <a:solidFill>
-                  <a:srgbClr val="FFFFFF"/>
-                </a:solidFill>
-              </a:rPr>
-              <a:t>Reusable workflows reduce</a:t>
-            </a:r>
-          </a:p>
-          <a:p xmlns:a="http://schemas.openxmlformats.org/drawingml/2006/main">
-            <a:pPr>
-              <a:defRPr sz="1725" b="0">
-                <a:solidFill>
-                  <a:srgbClr val="FFFFFF"/>
-                </a:solidFill>
-              </a:defRPr>
-            </a:pPr>
-            <a:r>
-              <a:rPr sz="1725" b="0">
-                <a:solidFill>
-                  <a:srgbClr val="FFFFFF"/>
-                </a:solidFill>
-              </a:rPr>
-              <a:t>repeated LLM reasoning calls.</a:t>
-            </a:r>
-          </a:p>
-        </p:txBody>
-      </p:sp>
-      <p:sp>
-        <p:nvSpPr>
-          <p:cNvPr id="15" name="milestone-2">
-            <a:extLst xmlns:a="http://schemas.openxmlformats.org/drawingml/2006/main">
-              <a:ext uri="{FF2B5EF4-FFF2-40B4-BE49-F238E27FC236}">
-                <a16:creationId xmlns:a16="http://schemas.microsoft.com/office/drawing/2014/main" id="{169AB614-F670-4BF9-8646-9BF9722F3D29}"/>
-              </a:ext>
-            </a:extLst>
-          </p:cNvPr>
-          <p:cNvSpPr>
-            <a:spLocks xmlns:a="http://schemas.openxmlformats.org/drawingml/2006/main" noGrp="1"/>
-          </p:cNvSpPr>
-          <p:nvPr/>
-        </p:nvSpPr>
-        <p:spPr>
-          <a:xfrm xmlns:a="http://schemas.openxmlformats.org/drawingml/2006/main">
-            <a:off x="8343900" y="2933700"/>
-            <a:ext cx="704850" cy="704850"/>
-          </a:xfrm>
-          <a:prstGeom xmlns:a="http://schemas.openxmlformats.org/drawingml/2006/main" prst="ellipse">
-            <a:avLst/>
-          </a:prstGeom>
-          <a:solidFill xmlns:a="http://schemas.openxmlformats.org/drawingml/2006/main">
-            <a:srgbClr val="FFFFFF"/>
-          </a:solidFill>
-          <a:ln xmlns:a="http://schemas.openxmlformats.org/drawingml/2006/main" w="9525">
-            <a:solidFill>
-              <a:srgbClr val="FFFFFF"/>
-            </a:solidFill>
-            <a:prstDash val="solid"/>
-          </a:ln>
-        </p:spPr>
-      </p:sp>
-      <p:sp>
-        <p:nvSpPr>
-          <p:cNvPr id="16" name="milestone-number-2">
-            <a:extLst xmlns:a="http://schemas.openxmlformats.org/drawingml/2006/main">
-              <a:ext uri="{FF2B5EF4-FFF2-40B4-BE49-F238E27FC236}">
-                <a16:creationId xmlns:a16="http://schemas.microsoft.com/office/drawing/2014/main" id="{5217F89F-8D4E-448F-A444-DF82DC5B21A9}"/>
-              </a:ext>
-            </a:extLst>
-          </p:cNvPr>
-          <p:cNvSpPr>
-            <a:spLocks xmlns:a="http://schemas.openxmlformats.org/drawingml/2006/main" noGrp="1"/>
-          </p:cNvSpPr>
-          <p:nvPr/>
-        </p:nvSpPr>
-        <p:spPr>
-          <a:xfrm xmlns:a="http://schemas.openxmlformats.org/drawingml/2006/main">
-            <a:off x="8486775" y="3095625"/>
-            <a:ext cx="523875" cy="381000"/>
-          </a:xfrm>
-          <a:prstGeom xmlns:a="http://schemas.openxmlformats.org/drawingml/2006/main" prst="rect">
-            <a:avLst/>
-          </a:prstGeom>
-          <a:noFill xmlns:a="http://schemas.openxmlformats.org/drawingml/2006/main"/>
-          <a:ln xmlns:a="http://schemas.openxmlformats.org/drawingml/2006/main" w="0">
-            <a:noFill/>
-            <a:prstDash val="solid"/>
-          </a:ln>
-        </p:spPr>
-        <p:txBody>
-          <a:bodyPr xmlns:a="http://schemas.openxmlformats.org/drawingml/2006/main" lIns="0" tIns="0" rIns="0" bIns="0"/>
-          <a:lstStyle xmlns:a="http://schemas.openxmlformats.org/drawingml/2006/main">
-            <a:defPPr>
-              <a:defRPr sz="2175" b="1">
-                <a:solidFill>
-                  <a:srgbClr val="F25037"/>
-                </a:solidFill>
-              </a:defRPr>
-            </a:defPPr>
-            <a:lvl1pPr>
-              <a:defRPr sz="2175" b="1">
-                <a:solidFill>
-                  <a:srgbClr val="F25037"/>
-                </a:solidFill>
-              </a:defRPr>
-            </a:lvl1pPr>
-            <a:lvl2pPr>
-              <a:defRPr sz="2175" b="1">
-                <a:solidFill>
-                  <a:srgbClr val="F25037"/>
-                </a:solidFill>
-              </a:defRPr>
-            </a:lvl2pPr>
-            <a:lvl3pPr>
-              <a:defRPr sz="2175" b="1">
-                <a:solidFill>
-                  <a:srgbClr val="F25037"/>
-                </a:solidFill>
-              </a:defRPr>
-            </a:lvl3pPr>
-            <a:lvl4pPr>
-              <a:defRPr sz="2175" b="1">
-                <a:solidFill>
-                  <a:srgbClr val="F25037"/>
-                </a:solidFill>
-              </a:defRPr>
-            </a:lvl4pPr>
-            <a:lvl5pPr>
-              <a:defRPr sz="2175" b="1">
-                <a:solidFill>
-                  <a:srgbClr val="F25037"/>
-                </a:solidFill>
-              </a:defRPr>
-            </a:lvl5pPr>
-            <a:lvl6pPr>
-              <a:defRPr sz="2175" b="1">
-                <a:solidFill>
-                  <a:srgbClr val="F25037"/>
-                </a:solidFill>
-              </a:defRPr>
-            </a:lvl6pPr>
-            <a:lvl7pPr>
-              <a:defRPr sz="2175" b="1">
-                <a:solidFill>
-                  <a:srgbClr val="F25037"/>
-                </a:solidFill>
-              </a:defRPr>
-            </a:lvl7pPr>
-            <a:lvl8pPr>
-              <a:defRPr sz="2175" b="1">
-                <a:solidFill>
-                  <a:srgbClr val="F25037"/>
-                </a:solidFill>
-              </a:defRPr>
-            </a:lvl8pPr>
-            <a:lvl9pPr>
-              <a:defRPr sz="2175" b="1">
-                <a:solidFill>
-                  <a:srgbClr val="F25037"/>
-                </a:solidFill>
-              </a:defRPr>
-            </a:lvl9pPr>
-          </a:lstStyle>
-          <a:p xmlns:a="http://schemas.openxmlformats.org/drawingml/2006/main">
-            <a:pPr>
-              <a:defRPr sz="2175" b="1">
-                <a:solidFill>
-                  <a:srgbClr val="F25037"/>
-                </a:solidFill>
-              </a:defRPr>
-            </a:pPr>
-            <a:r>
-              <a:rPr sz="2175" b="1">
-                <a:solidFill>
-                  <a:srgbClr val="F25037"/>
-                </a:solidFill>
-              </a:rPr>
-              <a:t>03</a:t>
-            </a:r>
-          </a:p>
-        </p:txBody>
-      </p:sp>
-      <p:sp>
-        <p:nvSpPr>
-          <p:cNvPr id="17" name="milestone-title-2">
-            <a:extLst xmlns:a="http://schemas.openxmlformats.org/drawingml/2006/main">
-              <a:ext uri="{FF2B5EF4-FFF2-40B4-BE49-F238E27FC236}">
-                <a16:creationId xmlns:a16="http://schemas.microsoft.com/office/drawing/2014/main" id="{86DA58CE-DE4C-4134-B794-4C90B0F1C023}"/>
-              </a:ext>
-            </a:extLst>
-          </p:cNvPr>
-          <p:cNvSpPr>
-            <a:spLocks xmlns:a="http://schemas.openxmlformats.org/drawingml/2006/main" noGrp="1"/>
-          </p:cNvSpPr>
-          <p:nvPr/>
-        </p:nvSpPr>
-        <p:spPr>
-          <a:xfrm xmlns:a="http://schemas.openxmlformats.org/drawingml/2006/main">
-            <a:off x="8343900" y="3952875"/>
-            <a:ext cx="3143250" cy="428625"/>
-          </a:xfrm>
-          <a:prstGeom xmlns:a="http://schemas.openxmlformats.org/drawingml/2006/main" prst="rect">
-            <a:avLst/>
-          </a:prstGeom>
-          <a:noFill xmlns:a="http://schemas.openxmlformats.org/drawingml/2006/main"/>
-          <a:ln xmlns:a="http://schemas.openxmlformats.org/drawingml/2006/main" w="0">
-            <a:noFill/>
-            <a:prstDash val="solid"/>
-          </a:ln>
-        </p:spPr>
-        <p:txBody>
-          <a:bodyPr xmlns:a="http://schemas.openxmlformats.org/drawingml/2006/main" lIns="0" tIns="0" rIns="0" bIns="0"/>
-          <a:lstStyle xmlns:a="http://schemas.openxmlformats.org/drawingml/2006/main">
-            <a:defPPr>
-              <a:defRPr sz="2550" b="1">
-                <a:solidFill>
-                  <a:srgbClr val="FFFFFF"/>
-                </a:solidFill>
-              </a:defRPr>
-            </a:defPPr>
-            <a:lvl1pPr>
-              <a:defRPr sz="2550" b="1">
-                <a:solidFill>
-                  <a:srgbClr val="FFFFFF"/>
-                </a:solidFill>
-              </a:defRPr>
-            </a:lvl1pPr>
-            <a:lvl2pPr>
-              <a:defRPr sz="2550" b="1">
-                <a:solidFill>
-                  <a:srgbClr val="FFFFFF"/>
-                </a:solidFill>
-              </a:defRPr>
-            </a:lvl2pPr>
-            <a:lvl3pPr>
-              <a:defRPr sz="2550" b="1">
-                <a:solidFill>
-                  <a:srgbClr val="FFFFFF"/>
-                </a:solidFill>
-              </a:defRPr>
-            </a:lvl3pPr>
-            <a:lvl4pPr>
-              <a:defRPr sz="2550" b="1">
-                <a:solidFill>
-                  <a:srgbClr val="FFFFFF"/>
-                </a:solidFill>
-              </a:defRPr>
-            </a:lvl4pPr>
-            <a:lvl5pPr>
-              <a:defRPr sz="2550" b="1">
-                <a:solidFill>
-                  <a:srgbClr val="FFFFFF"/>
-                </a:solidFill>
-              </a:defRPr>
-            </a:lvl5pPr>
-            <a:lvl6pPr>
-              <a:defRPr sz="2550" b="1">
-                <a:solidFill>
-                  <a:srgbClr val="FFFFFF"/>
-                </a:solidFill>
-              </a:defRPr>
-            </a:lvl6pPr>
-            <a:lvl7pPr>
-              <a:defRPr sz="2550" b="1">
-                <a:solidFill>
-                  <a:srgbClr val="FFFFFF"/>
-                </a:solidFill>
-              </a:defRPr>
-            </a:lvl7pPr>
-            <a:lvl8pPr>
-              <a:defRPr sz="2550" b="1">
-                <a:solidFill>
-                  <a:srgbClr val="FFFFFF"/>
-                </a:solidFill>
-              </a:defRPr>
-            </a:lvl8pPr>
-            <a:lvl9pPr>
-              <a:defRPr sz="2550" b="1">
-                <a:solidFill>
-                  <a:srgbClr val="FFFFFF"/>
-                </a:solidFill>
-              </a:defRPr>
-            </a:lvl9pPr>
-          </a:lstStyle>
-          <a:p xmlns:a="http://schemas.openxmlformats.org/drawingml/2006/main">
-            <a:pPr>
-              <a:defRPr sz="2550" b="1">
-                <a:solidFill>
-                  <a:srgbClr val="FFFFFF"/>
-                </a:solidFill>
-              </a:defRPr>
-            </a:pPr>
-            <a:r>
-              <a:rPr sz="2550" b="1">
-                <a:solidFill>
-                  <a:srgbClr val="FFFFFF"/>
-                </a:solidFill>
-              </a:rPr>
-              <a:t>Easier adoption</a:t>
-            </a:r>
-          </a:p>
-        </p:txBody>
-      </p:sp>
-      <p:sp>
-        <p:nvSpPr>
-          <p:cNvPr id="18" name="milestone-body-2">
-            <a:extLst xmlns:a="http://schemas.openxmlformats.org/drawingml/2006/main">
-              <a:ext uri="{FF2B5EF4-FFF2-40B4-BE49-F238E27FC236}">
-                <a16:creationId xmlns:a16="http://schemas.microsoft.com/office/drawing/2014/main" id="{C66E0FE9-C578-4A46-9B6A-C619784FAED5}"/>
-              </a:ext>
-            </a:extLst>
-          </p:cNvPr>
-          <p:cNvSpPr>
-            <a:spLocks xmlns:a="http://schemas.openxmlformats.org/drawingml/2006/main" noGrp="1"/>
-          </p:cNvSpPr>
-          <p:nvPr/>
-        </p:nvSpPr>
-        <p:spPr>
-          <a:xfrm xmlns:a="http://schemas.openxmlformats.org/drawingml/2006/main">
-            <a:off x="8343900" y="4505325"/>
-            <a:ext cx="3209925" cy="781050"/>
-          </a:xfrm>
-          <a:prstGeom xmlns:a="http://schemas.openxmlformats.org/drawingml/2006/main" prst="rect">
-            <a:avLst/>
-          </a:prstGeom>
-          <a:noFill xmlns:a="http://schemas.openxmlformats.org/drawingml/2006/main"/>
-          <a:ln xmlns:a="http://schemas.openxmlformats.org/drawingml/2006/main" w="0">
-            <a:noFill/>
-            <a:prstDash val="solid"/>
-          </a:ln>
-        </p:spPr>
-        <p:txBody>
-          <a:bodyPr xmlns:a="http://schemas.openxmlformats.org/drawingml/2006/main" lIns="0" tIns="0" rIns="0" bIns="0"/>
-          <a:lstStyle xmlns:a="http://schemas.openxmlformats.org/drawingml/2006/main">
-            <a:defPPr>
-              <a:defRPr sz="1725" b="0">
-                <a:solidFill>
-                  <a:srgbClr val="FFFFFF"/>
-                </a:solidFill>
-              </a:defRPr>
-            </a:defPPr>
-            <a:lvl1pPr>
-              <a:defRPr sz="1725" b="0">
-                <a:solidFill>
-                  <a:srgbClr val="FFFFFF"/>
-                </a:solidFill>
-              </a:defRPr>
-            </a:lvl1pPr>
-            <a:lvl2pPr>
-              <a:defRPr sz="1725" b="0">
-                <a:solidFill>
-                  <a:srgbClr val="FFFFFF"/>
-                </a:solidFill>
-              </a:defRPr>
-            </a:lvl2pPr>
-            <a:lvl3pPr>
-              <a:defRPr sz="1725" b="0">
-                <a:solidFill>
-                  <a:srgbClr val="FFFFFF"/>
-                </a:solidFill>
-              </a:defRPr>
-            </a:lvl3pPr>
-            <a:lvl4pPr>
-              <a:defRPr sz="1725" b="0">
-                <a:solidFill>
-                  <a:srgbClr val="FFFFFF"/>
-                </a:solidFill>
-              </a:defRPr>
-            </a:lvl4pPr>
-            <a:lvl5pPr>
-              <a:defRPr sz="1725" b="0">
-                <a:solidFill>
-                  <a:srgbClr val="FFFFFF"/>
-                </a:solidFill>
-              </a:defRPr>
-            </a:lvl5pPr>
-            <a:lvl6pPr>
-              <a:defRPr sz="1725" b="0">
-                <a:solidFill>
-                  <a:srgbClr val="FFFFFF"/>
-                </a:solidFill>
-              </a:defRPr>
-            </a:lvl6pPr>
-            <a:lvl7pPr>
-              <a:defRPr sz="1725" b="0">
-                <a:solidFill>
-                  <a:srgbClr val="FFFFFF"/>
-                </a:solidFill>
-              </a:defRPr>
-            </a:lvl7pPr>
-            <a:lvl8pPr>
-              <a:defRPr sz="1725" b="0">
-                <a:solidFill>
-                  <a:srgbClr val="FFFFFF"/>
-                </a:solidFill>
-              </a:defRPr>
-            </a:lvl8pPr>
-            <a:lvl9pPr>
-              <a:defRPr sz="1725" b="0">
-                <a:solidFill>
-                  <a:srgbClr val="FFFFFF"/>
-                </a:solidFill>
-              </a:defRPr>
-            </a:lvl9pPr>
-          </a:lstStyle>
-          <a:p xmlns:a="http://schemas.openxmlformats.org/drawingml/2006/main">
-            <a:pPr>
-              <a:defRPr sz="1725" b="0">
-                <a:solidFill>
-                  <a:srgbClr val="FFFFFF"/>
-                </a:solidFill>
-              </a:defRPr>
-            </a:pPr>
-            <a:r>
-              <a:rPr sz="1725" b="0">
-                <a:solidFill>
-                  <a:srgbClr val="FFFFFF"/>
-                </a:solidFill>
-              </a:rPr>
-              <a:t>Predictable outcomes and</a:t>
-            </a:r>
-          </a:p>
-          <a:p xmlns:a="http://schemas.openxmlformats.org/drawingml/2006/main">
-            <a:pPr>
-              <a:defRPr sz="1725" b="0">
-                <a:solidFill>
-                  <a:srgbClr val="FFFFFF"/>
-                </a:solidFill>
-              </a:defRPr>
-            </a:pPr>
-            <a:r>
-              <a:rPr sz="1725" b="0">
-                <a:solidFill>
-                  <a:srgbClr val="FFFFFF"/>
-                </a:solidFill>
-              </a:rPr>
-              <a:t>clearer costs can build trust.</a:t>
-            </a:r>
-          </a:p>
-        </p:txBody>
-      </p:sp>
-      <p:sp>
-        <p:nvSpPr>
-          <p:cNvPr id="19" name="scope-label">
-            <a:extLst xmlns:a="http://schemas.openxmlformats.org/drawingml/2006/main">
-              <a:ext uri="{FF2B5EF4-FFF2-40B4-BE49-F238E27FC236}">
-                <a16:creationId xmlns:a16="http://schemas.microsoft.com/office/drawing/2014/main" id="{12DACCC3-15AA-4BAF-B81F-B170D46918E9}"/>
-              </a:ext>
-            </a:extLst>
-          </p:cNvPr>
-          <p:cNvSpPr>
-            <a:spLocks xmlns:a="http://schemas.openxmlformats.org/drawingml/2006/main" noGrp="1"/>
-          </p:cNvSpPr>
-          <p:nvPr/>
-        </p:nvSpPr>
-        <p:spPr>
-          <a:xfrm xmlns:a="http://schemas.openxmlformats.org/drawingml/2006/main">
-            <a:off x="609600" y="5600700"/>
-            <a:ext cx="2524125" cy="285750"/>
-          </a:xfrm>
-          <a:prstGeom xmlns:a="http://schemas.openxmlformats.org/drawingml/2006/main" prst="rect">
-            <a:avLst/>
-          </a:prstGeom>
-          <a:noFill xmlns:a="http://schemas.openxmlformats.org/drawingml/2006/main"/>
-          <a:ln xmlns:a="http://schemas.openxmlformats.org/drawingml/2006/main" w="0">
-            <a:noFill/>
-            <a:prstDash val="solid"/>
-          </a:ln>
-        </p:spPr>
-        <p:txBody>
-          <a:bodyPr xmlns:a="http://schemas.openxmlformats.org/drawingml/2006/main" lIns="0" tIns="0" rIns="0" bIns="0"/>
-          <a:lstStyle xmlns:a="http://schemas.openxmlformats.org/drawingml/2006/main">
-            <a:defPPr>
-              <a:defRPr sz="1275" b="1">
-                <a:solidFill>
-                  <a:srgbClr val="FFFFFF"/>
-                </a:solidFill>
-              </a:defRPr>
-            </a:defPPr>
-            <a:lvl1pPr>
-              <a:defRPr sz="1275" b="1">
-                <a:solidFill>
-                  <a:srgbClr val="FFFFFF"/>
-                </a:solidFill>
-              </a:defRPr>
-            </a:lvl1pPr>
-            <a:lvl2pPr>
-              <a:defRPr sz="1275" b="1">
-                <a:solidFill>
-                  <a:srgbClr val="FFFFFF"/>
-                </a:solidFill>
-              </a:defRPr>
-            </a:lvl2pPr>
-            <a:lvl3pPr>
-              <a:defRPr sz="1275" b="1">
-                <a:solidFill>
-                  <a:srgbClr val="FFFFFF"/>
-                </a:solidFill>
-              </a:defRPr>
-            </a:lvl3pPr>
-            <a:lvl4pPr>
-              <a:defRPr sz="1275" b="1">
-                <a:solidFill>
-                  <a:srgbClr val="FFFFFF"/>
-                </a:solidFill>
-              </a:defRPr>
-            </a:lvl4pPr>
-            <a:lvl5pPr>
-              <a:defRPr sz="1275" b="1">
-                <a:solidFill>
-                  <a:srgbClr val="FFFFFF"/>
-                </a:solidFill>
-              </a:defRPr>
-            </a:lvl5pPr>
-            <a:lvl6pPr>
-              <a:defRPr sz="1275" b="1">
-                <a:solidFill>
-                  <a:srgbClr val="FFFFFF"/>
-                </a:solidFill>
-              </a:defRPr>
-            </a:lvl6pPr>
-            <a:lvl7pPr>
-              <a:defRPr sz="1275" b="1">
-                <a:solidFill>
-                  <a:srgbClr val="FFFFFF"/>
-                </a:solidFill>
-              </a:defRPr>
-            </a:lvl7pPr>
-            <a:lvl8pPr>
-              <a:defRPr sz="1275" b="1">
-                <a:solidFill>
-                  <a:srgbClr val="FFFFFF"/>
-                </a:solidFill>
-              </a:defRPr>
-            </a:lvl8pPr>
-            <a:lvl9pPr>
-              <a:defRPr sz="1275" b="1">
-                <a:solidFill>
-                  <a:srgbClr val="FFFFFF"/>
-                </a:solidFill>
-              </a:defRPr>
-            </a:lvl9pPr>
-          </a:lstStyle>
-          <a:p xmlns:a="http://schemas.openxmlformats.org/drawingml/2006/main">
-            <a:pPr>
-              <a:defRPr sz="1275" b="1">
-                <a:solidFill>
-                  <a:srgbClr val="FFFFFF"/>
-                </a:solidFill>
-              </a:defRPr>
-            </a:pPr>
-            <a:r>
-              <a:rPr sz="1275" b="1">
-                <a:solidFill>
-                  <a:srgbClr val="FFFFFF"/>
-                </a:solidFill>
-              </a:rPr>
-              <a:t>FEASIBLE MVP</a:t>
-            </a:r>
-          </a:p>
-        </p:txBody>
-      </p:sp>
-      <p:sp>
-        <p:nvSpPr>
-          <p:cNvPr id="20" name="scope">
-            <a:extLst xmlns:a="http://schemas.openxmlformats.org/drawingml/2006/main">
-              <a:ext uri="{FF2B5EF4-FFF2-40B4-BE49-F238E27FC236}">
-                <a16:creationId xmlns:a16="http://schemas.microsoft.com/office/drawing/2014/main" id="{94C46795-3C41-4BF7-AA2C-C8D157EC80AB}"/>
-              </a:ext>
-            </a:extLst>
-          </p:cNvPr>
-          <p:cNvSpPr>
-            <a:spLocks xmlns:a="http://schemas.openxmlformats.org/drawingml/2006/main" noGrp="1"/>
-          </p:cNvSpPr>
-          <p:nvPr/>
-        </p:nvSpPr>
-        <p:spPr>
-          <a:xfrm xmlns:a="http://schemas.openxmlformats.org/drawingml/2006/main">
-            <a:off x="3143250" y="5581650"/>
-            <a:ext cx="8439150" cy="571500"/>
+            <a:off x="609600" y="3648075"/>
+            <a:ext cx="5238750" cy="323850"/>
           </a:xfrm>
           <a:prstGeom xmlns:a="http://schemas.openxmlformats.org/drawingml/2006/main" prst="rect">
             <a:avLst/>
@@ -18322,17 +17284,17 @@
                   <a:srgbClr val="FFFFFF"/>
                 </a:solidFill>
               </a:rPr>
-              <a:t>Curated modules and task expressions run on shared execution infrastructure.</a:t>
+              <a:t>illustrative total usage cost saving</a:t>
             </a:r>
           </a:p>
         </p:txBody>
       </p:sp>
       <p:sp>
         <p:nvSpPr>
-          <p:cNvPr id="21" name="roadmap">
+          <p:cNvPr id="10" name="scope-value">
             <a:extLst xmlns:a="http://schemas.openxmlformats.org/drawingml/2006/main">
               <a:ext uri="{FF2B5EF4-FFF2-40B4-BE49-F238E27FC236}">
-                <a16:creationId xmlns:a16="http://schemas.microsoft.com/office/drawing/2014/main" id="{0574A088-4756-4891-887F-A79A5307C1D6}"/>
+                <a16:creationId xmlns:a16="http://schemas.microsoft.com/office/drawing/2014/main" id="{75D783EB-4012-4083-968F-DB614EF8D8E6}"/>
               </a:ext>
             </a:extLst>
           </p:cNvPr>
@@ -18343,8 +17305,8 @@
         </p:nvSpPr>
         <p:spPr>
           <a:xfrm xmlns:a="http://schemas.openxmlformats.org/drawingml/2006/main">
-            <a:off x="609600" y="6334125"/>
-            <a:ext cx="10477500" cy="285750"/>
+            <a:off x="6762750" y="2495550"/>
+            <a:ext cx="2000250" cy="1066800"/>
           </a:xfrm>
           <a:prstGeom xmlns:a="http://schemas.openxmlformats.org/drawingml/2006/main" prst="rect">
             <a:avLst/>
@@ -18359,70 +17321,70 @@
           <a:bodyPr xmlns:a="http://schemas.openxmlformats.org/drawingml/2006/main" lIns="0" tIns="0" rIns="0" bIns="0"/>
           <a:lstStyle xmlns:a="http://schemas.openxmlformats.org/drawingml/2006/main">
             <a:defPPr>
-              <a:defRPr sz="1500" b="0">
+              <a:defRPr sz="7950" b="1">
                 <a:solidFill>
                   <a:srgbClr val="FFFFFF"/>
                 </a:solidFill>
               </a:defRPr>
             </a:defPPr>
             <a:lvl1pPr>
-              <a:defRPr sz="1500" b="0">
+              <a:defRPr sz="7950" b="1">
                 <a:solidFill>
                   <a:srgbClr val="FFFFFF"/>
                 </a:solidFill>
               </a:defRPr>
             </a:lvl1pPr>
             <a:lvl2pPr>
-              <a:defRPr sz="1500" b="0">
+              <a:defRPr sz="7950" b="1">
                 <a:solidFill>
                   <a:srgbClr val="FFFFFF"/>
                 </a:solidFill>
               </a:defRPr>
             </a:lvl2pPr>
             <a:lvl3pPr>
-              <a:defRPr sz="1500" b="0">
+              <a:defRPr sz="7950" b="1">
                 <a:solidFill>
                   <a:srgbClr val="FFFFFF"/>
                 </a:solidFill>
               </a:defRPr>
             </a:lvl3pPr>
             <a:lvl4pPr>
-              <a:defRPr sz="1500" b="0">
+              <a:defRPr sz="7950" b="1">
                 <a:solidFill>
                   <a:srgbClr val="FFFFFF"/>
                 </a:solidFill>
               </a:defRPr>
             </a:lvl4pPr>
             <a:lvl5pPr>
-              <a:defRPr sz="1500" b="0">
+              <a:defRPr sz="7950" b="1">
                 <a:solidFill>
                   <a:srgbClr val="FFFFFF"/>
                 </a:solidFill>
               </a:defRPr>
             </a:lvl5pPr>
             <a:lvl6pPr>
-              <a:defRPr sz="1500" b="0">
+              <a:defRPr sz="7950" b="1">
                 <a:solidFill>
                   <a:srgbClr val="FFFFFF"/>
                 </a:solidFill>
               </a:defRPr>
             </a:lvl6pPr>
             <a:lvl7pPr>
-              <a:defRPr sz="1500" b="0">
+              <a:defRPr sz="7950" b="1">
                 <a:solidFill>
                   <a:srgbClr val="FFFFFF"/>
                 </a:solidFill>
               </a:defRPr>
             </a:lvl7pPr>
             <a:lvl8pPr>
-              <a:defRPr sz="1500" b="0">
+              <a:defRPr sz="7950" b="1">
                 <a:solidFill>
                   <a:srgbClr val="FFFFFF"/>
                 </a:solidFill>
               </a:defRPr>
             </a:lvl8pPr>
             <a:lvl9pPr>
-              <a:defRPr sz="1500" b="0">
+              <a:defRPr sz="7950" b="1">
                 <a:solidFill>
                   <a:srgbClr val="FFFFFF"/>
                 </a:solidFill>
@@ -18431,19 +17393,1133 @@
           </a:lstStyle>
           <a:p xmlns:a="http://schemas.openxmlformats.org/drawingml/2006/main">
             <a:pPr>
-              <a:defRPr sz="1500" b="0">
+              <a:defRPr sz="7950" b="1">
                 <a:solidFill>
                   <a:srgbClr val="FFFFFF"/>
                 </a:solidFill>
               </a:defRPr>
             </a:pPr>
             <a:r>
-              <a:rPr sz="1500" b="0">
+              <a:rPr sz="7950" b="1">
                 <a:solidFill>
                   <a:srgbClr val="FFFFFF"/>
                 </a:solidFill>
               </a:rPr>
-              <a:t>Benefits to validate: result correctness, total usage cost and user adoption</a:t>
+              <a:t>4</a:t>
+            </a:r>
+          </a:p>
+        </p:txBody>
+      </p:sp>
+      <p:sp>
+        <p:nvSpPr>
+          <p:cNvPr id="11" name="scope-label">
+            <a:extLst xmlns:a="http://schemas.openxmlformats.org/drawingml/2006/main">
+              <a:ext uri="{FF2B5EF4-FFF2-40B4-BE49-F238E27FC236}">
+                <a16:creationId xmlns:a16="http://schemas.microsoft.com/office/drawing/2014/main" id="{DB695148-BFD8-4CE4-9F2A-8295D423146E}"/>
+              </a:ext>
+            </a:extLst>
+          </p:cNvPr>
+          <p:cNvSpPr>
+            <a:spLocks xmlns:a="http://schemas.openxmlformats.org/drawingml/2006/main" noGrp="1"/>
+          </p:cNvSpPr>
+          <p:nvPr/>
+        </p:nvSpPr>
+        <p:spPr>
+          <a:xfrm xmlns:a="http://schemas.openxmlformats.org/drawingml/2006/main">
+            <a:off x="6762750" y="3648075"/>
+            <a:ext cx="4819650" cy="323850"/>
+          </a:xfrm>
+          <a:prstGeom xmlns:a="http://schemas.openxmlformats.org/drawingml/2006/main" prst="rect">
+            <a:avLst/>
+          </a:prstGeom>
+          <a:noFill xmlns:a="http://schemas.openxmlformats.org/drawingml/2006/main"/>
+          <a:ln xmlns:a="http://schemas.openxmlformats.org/drawingml/2006/main" w="0">
+            <a:noFill/>
+            <a:prstDash val="solid"/>
+          </a:ln>
+        </p:spPr>
+        <p:txBody>
+          <a:bodyPr xmlns:a="http://schemas.openxmlformats.org/drawingml/2006/main" lIns="0" tIns="0" rIns="0" bIns="0"/>
+          <a:lstStyle xmlns:a="http://schemas.openxmlformats.org/drawingml/2006/main">
+            <a:defPPr>
+              <a:defRPr sz="1800" b="0">
+                <a:solidFill>
+                  <a:srgbClr val="FFFFFF"/>
+                </a:solidFill>
+              </a:defRPr>
+            </a:defPPr>
+            <a:lvl1pPr>
+              <a:defRPr sz="1800" b="0">
+                <a:solidFill>
+                  <a:srgbClr val="FFFFFF"/>
+                </a:solidFill>
+              </a:defRPr>
+            </a:lvl1pPr>
+            <a:lvl2pPr>
+              <a:defRPr sz="1800" b="0">
+                <a:solidFill>
+                  <a:srgbClr val="FFFFFF"/>
+                </a:solidFill>
+              </a:defRPr>
+            </a:lvl2pPr>
+            <a:lvl3pPr>
+              <a:defRPr sz="1800" b="0">
+                <a:solidFill>
+                  <a:srgbClr val="FFFFFF"/>
+                </a:solidFill>
+              </a:defRPr>
+            </a:lvl3pPr>
+            <a:lvl4pPr>
+              <a:defRPr sz="1800" b="0">
+                <a:solidFill>
+                  <a:srgbClr val="FFFFFF"/>
+                </a:solidFill>
+              </a:defRPr>
+            </a:lvl4pPr>
+            <a:lvl5pPr>
+              <a:defRPr sz="1800" b="0">
+                <a:solidFill>
+                  <a:srgbClr val="FFFFFF"/>
+                </a:solidFill>
+              </a:defRPr>
+            </a:lvl5pPr>
+            <a:lvl6pPr>
+              <a:defRPr sz="1800" b="0">
+                <a:solidFill>
+                  <a:srgbClr val="FFFFFF"/>
+                </a:solidFill>
+              </a:defRPr>
+            </a:lvl6pPr>
+            <a:lvl7pPr>
+              <a:defRPr sz="1800" b="0">
+                <a:solidFill>
+                  <a:srgbClr val="FFFFFF"/>
+                </a:solidFill>
+              </a:defRPr>
+            </a:lvl7pPr>
+            <a:lvl8pPr>
+              <a:defRPr sz="1800" b="0">
+                <a:solidFill>
+                  <a:srgbClr val="FFFFFF"/>
+                </a:solidFill>
+              </a:defRPr>
+            </a:lvl8pPr>
+            <a:lvl9pPr>
+              <a:defRPr sz="1800" b="0">
+                <a:solidFill>
+                  <a:srgbClr val="FFFFFF"/>
+                </a:solidFill>
+              </a:defRPr>
+            </a:lvl9pPr>
+          </a:lstStyle>
+          <a:p xmlns:a="http://schemas.openxmlformats.org/drawingml/2006/main">
+            <a:pPr>
+              <a:defRPr sz="1800" b="0">
+                <a:solidFill>
+                  <a:srgbClr val="FFFFFF"/>
+                </a:solidFill>
+              </a:defRPr>
+            </a:pPr>
+            <a:r>
+              <a:rPr sz="1800" b="0">
+                <a:solidFill>
+                  <a:srgbClr val="FFFFFF"/>
+                </a:solidFill>
+              </a:rPr>
+              <a:t>planned capability types in one agent</a:t>
+            </a:r>
+          </a:p>
+        </p:txBody>
+      </p:sp>
+      <p:graphicFrame>
+        <p:nvGraphicFramePr>
+          <p:cNvPr id="12" name="Chart">
+            <a:extLst xmlns:a="http://schemas.openxmlformats.org/drawingml/2006/main">
+              <a:ext uri="{FF2B5EF4-FFF2-40B4-BE49-F238E27FC236}">
+                <a16:creationId xmlns:a16="http://schemas.microsoft.com/office/drawing/2014/main" id="{CC40CFDB-4E00-4D4E-B66F-7E43421D38CB}"/>
+              </a:ext>
+            </a:extLst>
+          </p:cNvPr>
+          <p:cNvGraphicFramePr/>
+          <p:nvPr/>
+        </p:nvGraphicFramePr>
+        <p:xfrm>
+          <a:off xmlns:a="http://schemas.openxmlformats.org/drawingml/2006/main" x="609600" y="4152900"/>
+          <a:ext xmlns:a="http://schemas.openxmlformats.org/drawingml/2006/main" cx="5143500" cy="1314450"/>
+        </p:xfrm>
+        <a:graphic xmlns:a="http://schemas.openxmlformats.org/drawingml/2006/main">
+          <a:graphicData uri="http://schemas.openxmlformats.org/drawingml/2006/chart">
+            <c:chart xmlns:r="http://schemas.openxmlformats.org/officeDocument/2006/relationships" xmlns:c="http://schemas.openxmlformats.org/drawingml/2006/chart" r:id="R6fc960617f8e4897"/>
+          </a:graphicData>
+        </a:graphic>
+      </p:graphicFrame>
+      <p:sp>
+        <p:nvSpPr>
+          <p:cNvPr id="13" name="interpret">
+            <a:extLst xmlns:a="http://schemas.openxmlformats.org/drawingml/2006/main">
+              <a:ext uri="{FF2B5EF4-FFF2-40B4-BE49-F238E27FC236}">
+                <a16:creationId xmlns:a16="http://schemas.microsoft.com/office/drawing/2014/main" id="{C6E65349-AE87-4A02-98A6-02B3B2EED41B}"/>
+              </a:ext>
+            </a:extLst>
+          </p:cNvPr>
+          <p:cNvSpPr>
+            <a:spLocks xmlns:a="http://schemas.openxmlformats.org/drawingml/2006/main" noGrp="1"/>
+          </p:cNvSpPr>
+          <p:nvPr/>
+        </p:nvSpPr>
+        <p:spPr>
+          <a:xfrm xmlns:a="http://schemas.openxmlformats.org/drawingml/2006/main">
+            <a:off x="6762750" y="4524375"/>
+            <a:ext cx="1619250" cy="542925"/>
+          </a:xfrm>
+          <a:prstGeom xmlns:a="http://schemas.openxmlformats.org/drawingml/2006/main" prst="rect">
+            <a:avLst/>
+          </a:prstGeom>
+          <a:noFill xmlns:a="http://schemas.openxmlformats.org/drawingml/2006/main"/>
+          <a:ln xmlns:a="http://schemas.openxmlformats.org/drawingml/2006/main" w="14288">
+            <a:solidFill>
+              <a:srgbClr val="FFFFFF"/>
+            </a:solidFill>
+            <a:prstDash val="solid"/>
+          </a:ln>
+        </p:spPr>
+      </p:sp>
+      <p:sp>
+        <p:nvSpPr>
+          <p:cNvPr id="14" name="interpret-label">
+            <a:extLst xmlns:a="http://schemas.openxmlformats.org/drawingml/2006/main">
+              <a:ext uri="{FF2B5EF4-FFF2-40B4-BE49-F238E27FC236}">
+                <a16:creationId xmlns:a16="http://schemas.microsoft.com/office/drawing/2014/main" id="{F48FD354-5AEB-4397-9489-C1734CDF9A24}"/>
+              </a:ext>
+            </a:extLst>
+          </p:cNvPr>
+          <p:cNvSpPr>
+            <a:spLocks xmlns:a="http://schemas.openxmlformats.org/drawingml/2006/main" noGrp="1"/>
+          </p:cNvSpPr>
+          <p:nvPr/>
+        </p:nvSpPr>
+        <p:spPr>
+          <a:xfrm xmlns:a="http://schemas.openxmlformats.org/drawingml/2006/main">
+            <a:off x="6896100" y="4629150"/>
+            <a:ext cx="1371600" cy="409575"/>
+          </a:xfrm>
+          <a:prstGeom xmlns:a="http://schemas.openxmlformats.org/drawingml/2006/main" prst="rect">
+            <a:avLst/>
+          </a:prstGeom>
+          <a:noFill xmlns:a="http://schemas.openxmlformats.org/drawingml/2006/main"/>
+          <a:ln xmlns:a="http://schemas.openxmlformats.org/drawingml/2006/main" w="0">
+            <a:noFill/>
+            <a:prstDash val="solid"/>
+          </a:ln>
+        </p:spPr>
+        <p:txBody>
+          <a:bodyPr xmlns:a="http://schemas.openxmlformats.org/drawingml/2006/main" lIns="0" tIns="0" rIns="0" bIns="0"/>
+          <a:lstStyle xmlns:a="http://schemas.openxmlformats.org/drawingml/2006/main">
+            <a:defPPr>
+              <a:defRPr sz="1650" b="0">
+                <a:solidFill>
+                  <a:srgbClr val="FFFFFF"/>
+                </a:solidFill>
+              </a:defRPr>
+            </a:defPPr>
+            <a:lvl1pPr>
+              <a:defRPr sz="1650" b="0">
+                <a:solidFill>
+                  <a:srgbClr val="FFFFFF"/>
+                </a:solidFill>
+              </a:defRPr>
+            </a:lvl1pPr>
+            <a:lvl2pPr>
+              <a:defRPr sz="1650" b="0">
+                <a:solidFill>
+                  <a:srgbClr val="FFFFFF"/>
+                </a:solidFill>
+              </a:defRPr>
+            </a:lvl2pPr>
+            <a:lvl3pPr>
+              <a:defRPr sz="1650" b="0">
+                <a:solidFill>
+                  <a:srgbClr val="FFFFFF"/>
+                </a:solidFill>
+              </a:defRPr>
+            </a:lvl3pPr>
+            <a:lvl4pPr>
+              <a:defRPr sz="1650" b="0">
+                <a:solidFill>
+                  <a:srgbClr val="FFFFFF"/>
+                </a:solidFill>
+              </a:defRPr>
+            </a:lvl4pPr>
+            <a:lvl5pPr>
+              <a:defRPr sz="1650" b="0">
+                <a:solidFill>
+                  <a:srgbClr val="FFFFFF"/>
+                </a:solidFill>
+              </a:defRPr>
+            </a:lvl5pPr>
+            <a:lvl6pPr>
+              <a:defRPr sz="1650" b="0">
+                <a:solidFill>
+                  <a:srgbClr val="FFFFFF"/>
+                </a:solidFill>
+              </a:defRPr>
+            </a:lvl6pPr>
+            <a:lvl7pPr>
+              <a:defRPr sz="1650" b="0">
+                <a:solidFill>
+                  <a:srgbClr val="FFFFFF"/>
+                </a:solidFill>
+              </a:defRPr>
+            </a:lvl7pPr>
+            <a:lvl8pPr>
+              <a:defRPr sz="1650" b="0">
+                <a:solidFill>
+                  <a:srgbClr val="FFFFFF"/>
+                </a:solidFill>
+              </a:defRPr>
+            </a:lvl8pPr>
+            <a:lvl9pPr>
+              <a:defRPr sz="1650" b="0">
+                <a:solidFill>
+                  <a:srgbClr val="FFFFFF"/>
+                </a:solidFill>
+              </a:defRPr>
+            </a:lvl9pPr>
+          </a:lstStyle>
+          <a:p xmlns:a="http://schemas.openxmlformats.org/drawingml/2006/main">
+            <a:pPr>
+              <a:defRPr sz="1650" b="0">
+                <a:solidFill>
+                  <a:srgbClr val="FFFFFF"/>
+                </a:solidFill>
+              </a:defRPr>
+            </a:pPr>
+            <a:r>
+              <a:rPr sz="1650" b="0">
+                <a:solidFill>
+                  <a:srgbClr val="FFFFFF"/>
+                </a:solidFill>
+              </a:rPr>
+              <a:t>Interpret</a:t>
+            </a:r>
+          </a:p>
+        </p:txBody>
+      </p:sp>
+      <p:sp>
+        <p:nvSpPr>
+          <p:cNvPr id="15" name="cap-Calculate">
+            <a:extLst xmlns:a="http://schemas.openxmlformats.org/drawingml/2006/main">
+              <a:ext uri="{FF2B5EF4-FFF2-40B4-BE49-F238E27FC236}">
+                <a16:creationId xmlns:a16="http://schemas.microsoft.com/office/drawing/2014/main" id="{452C676C-FD3F-43A3-8C3F-D5F67492422E}"/>
+              </a:ext>
+            </a:extLst>
+          </p:cNvPr>
+          <p:cNvSpPr>
+            <a:spLocks xmlns:a="http://schemas.openxmlformats.org/drawingml/2006/main" noGrp="1"/>
+          </p:cNvSpPr>
+          <p:nvPr/>
+        </p:nvSpPr>
+        <p:spPr>
+          <a:xfrm xmlns:a="http://schemas.openxmlformats.org/drawingml/2006/main">
+            <a:off x="9525000" y="4143375"/>
+            <a:ext cx="2057400" cy="457200"/>
+          </a:xfrm>
+          <a:prstGeom xmlns:a="http://schemas.openxmlformats.org/drawingml/2006/main" prst="rect">
+            <a:avLst/>
+          </a:prstGeom>
+          <a:noFill xmlns:a="http://schemas.openxmlformats.org/drawingml/2006/main"/>
+          <a:ln xmlns:a="http://schemas.openxmlformats.org/drawingml/2006/main" w="14288">
+            <a:solidFill>
+              <a:srgbClr val="FFFFFF"/>
+            </a:solidFill>
+            <a:prstDash val="solid"/>
+          </a:ln>
+        </p:spPr>
+      </p:sp>
+      <p:sp>
+        <p:nvSpPr>
+          <p:cNvPr id="16" name="cap-Calculate-label">
+            <a:extLst xmlns:a="http://schemas.openxmlformats.org/drawingml/2006/main">
+              <a:ext uri="{FF2B5EF4-FFF2-40B4-BE49-F238E27FC236}">
+                <a16:creationId xmlns:a16="http://schemas.microsoft.com/office/drawing/2014/main" id="{05021095-FEE8-45AF-AFFA-8CEE1BBBBDF4}"/>
+              </a:ext>
+            </a:extLst>
+          </p:cNvPr>
+          <p:cNvSpPr>
+            <a:spLocks xmlns:a="http://schemas.openxmlformats.org/drawingml/2006/main" noGrp="1"/>
+          </p:cNvSpPr>
+          <p:nvPr/>
+        </p:nvSpPr>
+        <p:spPr>
+          <a:xfrm xmlns:a="http://schemas.openxmlformats.org/drawingml/2006/main">
+            <a:off x="9658350" y="4248150"/>
+            <a:ext cx="1809750" cy="323850"/>
+          </a:xfrm>
+          <a:prstGeom xmlns:a="http://schemas.openxmlformats.org/drawingml/2006/main" prst="rect">
+            <a:avLst/>
+          </a:prstGeom>
+          <a:noFill xmlns:a="http://schemas.openxmlformats.org/drawingml/2006/main"/>
+          <a:ln xmlns:a="http://schemas.openxmlformats.org/drawingml/2006/main" w="0">
+            <a:noFill/>
+            <a:prstDash val="solid"/>
+          </a:ln>
+        </p:spPr>
+        <p:txBody>
+          <a:bodyPr xmlns:a="http://schemas.openxmlformats.org/drawingml/2006/main" lIns="0" tIns="0" rIns="0" bIns="0"/>
+          <a:lstStyle xmlns:a="http://schemas.openxmlformats.org/drawingml/2006/main">
+            <a:defPPr>
+              <a:defRPr sz="1650" b="0">
+                <a:solidFill>
+                  <a:srgbClr val="FFFFFF"/>
+                </a:solidFill>
+              </a:defRPr>
+            </a:defPPr>
+            <a:lvl1pPr>
+              <a:defRPr sz="1650" b="0">
+                <a:solidFill>
+                  <a:srgbClr val="FFFFFF"/>
+                </a:solidFill>
+              </a:defRPr>
+            </a:lvl1pPr>
+            <a:lvl2pPr>
+              <a:defRPr sz="1650" b="0">
+                <a:solidFill>
+                  <a:srgbClr val="FFFFFF"/>
+                </a:solidFill>
+              </a:defRPr>
+            </a:lvl2pPr>
+            <a:lvl3pPr>
+              <a:defRPr sz="1650" b="0">
+                <a:solidFill>
+                  <a:srgbClr val="FFFFFF"/>
+                </a:solidFill>
+              </a:defRPr>
+            </a:lvl3pPr>
+            <a:lvl4pPr>
+              <a:defRPr sz="1650" b="0">
+                <a:solidFill>
+                  <a:srgbClr val="FFFFFF"/>
+                </a:solidFill>
+              </a:defRPr>
+            </a:lvl4pPr>
+            <a:lvl5pPr>
+              <a:defRPr sz="1650" b="0">
+                <a:solidFill>
+                  <a:srgbClr val="FFFFFF"/>
+                </a:solidFill>
+              </a:defRPr>
+            </a:lvl5pPr>
+            <a:lvl6pPr>
+              <a:defRPr sz="1650" b="0">
+                <a:solidFill>
+                  <a:srgbClr val="FFFFFF"/>
+                </a:solidFill>
+              </a:defRPr>
+            </a:lvl6pPr>
+            <a:lvl7pPr>
+              <a:defRPr sz="1650" b="0">
+                <a:solidFill>
+                  <a:srgbClr val="FFFFFF"/>
+                </a:solidFill>
+              </a:defRPr>
+            </a:lvl7pPr>
+            <a:lvl8pPr>
+              <a:defRPr sz="1650" b="0">
+                <a:solidFill>
+                  <a:srgbClr val="FFFFFF"/>
+                </a:solidFill>
+              </a:defRPr>
+            </a:lvl8pPr>
+            <a:lvl9pPr>
+              <a:defRPr sz="1650" b="0">
+                <a:solidFill>
+                  <a:srgbClr val="FFFFFF"/>
+                </a:solidFill>
+              </a:defRPr>
+            </a:lvl9pPr>
+          </a:lstStyle>
+          <a:p xmlns:a="http://schemas.openxmlformats.org/drawingml/2006/main">
+            <a:pPr>
+              <a:defRPr sz="1650" b="0">
+                <a:solidFill>
+                  <a:srgbClr val="FFFFFF"/>
+                </a:solidFill>
+              </a:defRPr>
+            </a:pPr>
+            <a:r>
+              <a:rPr sz="1650" b="0">
+                <a:solidFill>
+                  <a:srgbClr val="FFFFFF"/>
+                </a:solidFill>
+              </a:rPr>
+              <a:t>Calculate</a:t>
+            </a:r>
+          </a:p>
+        </p:txBody>
+      </p:sp>
+      <p:sp>
+        <p:nvSpPr>
+          <p:cNvPr id="17" name="cap-Validate">
+            <a:extLst xmlns:a="http://schemas.openxmlformats.org/drawingml/2006/main">
+              <a:ext uri="{FF2B5EF4-FFF2-40B4-BE49-F238E27FC236}">
+                <a16:creationId xmlns:a16="http://schemas.microsoft.com/office/drawing/2014/main" id="{EF0ED873-1CC6-4DD9-96DA-4A058809C909}"/>
+              </a:ext>
+            </a:extLst>
+          </p:cNvPr>
+          <p:cNvSpPr>
+            <a:spLocks xmlns:a="http://schemas.openxmlformats.org/drawingml/2006/main" noGrp="1"/>
+          </p:cNvSpPr>
+          <p:nvPr/>
+        </p:nvSpPr>
+        <p:spPr>
+          <a:xfrm xmlns:a="http://schemas.openxmlformats.org/drawingml/2006/main">
+            <a:off x="9525000" y="4752975"/>
+            <a:ext cx="2057400" cy="457200"/>
+          </a:xfrm>
+          <a:prstGeom xmlns:a="http://schemas.openxmlformats.org/drawingml/2006/main" prst="rect">
+            <a:avLst/>
+          </a:prstGeom>
+          <a:noFill xmlns:a="http://schemas.openxmlformats.org/drawingml/2006/main"/>
+          <a:ln xmlns:a="http://schemas.openxmlformats.org/drawingml/2006/main" w="14288">
+            <a:solidFill>
+              <a:srgbClr val="FFFFFF"/>
+            </a:solidFill>
+            <a:prstDash val="solid"/>
+          </a:ln>
+        </p:spPr>
+      </p:sp>
+      <p:sp>
+        <p:nvSpPr>
+          <p:cNvPr id="18" name="cap-Validate-label">
+            <a:extLst xmlns:a="http://schemas.openxmlformats.org/drawingml/2006/main">
+              <a:ext uri="{FF2B5EF4-FFF2-40B4-BE49-F238E27FC236}">
+                <a16:creationId xmlns:a16="http://schemas.microsoft.com/office/drawing/2014/main" id="{D245CA7F-FEC3-4D9D-8226-3A3FFD46F2DD}"/>
+              </a:ext>
+            </a:extLst>
+          </p:cNvPr>
+          <p:cNvSpPr>
+            <a:spLocks xmlns:a="http://schemas.openxmlformats.org/drawingml/2006/main" noGrp="1"/>
+          </p:cNvSpPr>
+          <p:nvPr/>
+        </p:nvSpPr>
+        <p:spPr>
+          <a:xfrm xmlns:a="http://schemas.openxmlformats.org/drawingml/2006/main">
+            <a:off x="9658350" y="4857750"/>
+            <a:ext cx="1809750" cy="323850"/>
+          </a:xfrm>
+          <a:prstGeom xmlns:a="http://schemas.openxmlformats.org/drawingml/2006/main" prst="rect">
+            <a:avLst/>
+          </a:prstGeom>
+          <a:noFill xmlns:a="http://schemas.openxmlformats.org/drawingml/2006/main"/>
+          <a:ln xmlns:a="http://schemas.openxmlformats.org/drawingml/2006/main" w="0">
+            <a:noFill/>
+            <a:prstDash val="solid"/>
+          </a:ln>
+        </p:spPr>
+        <p:txBody>
+          <a:bodyPr xmlns:a="http://schemas.openxmlformats.org/drawingml/2006/main" lIns="0" tIns="0" rIns="0" bIns="0"/>
+          <a:lstStyle xmlns:a="http://schemas.openxmlformats.org/drawingml/2006/main">
+            <a:defPPr>
+              <a:defRPr sz="1650" b="0">
+                <a:solidFill>
+                  <a:srgbClr val="FFFFFF"/>
+                </a:solidFill>
+              </a:defRPr>
+            </a:defPPr>
+            <a:lvl1pPr>
+              <a:defRPr sz="1650" b="0">
+                <a:solidFill>
+                  <a:srgbClr val="FFFFFF"/>
+                </a:solidFill>
+              </a:defRPr>
+            </a:lvl1pPr>
+            <a:lvl2pPr>
+              <a:defRPr sz="1650" b="0">
+                <a:solidFill>
+                  <a:srgbClr val="FFFFFF"/>
+                </a:solidFill>
+              </a:defRPr>
+            </a:lvl2pPr>
+            <a:lvl3pPr>
+              <a:defRPr sz="1650" b="0">
+                <a:solidFill>
+                  <a:srgbClr val="FFFFFF"/>
+                </a:solidFill>
+              </a:defRPr>
+            </a:lvl3pPr>
+            <a:lvl4pPr>
+              <a:defRPr sz="1650" b="0">
+                <a:solidFill>
+                  <a:srgbClr val="FFFFFF"/>
+                </a:solidFill>
+              </a:defRPr>
+            </a:lvl4pPr>
+            <a:lvl5pPr>
+              <a:defRPr sz="1650" b="0">
+                <a:solidFill>
+                  <a:srgbClr val="FFFFFF"/>
+                </a:solidFill>
+              </a:defRPr>
+            </a:lvl5pPr>
+            <a:lvl6pPr>
+              <a:defRPr sz="1650" b="0">
+                <a:solidFill>
+                  <a:srgbClr val="FFFFFF"/>
+                </a:solidFill>
+              </a:defRPr>
+            </a:lvl6pPr>
+            <a:lvl7pPr>
+              <a:defRPr sz="1650" b="0">
+                <a:solidFill>
+                  <a:srgbClr val="FFFFFF"/>
+                </a:solidFill>
+              </a:defRPr>
+            </a:lvl7pPr>
+            <a:lvl8pPr>
+              <a:defRPr sz="1650" b="0">
+                <a:solidFill>
+                  <a:srgbClr val="FFFFFF"/>
+                </a:solidFill>
+              </a:defRPr>
+            </a:lvl8pPr>
+            <a:lvl9pPr>
+              <a:defRPr sz="1650" b="0">
+                <a:solidFill>
+                  <a:srgbClr val="FFFFFF"/>
+                </a:solidFill>
+              </a:defRPr>
+            </a:lvl9pPr>
+          </a:lstStyle>
+          <a:p xmlns:a="http://schemas.openxmlformats.org/drawingml/2006/main">
+            <a:pPr>
+              <a:defRPr sz="1650" b="0">
+                <a:solidFill>
+                  <a:srgbClr val="FFFFFF"/>
+                </a:solidFill>
+              </a:defRPr>
+            </a:pPr>
+            <a:r>
+              <a:rPr sz="1650" b="0">
+                <a:solidFill>
+                  <a:srgbClr val="FFFFFF"/>
+                </a:solidFill>
+              </a:rPr>
+              <a:t>Validate</a:t>
+            </a:r>
+          </a:p>
+        </p:txBody>
+      </p:sp>
+      <p:sp>
+        <p:nvSpPr>
+          <p:cNvPr id="19" name="cap-Act">
+            <a:extLst xmlns:a="http://schemas.openxmlformats.org/drawingml/2006/main">
+              <a:ext uri="{FF2B5EF4-FFF2-40B4-BE49-F238E27FC236}">
+                <a16:creationId xmlns:a16="http://schemas.microsoft.com/office/drawing/2014/main" id="{A99D0E92-D87B-4AFB-A994-D6E440C1BBED}"/>
+              </a:ext>
+            </a:extLst>
+          </p:cNvPr>
+          <p:cNvSpPr>
+            <a:spLocks xmlns:a="http://schemas.openxmlformats.org/drawingml/2006/main" noGrp="1"/>
+          </p:cNvSpPr>
+          <p:nvPr/>
+        </p:nvSpPr>
+        <p:spPr>
+          <a:xfrm xmlns:a="http://schemas.openxmlformats.org/drawingml/2006/main">
+            <a:off x="9525000" y="5362575"/>
+            <a:ext cx="2057400" cy="457200"/>
+          </a:xfrm>
+          <a:prstGeom xmlns:a="http://schemas.openxmlformats.org/drawingml/2006/main" prst="rect">
+            <a:avLst/>
+          </a:prstGeom>
+          <a:noFill xmlns:a="http://schemas.openxmlformats.org/drawingml/2006/main"/>
+          <a:ln xmlns:a="http://schemas.openxmlformats.org/drawingml/2006/main" w="14288">
+            <a:solidFill>
+              <a:srgbClr val="FFFFFF"/>
+            </a:solidFill>
+            <a:prstDash val="solid"/>
+          </a:ln>
+        </p:spPr>
+      </p:sp>
+      <p:sp>
+        <p:nvSpPr>
+          <p:cNvPr id="20" name="cap-Act-label">
+            <a:extLst xmlns:a="http://schemas.openxmlformats.org/drawingml/2006/main">
+              <a:ext uri="{FF2B5EF4-FFF2-40B4-BE49-F238E27FC236}">
+                <a16:creationId xmlns:a16="http://schemas.microsoft.com/office/drawing/2014/main" id="{7DD5D875-33A3-4CFB-A9AD-9FB01D2A7BA6}"/>
+              </a:ext>
+            </a:extLst>
+          </p:cNvPr>
+          <p:cNvSpPr>
+            <a:spLocks xmlns:a="http://schemas.openxmlformats.org/drawingml/2006/main" noGrp="1"/>
+          </p:cNvSpPr>
+          <p:nvPr/>
+        </p:nvSpPr>
+        <p:spPr>
+          <a:xfrm xmlns:a="http://schemas.openxmlformats.org/drawingml/2006/main">
+            <a:off x="9658350" y="5467350"/>
+            <a:ext cx="1809750" cy="323850"/>
+          </a:xfrm>
+          <a:prstGeom xmlns:a="http://schemas.openxmlformats.org/drawingml/2006/main" prst="rect">
+            <a:avLst/>
+          </a:prstGeom>
+          <a:noFill xmlns:a="http://schemas.openxmlformats.org/drawingml/2006/main"/>
+          <a:ln xmlns:a="http://schemas.openxmlformats.org/drawingml/2006/main" w="0">
+            <a:noFill/>
+            <a:prstDash val="solid"/>
+          </a:ln>
+        </p:spPr>
+        <p:txBody>
+          <a:bodyPr xmlns:a="http://schemas.openxmlformats.org/drawingml/2006/main" lIns="0" tIns="0" rIns="0" bIns="0"/>
+          <a:lstStyle xmlns:a="http://schemas.openxmlformats.org/drawingml/2006/main">
+            <a:defPPr>
+              <a:defRPr sz="1650" b="0">
+                <a:solidFill>
+                  <a:srgbClr val="FFFFFF"/>
+                </a:solidFill>
+              </a:defRPr>
+            </a:defPPr>
+            <a:lvl1pPr>
+              <a:defRPr sz="1650" b="0">
+                <a:solidFill>
+                  <a:srgbClr val="FFFFFF"/>
+                </a:solidFill>
+              </a:defRPr>
+            </a:lvl1pPr>
+            <a:lvl2pPr>
+              <a:defRPr sz="1650" b="0">
+                <a:solidFill>
+                  <a:srgbClr val="FFFFFF"/>
+                </a:solidFill>
+              </a:defRPr>
+            </a:lvl2pPr>
+            <a:lvl3pPr>
+              <a:defRPr sz="1650" b="0">
+                <a:solidFill>
+                  <a:srgbClr val="FFFFFF"/>
+                </a:solidFill>
+              </a:defRPr>
+            </a:lvl3pPr>
+            <a:lvl4pPr>
+              <a:defRPr sz="1650" b="0">
+                <a:solidFill>
+                  <a:srgbClr val="FFFFFF"/>
+                </a:solidFill>
+              </a:defRPr>
+            </a:lvl4pPr>
+            <a:lvl5pPr>
+              <a:defRPr sz="1650" b="0">
+                <a:solidFill>
+                  <a:srgbClr val="FFFFFF"/>
+                </a:solidFill>
+              </a:defRPr>
+            </a:lvl5pPr>
+            <a:lvl6pPr>
+              <a:defRPr sz="1650" b="0">
+                <a:solidFill>
+                  <a:srgbClr val="FFFFFF"/>
+                </a:solidFill>
+              </a:defRPr>
+            </a:lvl6pPr>
+            <a:lvl7pPr>
+              <a:defRPr sz="1650" b="0">
+                <a:solidFill>
+                  <a:srgbClr val="FFFFFF"/>
+                </a:solidFill>
+              </a:defRPr>
+            </a:lvl7pPr>
+            <a:lvl8pPr>
+              <a:defRPr sz="1650" b="0">
+                <a:solidFill>
+                  <a:srgbClr val="FFFFFF"/>
+                </a:solidFill>
+              </a:defRPr>
+            </a:lvl8pPr>
+            <a:lvl9pPr>
+              <a:defRPr sz="1650" b="0">
+                <a:solidFill>
+                  <a:srgbClr val="FFFFFF"/>
+                </a:solidFill>
+              </a:defRPr>
+            </a:lvl9pPr>
+          </a:lstStyle>
+          <a:p xmlns:a="http://schemas.openxmlformats.org/drawingml/2006/main">
+            <a:pPr>
+              <a:defRPr sz="1650" b="0">
+                <a:solidFill>
+                  <a:srgbClr val="FFFFFF"/>
+                </a:solidFill>
+              </a:defRPr>
+            </a:pPr>
+            <a:r>
+              <a:rPr sz="1650" b="0">
+                <a:solidFill>
+                  <a:srgbClr val="FFFFFF"/>
+                </a:solidFill>
+              </a:rPr>
+              <a:t>Act</a:t>
+            </a:r>
+          </a:p>
+        </p:txBody>
+      </p:sp>
+      <p:sp>
+        <p:nvSpPr>
+          <p:cNvPr id="21" name="reliability">
+            <a:extLst xmlns:a="http://schemas.openxmlformats.org/drawingml/2006/main">
+              <a:ext uri="{FF2B5EF4-FFF2-40B4-BE49-F238E27FC236}">
+                <a16:creationId xmlns:a16="http://schemas.microsoft.com/office/drawing/2014/main" id="{6C22A9F8-ADBE-4745-A33B-08F4D4DC74F2}"/>
+              </a:ext>
+            </a:extLst>
+          </p:cNvPr>
+          <p:cNvSpPr>
+            <a:spLocks xmlns:a="http://schemas.openxmlformats.org/drawingml/2006/main" noGrp="1"/>
+          </p:cNvSpPr>
+          <p:nvPr/>
+        </p:nvSpPr>
+        <p:spPr>
+          <a:xfrm xmlns:a="http://schemas.openxmlformats.org/drawingml/2006/main">
+            <a:off x="609600" y="5800725"/>
+            <a:ext cx="10972800" cy="323850"/>
+          </a:xfrm>
+          <a:prstGeom xmlns:a="http://schemas.openxmlformats.org/drawingml/2006/main" prst="rect">
+            <a:avLst/>
+          </a:prstGeom>
+          <a:noFill xmlns:a="http://schemas.openxmlformats.org/drawingml/2006/main"/>
+          <a:ln xmlns:a="http://schemas.openxmlformats.org/drawingml/2006/main" w="0">
+            <a:noFill/>
+            <a:prstDash val="solid"/>
+          </a:ln>
+        </p:spPr>
+        <p:txBody>
+          <a:bodyPr xmlns:a="http://schemas.openxmlformats.org/drawingml/2006/main" lIns="0" tIns="0" rIns="0" bIns="0"/>
+          <a:lstStyle xmlns:a="http://schemas.openxmlformats.org/drawingml/2006/main">
+            <a:defPPr>
+              <a:defRPr sz="1650" b="1">
+                <a:solidFill>
+                  <a:srgbClr val="FFFFFF"/>
+                </a:solidFill>
+              </a:defRPr>
+            </a:defPPr>
+            <a:lvl1pPr>
+              <a:defRPr sz="1650" b="1">
+                <a:solidFill>
+                  <a:srgbClr val="FFFFFF"/>
+                </a:solidFill>
+              </a:defRPr>
+            </a:lvl1pPr>
+            <a:lvl2pPr>
+              <a:defRPr sz="1650" b="1">
+                <a:solidFill>
+                  <a:srgbClr val="FFFFFF"/>
+                </a:solidFill>
+              </a:defRPr>
+            </a:lvl2pPr>
+            <a:lvl3pPr>
+              <a:defRPr sz="1650" b="1">
+                <a:solidFill>
+                  <a:srgbClr val="FFFFFF"/>
+                </a:solidFill>
+              </a:defRPr>
+            </a:lvl3pPr>
+            <a:lvl4pPr>
+              <a:defRPr sz="1650" b="1">
+                <a:solidFill>
+                  <a:srgbClr val="FFFFFF"/>
+                </a:solidFill>
+              </a:defRPr>
+            </a:lvl4pPr>
+            <a:lvl5pPr>
+              <a:defRPr sz="1650" b="1">
+                <a:solidFill>
+                  <a:srgbClr val="FFFFFF"/>
+                </a:solidFill>
+              </a:defRPr>
+            </a:lvl5pPr>
+            <a:lvl6pPr>
+              <a:defRPr sz="1650" b="1">
+                <a:solidFill>
+                  <a:srgbClr val="FFFFFF"/>
+                </a:solidFill>
+              </a:defRPr>
+            </a:lvl6pPr>
+            <a:lvl7pPr>
+              <a:defRPr sz="1650" b="1">
+                <a:solidFill>
+                  <a:srgbClr val="FFFFFF"/>
+                </a:solidFill>
+              </a:defRPr>
+            </a:lvl7pPr>
+            <a:lvl8pPr>
+              <a:defRPr sz="1650" b="1">
+                <a:solidFill>
+                  <a:srgbClr val="FFFFFF"/>
+                </a:solidFill>
+              </a:defRPr>
+            </a:lvl8pPr>
+            <a:lvl9pPr>
+              <a:defRPr sz="1650" b="1">
+                <a:solidFill>
+                  <a:srgbClr val="FFFFFF"/>
+                </a:solidFill>
+              </a:defRPr>
+            </a:lvl9pPr>
+          </a:lstStyle>
+          <a:p xmlns:a="http://schemas.openxmlformats.org/drawingml/2006/main">
+            <a:pPr>
+              <a:defRPr sz="1650" b="1">
+                <a:solidFill>
+                  <a:srgbClr val="FFFFFF"/>
+                </a:solidFill>
+              </a:defRPr>
+            </a:pPr>
+            <a:r>
+              <a:rPr sz="1650" b="1">
+                <a:solidFill>
+                  <a:srgbClr val="FFFFFF"/>
+                </a:solidFill>
+              </a:rPr>
+              <a:t>Tested rules support repeatability. Predictable results and costs can build trust.</a:t>
+            </a:r>
+          </a:p>
+        </p:txBody>
+      </p:sp>
+      <p:sp>
+        <p:nvSpPr>
+          <p:cNvPr id="22" name="assumptions">
+            <a:extLst xmlns:a="http://schemas.openxmlformats.org/drawingml/2006/main">
+              <a:ext uri="{FF2B5EF4-FFF2-40B4-BE49-F238E27FC236}">
+                <a16:creationId xmlns:a16="http://schemas.microsoft.com/office/drawing/2014/main" id="{C0603458-AD87-4615-8964-C926EEC51CD5}"/>
+              </a:ext>
+            </a:extLst>
+          </p:cNvPr>
+          <p:cNvSpPr>
+            <a:spLocks xmlns:a="http://schemas.openxmlformats.org/drawingml/2006/main" noGrp="1"/>
+          </p:cNvSpPr>
+          <p:nvPr/>
+        </p:nvSpPr>
+        <p:spPr>
+          <a:xfrm xmlns:a="http://schemas.openxmlformats.org/drawingml/2006/main">
+            <a:off x="609600" y="6257925"/>
+            <a:ext cx="10572750" cy="238125"/>
+          </a:xfrm>
+          <a:prstGeom xmlns:a="http://schemas.openxmlformats.org/drawingml/2006/main" prst="rect">
+            <a:avLst/>
+          </a:prstGeom>
+          <a:noFill xmlns:a="http://schemas.openxmlformats.org/drawingml/2006/main"/>
+          <a:ln xmlns:a="http://schemas.openxmlformats.org/drawingml/2006/main" w="0">
+            <a:noFill/>
+            <a:prstDash val="solid"/>
+          </a:ln>
+        </p:spPr>
+        <p:txBody>
+          <a:bodyPr xmlns:a="http://schemas.openxmlformats.org/drawingml/2006/main" lIns="0" tIns="0" rIns="0" bIns="0"/>
+          <a:lstStyle xmlns:a="http://schemas.openxmlformats.org/drawingml/2006/main">
+            <a:defPPr>
+              <a:defRPr sz="1275" b="0">
+                <a:solidFill>
+                  <a:srgbClr val="FFFFFF"/>
+                </a:solidFill>
+              </a:defRPr>
+            </a:defPPr>
+            <a:lvl1pPr>
+              <a:defRPr sz="1275" b="0">
+                <a:solidFill>
+                  <a:srgbClr val="FFFFFF"/>
+                </a:solidFill>
+              </a:defRPr>
+            </a:lvl1pPr>
+            <a:lvl2pPr>
+              <a:defRPr sz="1275" b="0">
+                <a:solidFill>
+                  <a:srgbClr val="FFFFFF"/>
+                </a:solidFill>
+              </a:defRPr>
+            </a:lvl2pPr>
+            <a:lvl3pPr>
+              <a:defRPr sz="1275" b="0">
+                <a:solidFill>
+                  <a:srgbClr val="FFFFFF"/>
+                </a:solidFill>
+              </a:defRPr>
+            </a:lvl3pPr>
+            <a:lvl4pPr>
+              <a:defRPr sz="1275" b="0">
+                <a:solidFill>
+                  <a:srgbClr val="FFFFFF"/>
+                </a:solidFill>
+              </a:defRPr>
+            </a:lvl4pPr>
+            <a:lvl5pPr>
+              <a:defRPr sz="1275" b="0">
+                <a:solidFill>
+                  <a:srgbClr val="FFFFFF"/>
+                </a:solidFill>
+              </a:defRPr>
+            </a:lvl5pPr>
+            <a:lvl6pPr>
+              <a:defRPr sz="1275" b="0">
+                <a:solidFill>
+                  <a:srgbClr val="FFFFFF"/>
+                </a:solidFill>
+              </a:defRPr>
+            </a:lvl6pPr>
+            <a:lvl7pPr>
+              <a:defRPr sz="1275" b="0">
+                <a:solidFill>
+                  <a:srgbClr val="FFFFFF"/>
+                </a:solidFill>
+              </a:defRPr>
+            </a:lvl7pPr>
+            <a:lvl8pPr>
+              <a:defRPr sz="1275" b="0">
+                <a:solidFill>
+                  <a:srgbClr val="FFFFFF"/>
+                </a:solidFill>
+              </a:defRPr>
+            </a:lvl8pPr>
+            <a:lvl9pPr>
+              <a:defRPr sz="1275" b="0">
+                <a:solidFill>
+                  <a:srgbClr val="FFFFFF"/>
+                </a:solidFill>
+              </a:defRPr>
+            </a:lvl9pPr>
+          </a:lstStyle>
+          <a:p xmlns:a="http://schemas.openxmlformats.org/drawingml/2006/main">
+            <a:pPr>
+              <a:defRPr sz="1275" b="0">
+                <a:solidFill>
+                  <a:srgbClr val="FFFFFF"/>
+                </a:solidFill>
+              </a:defRPr>
+            </a:pPr>
+            <a:r>
+              <a:rPr sz="1275" b="0">
+                <a:solidFill>
+                  <a:srgbClr val="FFFFFF"/>
+                </a:solidFill>
+              </a:rPr>
+              <a:t>Cost model: 100 = 70 fixed + 30 LLM. Replace 60% of LLM spend, add 3 execution units: total 85.</a:t>
+            </a:r>
+          </a:p>
+        </p:txBody>
+      </p:sp>
+      <p:sp>
+        <p:nvSpPr>
+          <p:cNvPr id="23" name="disclosure">
+            <a:extLst xmlns:a="http://schemas.openxmlformats.org/drawingml/2006/main">
+              <a:ext uri="{FF2B5EF4-FFF2-40B4-BE49-F238E27FC236}">
+                <a16:creationId xmlns:a16="http://schemas.microsoft.com/office/drawing/2014/main" id="{EB829550-C1EF-446A-9ECE-C8D47EE0B513}"/>
+              </a:ext>
+            </a:extLst>
+          </p:cNvPr>
+          <p:cNvSpPr>
+            <a:spLocks xmlns:a="http://schemas.openxmlformats.org/drawingml/2006/main" noGrp="1"/>
+          </p:cNvSpPr>
+          <p:nvPr/>
+        </p:nvSpPr>
+        <p:spPr>
+          <a:xfrm xmlns:a="http://schemas.openxmlformats.org/drawingml/2006/main">
+            <a:off x="609600" y="6534150"/>
+            <a:ext cx="10572750" cy="228600"/>
+          </a:xfrm>
+          <a:prstGeom xmlns:a="http://schemas.openxmlformats.org/drawingml/2006/main" prst="rect">
+            <a:avLst/>
+          </a:prstGeom>
+          <a:noFill xmlns:a="http://schemas.openxmlformats.org/drawingml/2006/main"/>
+          <a:ln xmlns:a="http://schemas.openxmlformats.org/drawingml/2006/main" w="0">
+            <a:noFill/>
+            <a:prstDash val="solid"/>
+          </a:ln>
+        </p:spPr>
+        <p:txBody>
+          <a:bodyPr xmlns:a="http://schemas.openxmlformats.org/drawingml/2006/main" lIns="0" tIns="0" rIns="0" bIns="0"/>
+          <a:lstStyle xmlns:a="http://schemas.openxmlformats.org/drawingml/2006/main">
+            <a:defPPr>
+              <a:defRPr sz="1200" b="0">
+                <a:solidFill>
+                  <a:srgbClr val="FFFFFF"/>
+                </a:solidFill>
+              </a:defRPr>
+            </a:defPPr>
+            <a:lvl1pPr>
+              <a:defRPr sz="1200" b="0">
+                <a:solidFill>
+                  <a:srgbClr val="FFFFFF"/>
+                </a:solidFill>
+              </a:defRPr>
+            </a:lvl1pPr>
+            <a:lvl2pPr>
+              <a:defRPr sz="1200" b="0">
+                <a:solidFill>
+                  <a:srgbClr val="FFFFFF"/>
+                </a:solidFill>
+              </a:defRPr>
+            </a:lvl2pPr>
+            <a:lvl3pPr>
+              <a:defRPr sz="1200" b="0">
+                <a:solidFill>
+                  <a:srgbClr val="FFFFFF"/>
+                </a:solidFill>
+              </a:defRPr>
+            </a:lvl3pPr>
+            <a:lvl4pPr>
+              <a:defRPr sz="1200" b="0">
+                <a:solidFill>
+                  <a:srgbClr val="FFFFFF"/>
+                </a:solidFill>
+              </a:defRPr>
+            </a:lvl4pPr>
+            <a:lvl5pPr>
+              <a:defRPr sz="1200" b="0">
+                <a:solidFill>
+                  <a:srgbClr val="FFFFFF"/>
+                </a:solidFill>
+              </a:defRPr>
+            </a:lvl5pPr>
+            <a:lvl6pPr>
+              <a:defRPr sz="1200" b="0">
+                <a:solidFill>
+                  <a:srgbClr val="FFFFFF"/>
+                </a:solidFill>
+              </a:defRPr>
+            </a:lvl6pPr>
+            <a:lvl7pPr>
+              <a:defRPr sz="1200" b="0">
+                <a:solidFill>
+                  <a:srgbClr val="FFFFFF"/>
+                </a:solidFill>
+              </a:defRPr>
+            </a:lvl7pPr>
+            <a:lvl8pPr>
+              <a:defRPr sz="1200" b="0">
+                <a:solidFill>
+                  <a:srgbClr val="FFFFFF"/>
+                </a:solidFill>
+              </a:defRPr>
+            </a:lvl8pPr>
+            <a:lvl9pPr>
+              <a:defRPr sz="1200" b="0">
+                <a:solidFill>
+                  <a:srgbClr val="FFFFFF"/>
+                </a:solidFill>
+              </a:defRPr>
+            </a:lvl9pPr>
+          </a:lstStyle>
+          <a:p xmlns:a="http://schemas.openxmlformats.org/drawingml/2006/main">
+            <a:pPr>
+              <a:defRPr sz="1200" b="0">
+                <a:solidFill>
+                  <a:srgbClr val="FFFFFF"/>
+                </a:solidFill>
+              </a:defRPr>
+            </a:pPr>
+            <a:r>
+              <a:rPr sz="1200" b="0">
+                <a:solidFill>
+                  <a:srgbClr val="FFFFFF"/>
+                </a:solidFill>
+              </a:rPr>
+              <a:t>Illustrative assumptions, not measured results. Capability count describes scope, not an intelligence score.</a:t>
             </a:r>
           </a:p>
         </p:txBody>

</xml_diff>

<commit_message>
Expand impact and feasibility with cost breakdown and MVP rationale
</commit_message>
<xml_diff>
--- a/submission/SpitchAI-Build-Arena-Submission.pptx
+++ b/submission/SpitchAI-Build-Arena-Submission.pptx
@@ -2,19 +2,19 @@
 <file path=ppt/presentation.xml><?xml version="1.0" encoding="utf-8"?>
 <p:presentation xmlns:p="http://schemas.openxmlformats.org/presentationml/2006/main">
   <p:sldMasterIdLst>
-    <p:sldMasterId xmlns:r="http://schemas.openxmlformats.org/officeDocument/2006/relationships" id="2147483648" r:id="R6192e1055631417d"/>
+    <p:sldMasterId xmlns:r="http://schemas.openxmlformats.org/officeDocument/2006/relationships" id="2147483648" r:id="R073e161855fc430c"/>
   </p:sldMasterIdLst>
   <p:notesMasterIdLst>
-    <p:notesMasterId xmlns:r="http://schemas.openxmlformats.org/officeDocument/2006/relationships" r:id="R881c680e45ac43ec"/>
+    <p:notesMasterId xmlns:r="http://schemas.openxmlformats.org/officeDocument/2006/relationships" r:id="R78e91ea9cec14f52"/>
   </p:notesMasterIdLst>
   <p:sldIdLst>
-    <p:sldId xmlns:r="http://schemas.openxmlformats.org/officeDocument/2006/relationships" id="256" r:id="R0ae7542d1843429a"/>
-    <p:sldId xmlns:r="http://schemas.openxmlformats.org/officeDocument/2006/relationships" id="257" r:id="R9bd8d61c055243ac"/>
-    <p:sldId xmlns:r="http://schemas.openxmlformats.org/officeDocument/2006/relationships" id="258" r:id="Re2fa3ed688514acb"/>
-    <p:sldId xmlns:r="http://schemas.openxmlformats.org/officeDocument/2006/relationships" id="259" r:id="R7bf1d11a4f0c4da8"/>
-    <p:sldId xmlns:r="http://schemas.openxmlformats.org/officeDocument/2006/relationships" id="260" r:id="R291e62ce2a4540c8"/>
-    <p:sldId xmlns:r="http://schemas.openxmlformats.org/officeDocument/2006/relationships" id="261" r:id="Rb236e0483f174364"/>
-    <p:sldId xmlns:r="http://schemas.openxmlformats.org/officeDocument/2006/relationships" id="262" r:id="Re23fb469543043af"/>
+    <p:sldId xmlns:r="http://schemas.openxmlformats.org/officeDocument/2006/relationships" id="256" r:id="R8ca0b741570742c3"/>
+    <p:sldId xmlns:r="http://schemas.openxmlformats.org/officeDocument/2006/relationships" id="257" r:id="R4ff9796e39d94fe6"/>
+    <p:sldId xmlns:r="http://schemas.openxmlformats.org/officeDocument/2006/relationships" id="258" r:id="Rd4704d83c3f8459a"/>
+    <p:sldId xmlns:r="http://schemas.openxmlformats.org/officeDocument/2006/relationships" id="259" r:id="Rfb33e9076b4e4755"/>
+    <p:sldId xmlns:r="http://schemas.openxmlformats.org/officeDocument/2006/relationships" id="260" r:id="R5bc40fdf263341a9"/>
+    <p:sldId xmlns:r="http://schemas.openxmlformats.org/officeDocument/2006/relationships" id="261" r:id="Rd5e72a5c93ce46c6"/>
+    <p:sldId xmlns:r="http://schemas.openxmlformats.org/officeDocument/2006/relationships" id="262" r:id="R14be0d4b9f5a4941"/>
   </p:sldIdLst>
   <p:sldSz cx="12192000" cy="6858000"/>
   <p:notesSz cx="6858000" cy="9144000"/>
@@ -798,7 +798,7 @@
           <a:lstStyle xmlns:a="http://schemas.openxmlformats.org/drawingml/2006/main"/>
           <a:p xmlns:a="http://schemas.openxmlformats.org/drawingml/2006/main">
             <a:r>
-              <a:t>Illustrative planning model, not a product benchmark or market statistic. Baseline normalized total usage cost = 100 units: 70 units fixed voice/transport/other costs plus 30 units for repeated LLM reasoning. Assume supported deterministic operations replace 60% of the LLM spend, leaving 12 units, while incremental execution costs add 3 units. Compiled total = 70+12+3=85, so saving = (100-85)/100 = 15%. These are explicit assumed cost shares, not current provider prices. Savings vary by task mix, call length, token usage, model, deployment and module cost, and could be lower or negative. The four planned capability types are interpretation, calculation, validation and external action. This illustrates a configured agent with broader executable scope, not four times greater intelligence or a claim that competitors lack these tools. Tested deterministic computations can support repeatability, but input interpretation and generation remain probabilistic and tools can fail. Trust and adoption remain hypotheses for user testing. Initial feasibility comes from curated modules and task expressions on a shared runtime.</a:t>
+              <a:t>Impact estimate uses an illustrative normalized cost model. Baseline is 100: 70 fixed voice/transport/other units plus 30 repeated LLM reasoning units. Assume supported deterministic computations replace 60% of the LLM reasoning spend, leaving 12 units, and execution adds 3 units. New total is 70+12+3=85, or 15% lower than the assumed baseline. No measured results or provider prices are claimed. Actual savings depend on the workload, token usage, voice length, model and tool costs and could be lower or negative. Four capability types illustrate product scope: interpretation, deterministic computation, validation and authorized external action. This is not an intelligence score or a claim that competing platforms cannot use tools. For tested supported operations, the same input and module version should reproduce the computation. LLM planning remains probabilistic and external integrations can fail. Adoption through predictable results and visible traces remains a user-testing hypothesis. Initial feasibility relies on a curated module catalog, typed input/output contracts, reference cases and a shared runtime. Full platform scope also includes the ElevenLabs conversation, web publication, session traces and phone integration or the permitted documented simulation.</a:t>
             </a:r>
           </a:p>
         </p:txBody>
@@ -3311,12 +3311,12 @@
   </p:cSld>
   <p:clrMap bg1="lt1" tx1="dk1" bg2="lt2" tx2="dk2" accent1="accent1" accent2="accent2" accent3="accent3" accent4="accent4" accent5="accent5" accent6="accent6" hlink="hlink" folHlink="folHlink"/>
   <p:sldLayoutIdLst>
-    <p:sldLayoutId xmlns:r="http://schemas.openxmlformats.org/officeDocument/2006/relationships" id="2147483649" r:id="R459b440391a94e17"/>
-    <p:sldLayoutId xmlns:r="http://schemas.openxmlformats.org/officeDocument/2006/relationships" id="2147483650" r:id="R3bd8ad80cca24167"/>
-    <p:sldLayoutId xmlns:r="http://schemas.openxmlformats.org/officeDocument/2006/relationships" id="2147483651" r:id="R00e79dfa21a34aeb"/>
-    <p:sldLayoutId xmlns:r="http://schemas.openxmlformats.org/officeDocument/2006/relationships" id="2147483652" r:id="R9f8a0f485cb447ec"/>
-    <p:sldLayoutId xmlns:r="http://schemas.openxmlformats.org/officeDocument/2006/relationships" id="2147483653" r:id="Rb03f5a6610084ab4"/>
-    <p:sldLayoutId xmlns:r="http://schemas.openxmlformats.org/officeDocument/2006/relationships" id="2147483654" r:id="R2247f99c84454601"/>
+    <p:sldLayoutId xmlns:r="http://schemas.openxmlformats.org/officeDocument/2006/relationships" id="2147483649" r:id="R7d0866634e044551"/>
+    <p:sldLayoutId xmlns:r="http://schemas.openxmlformats.org/officeDocument/2006/relationships" id="2147483650" r:id="R6a5c802b1da24a92"/>
+    <p:sldLayoutId xmlns:r="http://schemas.openxmlformats.org/officeDocument/2006/relationships" id="2147483651" r:id="Rf15877ff0ae846fc"/>
+    <p:sldLayoutId xmlns:r="http://schemas.openxmlformats.org/officeDocument/2006/relationships" id="2147483652" r:id="R4a53a005f0ca43df"/>
+    <p:sldLayoutId xmlns:r="http://schemas.openxmlformats.org/officeDocument/2006/relationships" id="2147483653" r:id="R5dbe4d9075a14ac9"/>
+    <p:sldLayoutId xmlns:r="http://schemas.openxmlformats.org/officeDocument/2006/relationships" id="2147483654" r:id="Rc9b4d0b7bf9b4320"/>
   </p:sldLayoutIdLst>
   <p:txStyles>
     <p:titleStyle>
@@ -3850,17 +3850,17 @@
     <c:plotArea>
       <c:barChart>
         <c:barDir val="bar"/>
-        <c:grouping val="clustered"/>
+        <c:grouping val="stacked"/>
         <c:varyColors val="0"/>
         <c:ser>
           <c:idx val="0"/>
           <c:order val="0"/>
           <c:tx>
-            <c:v>Total cost index</c:v>
+            <c:v>Fixed</c:v>
           </c:tx>
           <c:spPr>
             <a:solidFill xmlns:a="http://schemas.openxmlformats.org/drawingml/2006/main">
-              <a:srgbClr val="FFFFFF"/>
+              <a:srgbClr val="D6D2C9"/>
             </a:solidFill>
           </c:spPr>
           <c:invertIfNegative val="0"/>
@@ -3880,38 +3880,97 @@
               <c:formatCode>General</c:formatCode>
               <c:ptCount val="2"/>
               <c:pt idx="0">
-                <c:v>100</c:v>
+                <c:v>70</c:v>
               </c:pt>
               <c:pt idx="1">
-                <c:v>85</c:v>
+                <c:v>70</c:v>
+              </c:pt>
+            </c:numLit>
+          </c:val>
+        </c:ser>
+        <c:ser>
+          <c:idx val="1"/>
+          <c:order val="1"/>
+          <c:tx>
+            <c:v>LLM reasoning</c:v>
+          </c:tx>
+          <c:spPr>
+            <a:solidFill xmlns:a="http://schemas.openxmlformats.org/drawingml/2006/main">
+              <a:srgbClr val="111111"/>
+            </a:solidFill>
+          </c:spPr>
+          <c:invertIfNegative val="0"/>
+          <c:cat>
+            <c:strLit>
+              <c:ptCount val="2"/>
+              <c:pt idx="0">
+                <c:v>Baseline</c:v>
+              </c:pt>
+              <c:pt idx="1">
+                <c:v>Compiled</c:v>
+              </c:pt>
+            </c:strLit>
+          </c:cat>
+          <c:val>
+            <c:numLit>
+              <c:formatCode>General</c:formatCode>
+              <c:ptCount val="2"/>
+              <c:pt idx="0">
+                <c:v>30</c:v>
+              </c:pt>
+              <c:pt idx="1">
+                <c:v>12</c:v>
+              </c:pt>
+            </c:numLit>
+          </c:val>
+        </c:ser>
+        <c:ser>
+          <c:idx val="2"/>
+          <c:order val="2"/>
+          <c:tx>
+            <c:v>Execution</c:v>
+          </c:tx>
+          <c:spPr>
+            <a:solidFill xmlns:a="http://schemas.openxmlformats.org/drawingml/2006/main">
+              <a:srgbClr val="F25037"/>
+            </a:solidFill>
+          </c:spPr>
+          <c:invertIfNegative val="0"/>
+          <c:cat>
+            <c:strLit>
+              <c:ptCount val="2"/>
+              <c:pt idx="0">
+                <c:v>Baseline</c:v>
+              </c:pt>
+              <c:pt idx="1">
+                <c:v>Compiled</c:v>
+              </c:pt>
+            </c:strLit>
+          </c:cat>
+          <c:val>
+            <c:numLit>
+              <c:formatCode>General</c:formatCode>
+              <c:ptCount val="2"/>
+              <c:pt idx="0">
+                <c:v>0</c:v>
+              </c:pt>
+              <c:pt idx="1">
+                <c:v>3</c:v>
               </c:pt>
             </c:numLit>
           </c:val>
         </c:ser>
         <c:dLbls>
-          <c:txPr>
-            <a:bodyPr xmlns:a="http://schemas.openxmlformats.org/drawingml/2006/main" anchorCtr="1"/>
-            <a:lstStyle xmlns:a="http://schemas.openxmlformats.org/drawingml/2006/main"/>
-            <a:p xmlns:a="http://schemas.openxmlformats.org/drawingml/2006/main">
-              <a:pPr>
-                <a:defRPr sz="1500" b="1">
-                  <a:solidFill>
-                    <a:srgbClr val="FFFFFF"/>
-                  </a:solidFill>
-                </a:defRPr>
-              </a:pPr>
-            </a:p>
-          </c:txPr>
-          <c:dLblPos val="outEnd"/>
           <c:showLegendKey val="0"/>
-          <c:showVal val="1"/>
+          <c:showVal val="0"/>
           <c:showCatName val="0"/>
           <c:showSerName val="0"/>
           <c:showPercent val="0"/>
           <c:showBubbleSize val="0"/>
           <c:showLeaderLines val="0"/>
         </c:dLbls>
-        <c:gapWidth val="85"/>
+        <c:gapWidth val="70"/>
+        <c:overlap val="100"/>
         <c:axId val="48650112"/>
         <c:axId val="48672768"/>
       </c:barChart>
@@ -3936,9 +3995,9 @@
           <a:lstStyle xmlns:a="http://schemas.openxmlformats.org/drawingml/2006/main"/>
           <a:p xmlns:a="http://schemas.openxmlformats.org/drawingml/2006/main">
             <a:pPr>
-              <a:defRPr sz="1500">
-                <a:solidFill>
-                  <a:srgbClr val="FFFFFF"/>
+              <a:defRPr sz="1425">
+                <a:solidFill>
+                  <a:srgbClr val="111111"/>
                 </a:solidFill>
               </a:defRPr>
             </a:pPr>
@@ -3950,7 +4009,7 @@
         <c:axId val="48672768"/>
         <c:scaling>
           <c:orientation val="minMax"/>
-          <c:max val="115"/>
+          <c:max val="105"/>
           <c:min val="0"/>
         </c:scaling>
         <c:delete val="1"/>
@@ -3984,7 +4043,7 @@
       </c:valAx>
       <c:spPr>
         <a:solidFill xmlns:a="http://schemas.openxmlformats.org/drawingml/2006/main">
-          <a:srgbClr val="F25037"/>
+          <a:srgbClr val="F7F6F2"/>
         </a:solidFill>
         <a:ln xmlns:a="http://schemas.openxmlformats.org/drawingml/2006/main" w="0">
           <a:noFill/>
@@ -3992,11 +4051,28 @@
         </a:ln>
       </c:spPr>
     </c:plotArea>
+    <c:legend>
+      <c:legendPos val="b"/>
+      <c:overlay val="0"/>
+      <c:txPr>
+        <a:bodyPr xmlns:a="http://schemas.openxmlformats.org/drawingml/2006/main" anchorCtr="1"/>
+        <a:lstStyle xmlns:a="http://schemas.openxmlformats.org/drawingml/2006/main"/>
+        <a:p xmlns:a="http://schemas.openxmlformats.org/drawingml/2006/main">
+          <a:pPr>
+            <a:defRPr sz="1125">
+              <a:solidFill>
+                <a:srgbClr val="646464"/>
+              </a:solidFill>
+            </a:defRPr>
+          </a:pPr>
+        </a:p>
+      </c:txPr>
+    </c:legend>
     <c:plotVisOnly val="1"/>
   </c:chart>
   <c:spPr>
     <a:solidFill xmlns:a="http://schemas.openxmlformats.org/drawingml/2006/main">
-      <a:srgbClr val="F25037"/>
+      <a:srgbClr val="F7F6F2"/>
     </a:solidFill>
     <a:ln xmlns:a="http://schemas.openxmlformats.org/drawingml/2006/main" w="0">
       <a:noFill/>
@@ -4199,7 +4275,7 @@
           <p:nvPr/>
         </p:nvPicPr>
         <p:blipFill>
-          <a:blip xmlns:r="http://schemas.openxmlformats.org/officeDocument/2006/relationships" xmlns:a="http://schemas.openxmlformats.org/drawingml/2006/main" r:embed="R8fffbc5d884646fb"/>
+          <a:blip xmlns:r="http://schemas.openxmlformats.org/officeDocument/2006/relationships" xmlns:a="http://schemas.openxmlformats.org/drawingml/2006/main" r:embed="R77f460c3cfe14c72"/>
           <a:stretch xmlns:a="http://schemas.openxmlformats.org/drawingml/2006/main"/>
         </p:blipFill>
         <p:spPr>
@@ -4909,7 +4985,7 @@
           <p:nvPr/>
         </p:nvPicPr>
         <p:blipFill>
-          <a:blip xmlns:r="http://schemas.openxmlformats.org/officeDocument/2006/relationships" xmlns:a="http://schemas.openxmlformats.org/drawingml/2006/main" r:embed="R1fdc74750ac64d18"/>
+          <a:blip xmlns:r="http://schemas.openxmlformats.org/officeDocument/2006/relationships" xmlns:a="http://schemas.openxmlformats.org/drawingml/2006/main" r:embed="R7a173cbe8500428d"/>
           <a:stretch xmlns:a="http://schemas.openxmlformats.org/drawingml/2006/main"/>
         </p:blipFill>
         <p:spPr>
@@ -12925,7 +13001,7 @@
           <p:nvPr/>
         </p:nvPicPr>
         <p:blipFill>
-          <a:blip xmlns:r="http://schemas.openxmlformats.org/officeDocument/2006/relationships" xmlns:a="http://schemas.openxmlformats.org/drawingml/2006/main" r:embed="R5a0f2e393e814273"/>
+          <a:blip xmlns:r="http://schemas.openxmlformats.org/officeDocument/2006/relationships" xmlns:a="http://schemas.openxmlformats.org/drawingml/2006/main" r:embed="R5908492488344ccb"/>
           <a:stretch xmlns:a="http://schemas.openxmlformats.org/drawingml/2006/main"/>
         </p:blipFill>
         <p:spPr>
@@ -13112,10 +13188,10 @@
           <p:nvPr/>
         </p:nvPicPr>
         <p:blipFill>
-          <a:blip xmlns:r="http://schemas.openxmlformats.org/officeDocument/2006/relationships" xmlns:a="http://schemas.openxmlformats.org/drawingml/2006/main" r:embed="Rc76b97e2b4c24df2">
+          <a:blip xmlns:r="http://schemas.openxmlformats.org/officeDocument/2006/relationships" xmlns:a="http://schemas.openxmlformats.org/drawingml/2006/main" r:embed="R204da5e925cf4c33">
             <a:extLst>
               <a:ext uri="{96DAC541-7B7A-43D3-8B79-37D633B846F1}">
-                <asvg:svgBlip xmlns:asvg="http://schemas.microsoft.com/office/drawing/2016/SVG/main" r:embed="R676b5b3a09f44359"/>
+                <asvg:svgBlip xmlns:asvg="http://schemas.microsoft.com/office/drawing/2016/SVG/main" r:embed="R12dd7d7d05084bf3"/>
               </a:ext>
             </a:extLst>
           </a:blip>
@@ -13146,7 +13222,7 @@
           <p:nvPr/>
         </p:nvPicPr>
         <p:blipFill>
-          <a:blip xmlns:r="http://schemas.openxmlformats.org/officeDocument/2006/relationships" xmlns:a="http://schemas.openxmlformats.org/drawingml/2006/main" r:embed="R4f96cb04749d4bc0"/>
+          <a:blip xmlns:r="http://schemas.openxmlformats.org/officeDocument/2006/relationships" xmlns:a="http://schemas.openxmlformats.org/drawingml/2006/main" r:embed="R798390823184461d"/>
           <a:stretch xmlns:a="http://schemas.openxmlformats.org/drawingml/2006/main"/>
         </p:blipFill>
         <p:spPr>
@@ -16476,7 +16552,7 @@
     <p:bg>
       <p:bgPr>
         <a:solidFill xmlns:a="http://schemas.openxmlformats.org/drawingml/2006/main">
-          <a:srgbClr val="F25037"/>
+          <a:srgbClr val="F7F6F2"/>
         </a:solidFill>
       </p:bgPr>
     </p:bg>
@@ -16494,29 +16570,27 @@
           <p:cNvPr id="2" name="">
             <a:extLst xmlns:a="http://schemas.openxmlformats.org/drawingml/2006/main">
               <a:ext uri="{FF2B5EF4-FFF2-40B4-BE49-F238E27FC236}">
-                <a16:creationId xmlns:a16="http://schemas.microsoft.com/office/drawing/2014/main" id="{7C574315-6C9C-4274-8410-81E121AB35FB}"/>
+                <a16:creationId xmlns:a16="http://schemas.microsoft.com/office/drawing/2014/main" id="{ECB74B17-5235-4C38-A8A8-7B463134F021}"/>
               </a:ext>
             </a:extLst>
           </p:cNvPr>
           <p:cNvCxnSpPr>
-            <a:stCxn xmlns:a="http://schemas.openxmlformats.org/drawingml/2006/main" id="13" idx="3"/>
-            <a:endCxn xmlns:a="http://schemas.openxmlformats.org/drawingml/2006/main" id="19" idx="1"/>
+            <a:stCxn xmlns:a="http://schemas.openxmlformats.org/drawingml/2006/main" id="20" idx="3"/>
+            <a:endCxn xmlns:a="http://schemas.openxmlformats.org/drawingml/2006/main" id="23" idx="1"/>
           </p:cNvCxnSpPr>
           <p:nvPr/>
         </p:nvCxnSpPr>
         <p:spPr>
           <a:xfrm xmlns:a="http://schemas.openxmlformats.org/drawingml/2006/main">
-            <a:off x="8382000" y="4795838"/>
-            <a:ext cx="1143000" cy="795338"/>
+            <a:off x="10191750" y="3190875"/>
+            <a:ext cx="285750" cy="0"/>
           </a:xfrm>
-          <a:prstGeom xmlns:a="http://schemas.openxmlformats.org/drawingml/2006/main" prst="bentConnector3">
-            <a:avLst>
-              <a:gd name="adj1" fmla="val 50000"/>
-            </a:avLst>
+          <a:prstGeom xmlns:a="http://schemas.openxmlformats.org/drawingml/2006/main" prst="straightConnector1">
+            <a:avLst/>
           </a:prstGeom>
-          <a:ln xmlns:a="http://schemas.openxmlformats.org/drawingml/2006/main" w="14288">
+          <a:ln xmlns:a="http://schemas.openxmlformats.org/drawingml/2006/main" w="11430">
             <a:solidFill>
-              <a:srgbClr val="FFFFFF"/>
+              <a:srgbClr val="AAA69D"/>
             </a:solidFill>
             <a:prstDash val="solid"/>
             <a:tailEnd type="arrow" w="sm" len="sm"/>
@@ -16528,29 +16602,27 @@
           <p:cNvPr id="3" name="">
             <a:extLst xmlns:a="http://schemas.openxmlformats.org/drawingml/2006/main">
               <a:ext uri="{FF2B5EF4-FFF2-40B4-BE49-F238E27FC236}">
-                <a16:creationId xmlns:a16="http://schemas.microsoft.com/office/drawing/2014/main" id="{EA4F93F5-F0AC-495A-B863-B3F043F721A5}"/>
+                <a16:creationId xmlns:a16="http://schemas.microsoft.com/office/drawing/2014/main" id="{2DE459C1-92E4-4F68-BF52-2F6BA25CB46A}"/>
               </a:ext>
             </a:extLst>
           </p:cNvPr>
           <p:cNvCxnSpPr>
-            <a:stCxn xmlns:a="http://schemas.openxmlformats.org/drawingml/2006/main" id="13" idx="3"/>
-            <a:endCxn xmlns:a="http://schemas.openxmlformats.org/drawingml/2006/main" id="17" idx="1"/>
+            <a:stCxn xmlns:a="http://schemas.openxmlformats.org/drawingml/2006/main" id="17" idx="3"/>
+            <a:endCxn xmlns:a="http://schemas.openxmlformats.org/drawingml/2006/main" id="20" idx="1"/>
           </p:cNvCxnSpPr>
           <p:nvPr/>
         </p:nvCxnSpPr>
         <p:spPr>
           <a:xfrm xmlns:a="http://schemas.openxmlformats.org/drawingml/2006/main">
-            <a:off x="8382000" y="4795838"/>
-            <a:ext cx="1143000" cy="185738"/>
+            <a:off x="8820150" y="3190875"/>
+            <a:ext cx="285750" cy="0"/>
           </a:xfrm>
-          <a:prstGeom xmlns:a="http://schemas.openxmlformats.org/drawingml/2006/main" prst="bentConnector3">
-            <a:avLst>
-              <a:gd name="adj1" fmla="val 50000"/>
-            </a:avLst>
+          <a:prstGeom xmlns:a="http://schemas.openxmlformats.org/drawingml/2006/main" prst="straightConnector1">
+            <a:avLst/>
           </a:prstGeom>
-          <a:ln xmlns:a="http://schemas.openxmlformats.org/drawingml/2006/main" w="14288">
+          <a:ln xmlns:a="http://schemas.openxmlformats.org/drawingml/2006/main" w="11430">
             <a:solidFill>
-              <a:srgbClr val="FFFFFF"/>
+              <a:srgbClr val="AAA69D"/>
             </a:solidFill>
             <a:prstDash val="solid"/>
             <a:tailEnd type="arrow" w="sm" len="sm"/>
@@ -16562,29 +16634,27 @@
           <p:cNvPr id="4" name="">
             <a:extLst xmlns:a="http://schemas.openxmlformats.org/drawingml/2006/main">
               <a:ext uri="{FF2B5EF4-FFF2-40B4-BE49-F238E27FC236}">
-                <a16:creationId xmlns:a16="http://schemas.microsoft.com/office/drawing/2014/main" id="{160765C2-3095-4E7A-8C7C-BA7304D151F8}"/>
+                <a16:creationId xmlns:a16="http://schemas.microsoft.com/office/drawing/2014/main" id="{888E0384-1067-4910-A21F-885834953BEC}"/>
               </a:ext>
             </a:extLst>
           </p:cNvPr>
           <p:cNvCxnSpPr>
-            <a:stCxn xmlns:a="http://schemas.openxmlformats.org/drawingml/2006/main" id="13" idx="3"/>
-            <a:endCxn xmlns:a="http://schemas.openxmlformats.org/drawingml/2006/main" id="15" idx="1"/>
+            <a:stCxn xmlns:a="http://schemas.openxmlformats.org/drawingml/2006/main" id="14" idx="3"/>
+            <a:endCxn xmlns:a="http://schemas.openxmlformats.org/drawingml/2006/main" id="17" idx="1"/>
           </p:cNvCxnSpPr>
           <p:nvPr/>
         </p:nvCxnSpPr>
         <p:spPr>
-          <a:xfrm xmlns:a="http://schemas.openxmlformats.org/drawingml/2006/main" flipV="1">
-            <a:off x="8382000" y="4371975"/>
-            <a:ext cx="1143000" cy="423863"/>
+          <a:xfrm xmlns:a="http://schemas.openxmlformats.org/drawingml/2006/main">
+            <a:off x="7448550" y="3190875"/>
+            <a:ext cx="285750" cy="0"/>
           </a:xfrm>
-          <a:prstGeom xmlns:a="http://schemas.openxmlformats.org/drawingml/2006/main" prst="bentConnector3">
-            <a:avLst>
-              <a:gd name="adj1" fmla="val 50000"/>
-            </a:avLst>
+          <a:prstGeom xmlns:a="http://schemas.openxmlformats.org/drawingml/2006/main" prst="straightConnector1">
+            <a:avLst/>
           </a:prstGeom>
-          <a:ln xmlns:a="http://schemas.openxmlformats.org/drawingml/2006/main" w="14288">
+          <a:ln xmlns:a="http://schemas.openxmlformats.org/drawingml/2006/main" w="11430">
             <a:solidFill>
-              <a:srgbClr val="FFFFFF"/>
+              <a:srgbClr val="AAA69D"/>
             </a:solidFill>
             <a:prstDash val="solid"/>
             <a:tailEnd type="arrow" w="sm" len="sm"/>
@@ -16627,7 +16697,7 @@
             <a:defPPr>
               <a:defRPr sz="1350" b="1">
                 <a:solidFill>
-                  <a:srgbClr val="FFFFFF"/>
+                  <a:srgbClr val="111111"/>
                 </a:solidFill>
                 <a:latin typeface="Work Sans"/>
                 <a:ea typeface="Work Sans"/>
@@ -16637,7 +16707,7 @@
             <a:lvl1pPr>
               <a:defRPr sz="1350" b="1">
                 <a:solidFill>
-                  <a:srgbClr val="FFFFFF"/>
+                  <a:srgbClr val="111111"/>
                 </a:solidFill>
                 <a:latin typeface="Work Sans"/>
                 <a:ea typeface="Work Sans"/>
@@ -16647,7 +16717,7 @@
             <a:lvl2pPr>
               <a:defRPr sz="1350" b="1">
                 <a:solidFill>
-                  <a:srgbClr val="FFFFFF"/>
+                  <a:srgbClr val="111111"/>
                 </a:solidFill>
                 <a:latin typeface="Work Sans"/>
                 <a:ea typeface="Work Sans"/>
@@ -16657,7 +16727,7 @@
             <a:lvl3pPr>
               <a:defRPr sz="1350" b="1">
                 <a:solidFill>
-                  <a:srgbClr val="FFFFFF"/>
+                  <a:srgbClr val="111111"/>
                 </a:solidFill>
                 <a:latin typeface="Work Sans"/>
                 <a:ea typeface="Work Sans"/>
@@ -16667,7 +16737,7 @@
             <a:lvl4pPr>
               <a:defRPr sz="1350" b="1">
                 <a:solidFill>
-                  <a:srgbClr val="FFFFFF"/>
+                  <a:srgbClr val="111111"/>
                 </a:solidFill>
                 <a:latin typeface="Work Sans"/>
                 <a:ea typeface="Work Sans"/>
@@ -16677,7 +16747,7 @@
             <a:lvl5pPr>
               <a:defRPr sz="1350" b="1">
                 <a:solidFill>
-                  <a:srgbClr val="FFFFFF"/>
+                  <a:srgbClr val="111111"/>
                 </a:solidFill>
                 <a:latin typeface="Work Sans"/>
                 <a:ea typeface="Work Sans"/>
@@ -16687,7 +16757,7 @@
             <a:lvl6pPr>
               <a:defRPr sz="1350" b="1">
                 <a:solidFill>
-                  <a:srgbClr val="FFFFFF"/>
+                  <a:srgbClr val="111111"/>
                 </a:solidFill>
                 <a:latin typeface="Work Sans"/>
                 <a:ea typeface="Work Sans"/>
@@ -16697,7 +16767,7 @@
             <a:lvl7pPr>
               <a:defRPr sz="1350" b="1">
                 <a:solidFill>
-                  <a:srgbClr val="FFFFFF"/>
+                  <a:srgbClr val="111111"/>
                 </a:solidFill>
                 <a:latin typeface="Work Sans"/>
                 <a:ea typeface="Work Sans"/>
@@ -16707,7 +16777,7 @@
             <a:lvl8pPr>
               <a:defRPr sz="1350" b="1">
                 <a:solidFill>
-                  <a:srgbClr val="FFFFFF"/>
+                  <a:srgbClr val="111111"/>
                 </a:solidFill>
                 <a:latin typeface="Work Sans"/>
                 <a:ea typeface="Work Sans"/>
@@ -16717,7 +16787,7 @@
             <a:lvl9pPr>
               <a:defRPr sz="1350" b="1">
                 <a:solidFill>
-                  <a:srgbClr val="FFFFFF"/>
+                  <a:srgbClr val="111111"/>
                 </a:solidFill>
                 <a:latin typeface="Work Sans"/>
                 <a:ea typeface="Work Sans"/>
@@ -16729,7 +16799,7 @@
             <a:pPr>
               <a:defRPr sz="1350" b="1">
                 <a:solidFill>
-                  <a:srgbClr val="FFFFFF"/>
+                  <a:srgbClr val="111111"/>
                 </a:solidFill>
                 <a:latin typeface="Work Sans"/>
                 <a:ea typeface="Work Sans"/>
@@ -16739,7 +16809,7 @@
             <a:r>
               <a:rPr sz="1350" b="1">
                 <a:solidFill>
-                  <a:srgbClr val="FFFFFF"/>
+                  <a:srgbClr val="111111"/>
                 </a:solidFill>
                 <a:latin typeface="Work Sans"/>
                 <a:ea typeface="Work Sans"/>
@@ -16786,7 +16856,7 @@
             <a:defPPr>
               <a:defRPr sz="1275" b="0">
                 <a:solidFill>
-                  <a:srgbClr val="979797"/>
+                  <a:srgbClr val="646464"/>
                 </a:solidFill>
                 <a:latin typeface="Work Sans"/>
                 <a:ea typeface="Work Sans"/>
@@ -16796,7 +16866,7 @@
             <a:lvl1pPr>
               <a:defRPr sz="1275" b="0">
                 <a:solidFill>
-                  <a:srgbClr val="979797"/>
+                  <a:srgbClr val="646464"/>
                 </a:solidFill>
                 <a:latin typeface="Work Sans"/>
                 <a:ea typeface="Work Sans"/>
@@ -16806,7 +16876,7 @@
             <a:lvl2pPr>
               <a:defRPr sz="1275" b="0">
                 <a:solidFill>
-                  <a:srgbClr val="979797"/>
+                  <a:srgbClr val="646464"/>
                 </a:solidFill>
                 <a:latin typeface="Work Sans"/>
                 <a:ea typeface="Work Sans"/>
@@ -16816,7 +16886,7 @@
             <a:lvl3pPr>
               <a:defRPr sz="1275" b="0">
                 <a:solidFill>
-                  <a:srgbClr val="979797"/>
+                  <a:srgbClr val="646464"/>
                 </a:solidFill>
                 <a:latin typeface="Work Sans"/>
                 <a:ea typeface="Work Sans"/>
@@ -16826,7 +16896,7 @@
             <a:lvl4pPr>
               <a:defRPr sz="1275" b="0">
                 <a:solidFill>
-                  <a:srgbClr val="979797"/>
+                  <a:srgbClr val="646464"/>
                 </a:solidFill>
                 <a:latin typeface="Work Sans"/>
                 <a:ea typeface="Work Sans"/>
@@ -16836,7 +16906,7 @@
             <a:lvl5pPr>
               <a:defRPr sz="1275" b="0">
                 <a:solidFill>
-                  <a:srgbClr val="979797"/>
+                  <a:srgbClr val="646464"/>
                 </a:solidFill>
                 <a:latin typeface="Work Sans"/>
                 <a:ea typeface="Work Sans"/>
@@ -16846,7 +16916,7 @@
             <a:lvl6pPr>
               <a:defRPr sz="1275" b="0">
                 <a:solidFill>
-                  <a:srgbClr val="979797"/>
+                  <a:srgbClr val="646464"/>
                 </a:solidFill>
                 <a:latin typeface="Work Sans"/>
                 <a:ea typeface="Work Sans"/>
@@ -16856,7 +16926,7 @@
             <a:lvl7pPr>
               <a:defRPr sz="1275" b="0">
                 <a:solidFill>
-                  <a:srgbClr val="979797"/>
+                  <a:srgbClr val="646464"/>
                 </a:solidFill>
                 <a:latin typeface="Work Sans"/>
                 <a:ea typeface="Work Sans"/>
@@ -16866,7 +16936,7 @@
             <a:lvl8pPr>
               <a:defRPr sz="1275" b="0">
                 <a:solidFill>
-                  <a:srgbClr val="979797"/>
+                  <a:srgbClr val="646464"/>
                 </a:solidFill>
                 <a:latin typeface="Work Sans"/>
                 <a:ea typeface="Work Sans"/>
@@ -16876,7 +16946,7 @@
             <a:lvl9pPr>
               <a:defRPr sz="1275" b="0">
                 <a:solidFill>
-                  <a:srgbClr val="979797"/>
+                  <a:srgbClr val="646464"/>
                 </a:solidFill>
                 <a:latin typeface="Work Sans"/>
                 <a:ea typeface="Work Sans"/>
@@ -16888,7 +16958,7 @@
             <a:pPr>
               <a:defRPr sz="1275" b="0">
                 <a:solidFill>
-                  <a:srgbClr val="979797"/>
+                  <a:srgbClr val="646464"/>
                 </a:solidFill>
                 <a:latin typeface="Work Sans"/>
                 <a:ea typeface="Work Sans"/>
@@ -16898,7 +16968,7 @@
             <a:r>
               <a:rPr sz="1275" b="0">
                 <a:solidFill>
-                  <a:srgbClr val="979797"/>
+                  <a:srgbClr val="646464"/>
                 </a:solidFill>
                 <a:latin typeface="Work Sans"/>
                 <a:ea typeface="Work Sans"/>
@@ -16914,7 +16984,7 @@
           <p:cNvPr id="7" name="headline">
             <a:extLst xmlns:a="http://schemas.openxmlformats.org/drawingml/2006/main">
               <a:ext uri="{FF2B5EF4-FFF2-40B4-BE49-F238E27FC236}">
-                <a16:creationId xmlns:a16="http://schemas.microsoft.com/office/drawing/2014/main" id="{C44D4A65-C63B-43BA-8F4F-F291895D9B53}"/>
+                <a16:creationId xmlns:a16="http://schemas.microsoft.com/office/drawing/2014/main" id="{BFE9E468-94A0-4BE5-9DD9-ABCF31D96982}"/>
               </a:ext>
             </a:extLst>
           </p:cNvPr>
@@ -16925,7 +16995,7 @@
         </p:nvSpPr>
         <p:spPr>
           <a:xfrm xmlns:a="http://schemas.openxmlformats.org/drawingml/2006/main">
-            <a:off x="609600" y="1009650"/>
+            <a:off x="609600" y="990600"/>
             <a:ext cx="10972800" cy="1333500"/>
           </a:xfrm>
           <a:prstGeom xmlns:a="http://schemas.openxmlformats.org/drawingml/2006/main" prst="rect">
@@ -16941,118 +17011,118 @@
           <a:bodyPr xmlns:a="http://schemas.openxmlformats.org/drawingml/2006/main" lIns="0" tIns="0" rIns="0" bIns="0"/>
           <a:lstStyle xmlns:a="http://schemas.openxmlformats.org/drawingml/2006/main">
             <a:defPPr>
-              <a:defRPr sz="4200" b="1">
-                <a:solidFill>
-                  <a:srgbClr val="FFFFFF"/>
+              <a:defRPr sz="3975" b="1">
+                <a:solidFill>
+                  <a:srgbClr val="111111"/>
                 </a:solidFill>
               </a:defRPr>
             </a:defPPr>
             <a:lvl1pPr>
-              <a:defRPr sz="4200" b="1">
-                <a:solidFill>
-                  <a:srgbClr val="FFFFFF"/>
+              <a:defRPr sz="3975" b="1">
+                <a:solidFill>
+                  <a:srgbClr val="111111"/>
                 </a:solidFill>
               </a:defRPr>
             </a:lvl1pPr>
             <a:lvl2pPr>
-              <a:defRPr sz="4200" b="1">
-                <a:solidFill>
-                  <a:srgbClr val="FFFFFF"/>
+              <a:defRPr sz="3975" b="1">
+                <a:solidFill>
+                  <a:srgbClr val="111111"/>
                 </a:solidFill>
               </a:defRPr>
             </a:lvl2pPr>
             <a:lvl3pPr>
-              <a:defRPr sz="4200" b="1">
-                <a:solidFill>
-                  <a:srgbClr val="FFFFFF"/>
+              <a:defRPr sz="3975" b="1">
+                <a:solidFill>
+                  <a:srgbClr val="111111"/>
                 </a:solidFill>
               </a:defRPr>
             </a:lvl3pPr>
             <a:lvl4pPr>
-              <a:defRPr sz="4200" b="1">
-                <a:solidFill>
-                  <a:srgbClr val="FFFFFF"/>
+              <a:defRPr sz="3975" b="1">
+                <a:solidFill>
+                  <a:srgbClr val="111111"/>
                 </a:solidFill>
               </a:defRPr>
             </a:lvl4pPr>
             <a:lvl5pPr>
-              <a:defRPr sz="4200" b="1">
-                <a:solidFill>
-                  <a:srgbClr val="FFFFFF"/>
+              <a:defRPr sz="3975" b="1">
+                <a:solidFill>
+                  <a:srgbClr val="111111"/>
                 </a:solidFill>
               </a:defRPr>
             </a:lvl5pPr>
             <a:lvl6pPr>
-              <a:defRPr sz="4200" b="1">
-                <a:solidFill>
-                  <a:srgbClr val="FFFFFF"/>
+              <a:defRPr sz="3975" b="1">
+                <a:solidFill>
+                  <a:srgbClr val="111111"/>
                 </a:solidFill>
               </a:defRPr>
             </a:lvl6pPr>
             <a:lvl7pPr>
-              <a:defRPr sz="4200" b="1">
-                <a:solidFill>
-                  <a:srgbClr val="FFFFFF"/>
+              <a:defRPr sz="3975" b="1">
+                <a:solidFill>
+                  <a:srgbClr val="111111"/>
                 </a:solidFill>
               </a:defRPr>
             </a:lvl7pPr>
             <a:lvl8pPr>
-              <a:defRPr sz="4200" b="1">
-                <a:solidFill>
-                  <a:srgbClr val="FFFFFF"/>
+              <a:defRPr sz="3975" b="1">
+                <a:solidFill>
+                  <a:srgbClr val="111111"/>
                 </a:solidFill>
               </a:defRPr>
             </a:lvl8pPr>
             <a:lvl9pPr>
-              <a:defRPr sz="4200" b="1">
-                <a:solidFill>
-                  <a:srgbClr val="FFFFFF"/>
+              <a:defRPr sz="3975" b="1">
+                <a:solidFill>
+                  <a:srgbClr val="111111"/>
                 </a:solidFill>
               </a:defRPr>
             </a:lvl9pPr>
           </a:lstStyle>
           <a:p xmlns:a="http://schemas.openxmlformats.org/drawingml/2006/main">
             <a:pPr>
-              <a:defRPr sz="4200" b="1">
-                <a:solidFill>
-                  <a:srgbClr val="FFFFFF"/>
+              <a:defRPr sz="3975" b="1">
+                <a:solidFill>
+                  <a:srgbClr val="111111"/>
                 </a:solidFill>
               </a:defRPr>
             </a:pPr>
             <a:r>
-              <a:rPr sz="4200" b="1">
-                <a:solidFill>
-                  <a:srgbClr val="FFFFFF"/>
+              <a:rPr sz="3975" b="1">
+                <a:solidFill>
+                  <a:srgbClr val="111111"/>
                 </a:solidFill>
               </a:rPr>
-              <a:t>Projected efficiency.</a:t>
+              <a:t>Reliable execution.</a:t>
             </a:r>
           </a:p>
           <a:p xmlns:a="http://schemas.openxmlformats.org/drawingml/2006/main">
             <a:pPr>
-              <a:defRPr sz="4200" b="1">
-                <a:solidFill>
-                  <a:srgbClr val="FFFFFF"/>
+              <a:defRPr sz="3975" b="1">
+                <a:solidFill>
+                  <a:srgbClr val="111111"/>
                 </a:solidFill>
               </a:defRPr>
             </a:pPr>
             <a:r>
-              <a:rPr sz="4200" b="1">
-                <a:solidFill>
-                  <a:srgbClr val="FFFFFF"/>
+              <a:rPr sz="3975" b="1">
+                <a:solidFill>
+                  <a:srgbClr val="111111"/>
                 </a:solidFill>
               </a:rPr>
-              <a:t>Broader execution capability</a:t>
+              <a:t>Lower costs for repeatable work</a:t>
             </a:r>
           </a:p>
         </p:txBody>
       </p:sp>
       <p:sp>
         <p:nvSpPr>
-          <p:cNvPr id="8" name="saving-value">
+          <p:cNvPr id="8" name="cost-label">
             <a:extLst xmlns:a="http://schemas.openxmlformats.org/drawingml/2006/main">
               <a:ext uri="{FF2B5EF4-FFF2-40B4-BE49-F238E27FC236}">
-                <a16:creationId xmlns:a16="http://schemas.microsoft.com/office/drawing/2014/main" id="{2C267552-1361-4C8F-A9EA-D616452DFC6B}"/>
+                <a16:creationId xmlns:a16="http://schemas.microsoft.com/office/drawing/2014/main" id="{0D67E613-4CDF-41F8-84B5-7B4C8E997994}"/>
               </a:ext>
             </a:extLst>
           </p:cNvPr>
@@ -17064,7 +17134,7 @@
         <p:spPr>
           <a:xfrm xmlns:a="http://schemas.openxmlformats.org/drawingml/2006/main">
             <a:off x="609600" y="2495550"/>
-            <a:ext cx="4286250" cy="1066800"/>
+            <a:ext cx="5143500" cy="266700"/>
           </a:xfrm>
           <a:prstGeom xmlns:a="http://schemas.openxmlformats.org/drawingml/2006/main" prst="rect">
             <a:avLst/>
@@ -17079,101 +17149,101 @@
           <a:bodyPr xmlns:a="http://schemas.openxmlformats.org/drawingml/2006/main" lIns="0" tIns="0" rIns="0" bIns="0"/>
           <a:lstStyle xmlns:a="http://schemas.openxmlformats.org/drawingml/2006/main">
             <a:defPPr>
-              <a:defRPr sz="7950" b="1">
-                <a:solidFill>
-                  <a:srgbClr val="FFFFFF"/>
+              <a:defRPr sz="1275" b="1">
+                <a:solidFill>
+                  <a:srgbClr val="F25037"/>
                 </a:solidFill>
               </a:defRPr>
             </a:defPPr>
             <a:lvl1pPr>
-              <a:defRPr sz="7950" b="1">
-                <a:solidFill>
-                  <a:srgbClr val="FFFFFF"/>
+              <a:defRPr sz="1275" b="1">
+                <a:solidFill>
+                  <a:srgbClr val="F25037"/>
                 </a:solidFill>
               </a:defRPr>
             </a:lvl1pPr>
             <a:lvl2pPr>
-              <a:defRPr sz="7950" b="1">
-                <a:solidFill>
-                  <a:srgbClr val="FFFFFF"/>
+              <a:defRPr sz="1275" b="1">
+                <a:solidFill>
+                  <a:srgbClr val="F25037"/>
                 </a:solidFill>
               </a:defRPr>
             </a:lvl2pPr>
             <a:lvl3pPr>
-              <a:defRPr sz="7950" b="1">
-                <a:solidFill>
-                  <a:srgbClr val="FFFFFF"/>
+              <a:defRPr sz="1275" b="1">
+                <a:solidFill>
+                  <a:srgbClr val="F25037"/>
                 </a:solidFill>
               </a:defRPr>
             </a:lvl3pPr>
             <a:lvl4pPr>
-              <a:defRPr sz="7950" b="1">
-                <a:solidFill>
-                  <a:srgbClr val="FFFFFF"/>
+              <a:defRPr sz="1275" b="1">
+                <a:solidFill>
+                  <a:srgbClr val="F25037"/>
                 </a:solidFill>
               </a:defRPr>
             </a:lvl4pPr>
             <a:lvl5pPr>
-              <a:defRPr sz="7950" b="1">
-                <a:solidFill>
-                  <a:srgbClr val="FFFFFF"/>
+              <a:defRPr sz="1275" b="1">
+                <a:solidFill>
+                  <a:srgbClr val="F25037"/>
                 </a:solidFill>
               </a:defRPr>
             </a:lvl5pPr>
             <a:lvl6pPr>
-              <a:defRPr sz="7950" b="1">
-                <a:solidFill>
-                  <a:srgbClr val="FFFFFF"/>
+              <a:defRPr sz="1275" b="1">
+                <a:solidFill>
+                  <a:srgbClr val="F25037"/>
                 </a:solidFill>
               </a:defRPr>
             </a:lvl6pPr>
             <a:lvl7pPr>
-              <a:defRPr sz="7950" b="1">
-                <a:solidFill>
-                  <a:srgbClr val="FFFFFF"/>
+              <a:defRPr sz="1275" b="1">
+                <a:solidFill>
+                  <a:srgbClr val="F25037"/>
                 </a:solidFill>
               </a:defRPr>
             </a:lvl7pPr>
             <a:lvl8pPr>
-              <a:defRPr sz="7950" b="1">
-                <a:solidFill>
-                  <a:srgbClr val="FFFFFF"/>
+              <a:defRPr sz="1275" b="1">
+                <a:solidFill>
+                  <a:srgbClr val="F25037"/>
                 </a:solidFill>
               </a:defRPr>
             </a:lvl8pPr>
             <a:lvl9pPr>
-              <a:defRPr sz="7950" b="1">
-                <a:solidFill>
-                  <a:srgbClr val="FFFFFF"/>
+              <a:defRPr sz="1275" b="1">
+                <a:solidFill>
+                  <a:srgbClr val="F25037"/>
                 </a:solidFill>
               </a:defRPr>
             </a:lvl9pPr>
           </a:lstStyle>
           <a:p xmlns:a="http://schemas.openxmlformats.org/drawingml/2006/main">
             <a:pPr>
-              <a:defRPr sz="7950" b="1">
-                <a:solidFill>
-                  <a:srgbClr val="FFFFFF"/>
+              <a:defRPr sz="1275" b="1">
+                <a:solidFill>
+                  <a:srgbClr val="F25037"/>
                 </a:solidFill>
               </a:defRPr>
             </a:pPr>
             <a:r>
-              <a:rPr sz="7950" b="1">
-                <a:solidFill>
-                  <a:srgbClr val="FFFFFF"/>
+              <a:rPr sz="1275" b="1">
+                <a:solidFill>
+                  <a:srgbClr val="F25037"/>
                 </a:solidFill>
               </a:rPr>
-              <a:t>15%</a:t>
+              <a:t>ILLUSTRATIVE SAVINGS</a:t>
             </a:r>
           </a:p>
         </p:txBody>
       </p:sp>
       <p:sp>
         <p:nvSpPr>
-          <p:cNvPr id="9" name="saving-label">
+          <p:cNvPr id="9" name="savings">
             <a:extLst xmlns:a="http://schemas.openxmlformats.org/drawingml/2006/main">
               <a:ext uri="{FF2B5EF4-FFF2-40B4-BE49-F238E27FC236}">
-                <a16:creationId xmlns:a16="http://schemas.microsoft.com/office/drawing/2014/main" id="{11151AB9-68F6-40C3-97E8-E98906DB3F1E}"/>
+                <a16:creationId xmlns:a16="http://schemas.microsoft.com/office/drawing/2014/main" id="{968E8DC5-10B2-46E0-85BA-3B6324689EC9}"/>
               </a:ext>
             </a:extLst>
           </p:cNvPr>
@@ -17184,8 +17254,8 @@
         </p:nvSpPr>
         <p:spPr>
           <a:xfrm xmlns:a="http://schemas.openxmlformats.org/drawingml/2006/main">
-            <a:off x="609600" y="3648075"/>
-            <a:ext cx="5238750" cy="323850"/>
+            <a:off x="609600" y="2752725"/>
+            <a:ext cx="2381250" cy="1095375"/>
           </a:xfrm>
           <a:prstGeom xmlns:a="http://schemas.openxmlformats.org/drawingml/2006/main" prst="rect">
             <a:avLst/>
@@ -17200,101 +17270,101 @@
           <a:bodyPr xmlns:a="http://schemas.openxmlformats.org/drawingml/2006/main" lIns="0" tIns="0" rIns="0" bIns="0"/>
           <a:lstStyle xmlns:a="http://schemas.openxmlformats.org/drawingml/2006/main">
             <a:defPPr>
-              <a:defRPr sz="1800" b="0">
-                <a:solidFill>
-                  <a:srgbClr val="FFFFFF"/>
+              <a:defRPr sz="7650" b="1">
+                <a:solidFill>
+                  <a:srgbClr val="F25037"/>
                 </a:solidFill>
               </a:defRPr>
             </a:defPPr>
             <a:lvl1pPr>
-              <a:defRPr sz="1800" b="0">
-                <a:solidFill>
-                  <a:srgbClr val="FFFFFF"/>
+              <a:defRPr sz="7650" b="1">
+                <a:solidFill>
+                  <a:srgbClr val="F25037"/>
                 </a:solidFill>
               </a:defRPr>
             </a:lvl1pPr>
             <a:lvl2pPr>
-              <a:defRPr sz="1800" b="0">
-                <a:solidFill>
-                  <a:srgbClr val="FFFFFF"/>
+              <a:defRPr sz="7650" b="1">
+                <a:solidFill>
+                  <a:srgbClr val="F25037"/>
                 </a:solidFill>
               </a:defRPr>
             </a:lvl2pPr>
             <a:lvl3pPr>
-              <a:defRPr sz="1800" b="0">
-                <a:solidFill>
-                  <a:srgbClr val="FFFFFF"/>
+              <a:defRPr sz="7650" b="1">
+                <a:solidFill>
+                  <a:srgbClr val="F25037"/>
                 </a:solidFill>
               </a:defRPr>
             </a:lvl3pPr>
             <a:lvl4pPr>
-              <a:defRPr sz="1800" b="0">
-                <a:solidFill>
-                  <a:srgbClr val="FFFFFF"/>
+              <a:defRPr sz="7650" b="1">
+                <a:solidFill>
+                  <a:srgbClr val="F25037"/>
                 </a:solidFill>
               </a:defRPr>
             </a:lvl4pPr>
             <a:lvl5pPr>
-              <a:defRPr sz="1800" b="0">
-                <a:solidFill>
-                  <a:srgbClr val="FFFFFF"/>
+              <a:defRPr sz="7650" b="1">
+                <a:solidFill>
+                  <a:srgbClr val="F25037"/>
                 </a:solidFill>
               </a:defRPr>
             </a:lvl5pPr>
             <a:lvl6pPr>
-              <a:defRPr sz="1800" b="0">
-                <a:solidFill>
-                  <a:srgbClr val="FFFFFF"/>
+              <a:defRPr sz="7650" b="1">
+                <a:solidFill>
+                  <a:srgbClr val="F25037"/>
                 </a:solidFill>
               </a:defRPr>
             </a:lvl6pPr>
             <a:lvl7pPr>
-              <a:defRPr sz="1800" b="0">
-                <a:solidFill>
-                  <a:srgbClr val="FFFFFF"/>
+              <a:defRPr sz="7650" b="1">
+                <a:solidFill>
+                  <a:srgbClr val="F25037"/>
                 </a:solidFill>
               </a:defRPr>
             </a:lvl7pPr>
             <a:lvl8pPr>
-              <a:defRPr sz="1800" b="0">
-                <a:solidFill>
-                  <a:srgbClr val="FFFFFF"/>
+              <a:defRPr sz="7650" b="1">
+                <a:solidFill>
+                  <a:srgbClr val="F25037"/>
                 </a:solidFill>
               </a:defRPr>
             </a:lvl8pPr>
             <a:lvl9pPr>
-              <a:defRPr sz="1800" b="0">
-                <a:solidFill>
-                  <a:srgbClr val="FFFFFF"/>
+              <a:defRPr sz="7650" b="1">
+                <a:solidFill>
+                  <a:srgbClr val="F25037"/>
                 </a:solidFill>
               </a:defRPr>
             </a:lvl9pPr>
           </a:lstStyle>
           <a:p xmlns:a="http://schemas.openxmlformats.org/drawingml/2006/main">
             <a:pPr>
-              <a:defRPr sz="1800" b="0">
-                <a:solidFill>
-                  <a:srgbClr val="FFFFFF"/>
+              <a:defRPr sz="7650" b="1">
+                <a:solidFill>
+                  <a:srgbClr val="F25037"/>
                 </a:solidFill>
               </a:defRPr>
             </a:pPr>
             <a:r>
-              <a:rPr sz="1800" b="0">
-                <a:solidFill>
-                  <a:srgbClr val="FFFFFF"/>
+              <a:rPr sz="7650" b="1">
+                <a:solidFill>
+                  <a:srgbClr val="F25037"/>
                 </a:solidFill>
               </a:rPr>
-              <a:t>illustrative total usage cost saving</a:t>
+              <a:t>15%</a:t>
             </a:r>
           </a:p>
         </p:txBody>
       </p:sp>
       <p:sp>
         <p:nvSpPr>
-          <p:cNvPr id="10" name="scope-value">
+          <p:cNvPr id="10" name="saving-caption">
             <a:extLst xmlns:a="http://schemas.openxmlformats.org/drawingml/2006/main">
               <a:ext uri="{FF2B5EF4-FFF2-40B4-BE49-F238E27FC236}">
-                <a16:creationId xmlns:a16="http://schemas.microsoft.com/office/drawing/2014/main" id="{75D783EB-4012-4083-968F-DB614EF8D8E6}"/>
+                <a16:creationId xmlns:a16="http://schemas.microsoft.com/office/drawing/2014/main" id="{740EEF9C-108B-4153-9A8B-B26EC6238A2F}"/>
               </a:ext>
             </a:extLst>
           </p:cNvPr>
@@ -17305,8 +17375,8 @@
         </p:nvSpPr>
         <p:spPr>
           <a:xfrm xmlns:a="http://schemas.openxmlformats.org/drawingml/2006/main">
-            <a:off x="6762750" y="2495550"/>
-            <a:ext cx="2000250" cy="1066800"/>
+            <a:off x="2971800" y="3009900"/>
+            <a:ext cx="2781300" cy="723900"/>
           </a:xfrm>
           <a:prstGeom xmlns:a="http://schemas.openxmlformats.org/drawingml/2006/main" prst="rect">
             <a:avLst/>
@@ -17321,101 +17391,118 @@
           <a:bodyPr xmlns:a="http://schemas.openxmlformats.org/drawingml/2006/main" lIns="0" tIns="0" rIns="0" bIns="0"/>
           <a:lstStyle xmlns:a="http://schemas.openxmlformats.org/drawingml/2006/main">
             <a:defPPr>
-              <a:defRPr sz="7950" b="1">
-                <a:solidFill>
-                  <a:srgbClr val="FFFFFF"/>
+              <a:defRPr sz="1725" b="0">
+                <a:solidFill>
+                  <a:srgbClr val="111111"/>
                 </a:solidFill>
               </a:defRPr>
             </a:defPPr>
             <a:lvl1pPr>
-              <a:defRPr sz="7950" b="1">
-                <a:solidFill>
-                  <a:srgbClr val="FFFFFF"/>
+              <a:defRPr sz="1725" b="0">
+                <a:solidFill>
+                  <a:srgbClr val="111111"/>
                 </a:solidFill>
               </a:defRPr>
             </a:lvl1pPr>
             <a:lvl2pPr>
-              <a:defRPr sz="7950" b="1">
-                <a:solidFill>
-                  <a:srgbClr val="FFFFFF"/>
+              <a:defRPr sz="1725" b="0">
+                <a:solidFill>
+                  <a:srgbClr val="111111"/>
                 </a:solidFill>
               </a:defRPr>
             </a:lvl2pPr>
             <a:lvl3pPr>
-              <a:defRPr sz="7950" b="1">
-                <a:solidFill>
-                  <a:srgbClr val="FFFFFF"/>
+              <a:defRPr sz="1725" b="0">
+                <a:solidFill>
+                  <a:srgbClr val="111111"/>
                 </a:solidFill>
               </a:defRPr>
             </a:lvl3pPr>
             <a:lvl4pPr>
-              <a:defRPr sz="7950" b="1">
-                <a:solidFill>
-                  <a:srgbClr val="FFFFFF"/>
+              <a:defRPr sz="1725" b="0">
+                <a:solidFill>
+                  <a:srgbClr val="111111"/>
                 </a:solidFill>
               </a:defRPr>
             </a:lvl4pPr>
             <a:lvl5pPr>
-              <a:defRPr sz="7950" b="1">
-                <a:solidFill>
-                  <a:srgbClr val="FFFFFF"/>
+              <a:defRPr sz="1725" b="0">
+                <a:solidFill>
+                  <a:srgbClr val="111111"/>
                 </a:solidFill>
               </a:defRPr>
             </a:lvl5pPr>
             <a:lvl6pPr>
-              <a:defRPr sz="7950" b="1">
-                <a:solidFill>
-                  <a:srgbClr val="FFFFFF"/>
+              <a:defRPr sz="1725" b="0">
+                <a:solidFill>
+                  <a:srgbClr val="111111"/>
                 </a:solidFill>
               </a:defRPr>
             </a:lvl6pPr>
             <a:lvl7pPr>
-              <a:defRPr sz="7950" b="1">
-                <a:solidFill>
-                  <a:srgbClr val="FFFFFF"/>
+              <a:defRPr sz="1725" b="0">
+                <a:solidFill>
+                  <a:srgbClr val="111111"/>
                 </a:solidFill>
               </a:defRPr>
             </a:lvl7pPr>
             <a:lvl8pPr>
-              <a:defRPr sz="7950" b="1">
-                <a:solidFill>
-                  <a:srgbClr val="FFFFFF"/>
+              <a:defRPr sz="1725" b="0">
+                <a:solidFill>
+                  <a:srgbClr val="111111"/>
                 </a:solidFill>
               </a:defRPr>
             </a:lvl8pPr>
             <a:lvl9pPr>
-              <a:defRPr sz="7950" b="1">
-                <a:solidFill>
-                  <a:srgbClr val="FFFFFF"/>
+              <a:defRPr sz="1725" b="0">
+                <a:solidFill>
+                  <a:srgbClr val="111111"/>
                 </a:solidFill>
               </a:defRPr>
             </a:lvl9pPr>
           </a:lstStyle>
           <a:p xmlns:a="http://schemas.openxmlformats.org/drawingml/2006/main">
             <a:pPr>
-              <a:defRPr sz="7950" b="1">
-                <a:solidFill>
-                  <a:srgbClr val="FFFFFF"/>
+              <a:defRPr sz="1725" b="0">
+                <a:solidFill>
+                  <a:srgbClr val="111111"/>
                 </a:solidFill>
               </a:defRPr>
             </a:pPr>
             <a:r>
-              <a:rPr sz="7950" b="1">
-                <a:solidFill>
-                  <a:srgbClr val="FFFFFF"/>
+              <a:rPr sz="1725" b="0">
+                <a:solidFill>
+                  <a:srgbClr val="111111"/>
                 </a:solidFill>
               </a:rPr>
-              <a:t>4</a:t>
+              <a:t>lower total usage cost</a:t>
+            </a:r>
+          </a:p>
+          <a:p xmlns:a="http://schemas.openxmlformats.org/drawingml/2006/main">
+            <a:pPr>
+              <a:defRPr sz="1725" b="0">
+                <a:solidFill>
+                  <a:srgbClr val="111111"/>
+                </a:solidFill>
+              </a:defRPr>
+            </a:pPr>
+            <a:r>
+              <a:rPr sz="1725" b="0">
+                <a:solidFill>
+                  <a:srgbClr val="111111"/>
+                </a:solidFill>
+              </a:rPr>
+              <a:t>in this example model</a:t>
             </a:r>
           </a:p>
         </p:txBody>
       </p:sp>
       <p:sp>
         <p:nvSpPr>
-          <p:cNvPr id="11" name="scope-label">
+          <p:cNvPr id="11" name="cost-title">
             <a:extLst xmlns:a="http://schemas.openxmlformats.org/drawingml/2006/main">
               <a:ext uri="{FF2B5EF4-FFF2-40B4-BE49-F238E27FC236}">
-                <a16:creationId xmlns:a16="http://schemas.microsoft.com/office/drawing/2014/main" id="{DB695148-BFD8-4CE4-9F2A-8295D423146E}"/>
+                <a16:creationId xmlns:a16="http://schemas.microsoft.com/office/drawing/2014/main" id="{7925BE02-98A2-4AF3-AD9C-217C25114D0F}"/>
               </a:ext>
             </a:extLst>
           </p:cNvPr>
@@ -17426,8 +17513,8 @@
         </p:nvSpPr>
         <p:spPr>
           <a:xfrm xmlns:a="http://schemas.openxmlformats.org/drawingml/2006/main">
-            <a:off x="6762750" y="3648075"/>
-            <a:ext cx="4819650" cy="323850"/>
+            <a:off x="609600" y="3924300"/>
+            <a:ext cx="5143500" cy="266700"/>
           </a:xfrm>
           <a:prstGeom xmlns:a="http://schemas.openxmlformats.org/drawingml/2006/main" prst="rect">
             <a:avLst/>
@@ -17442,91 +17529,91 @@
           <a:bodyPr xmlns:a="http://schemas.openxmlformats.org/drawingml/2006/main" lIns="0" tIns="0" rIns="0" bIns="0"/>
           <a:lstStyle xmlns:a="http://schemas.openxmlformats.org/drawingml/2006/main">
             <a:defPPr>
-              <a:defRPr sz="1800" b="0">
-                <a:solidFill>
-                  <a:srgbClr val="FFFFFF"/>
+              <a:defRPr sz="1425" b="0">
+                <a:solidFill>
+                  <a:srgbClr val="646464"/>
                 </a:solidFill>
               </a:defRPr>
             </a:defPPr>
             <a:lvl1pPr>
-              <a:defRPr sz="1800" b="0">
-                <a:solidFill>
-                  <a:srgbClr val="FFFFFF"/>
+              <a:defRPr sz="1425" b="0">
+                <a:solidFill>
+                  <a:srgbClr val="646464"/>
                 </a:solidFill>
               </a:defRPr>
             </a:lvl1pPr>
             <a:lvl2pPr>
-              <a:defRPr sz="1800" b="0">
-                <a:solidFill>
-                  <a:srgbClr val="FFFFFF"/>
+              <a:defRPr sz="1425" b="0">
+                <a:solidFill>
+                  <a:srgbClr val="646464"/>
                 </a:solidFill>
               </a:defRPr>
             </a:lvl2pPr>
             <a:lvl3pPr>
-              <a:defRPr sz="1800" b="0">
-                <a:solidFill>
-                  <a:srgbClr val="FFFFFF"/>
+              <a:defRPr sz="1425" b="0">
+                <a:solidFill>
+                  <a:srgbClr val="646464"/>
                 </a:solidFill>
               </a:defRPr>
             </a:lvl3pPr>
             <a:lvl4pPr>
-              <a:defRPr sz="1800" b="0">
-                <a:solidFill>
-                  <a:srgbClr val="FFFFFF"/>
+              <a:defRPr sz="1425" b="0">
+                <a:solidFill>
+                  <a:srgbClr val="646464"/>
                 </a:solidFill>
               </a:defRPr>
             </a:lvl4pPr>
             <a:lvl5pPr>
-              <a:defRPr sz="1800" b="0">
-                <a:solidFill>
-                  <a:srgbClr val="FFFFFF"/>
+              <a:defRPr sz="1425" b="0">
+                <a:solidFill>
+                  <a:srgbClr val="646464"/>
                 </a:solidFill>
               </a:defRPr>
             </a:lvl5pPr>
             <a:lvl6pPr>
-              <a:defRPr sz="1800" b="0">
-                <a:solidFill>
-                  <a:srgbClr val="FFFFFF"/>
+              <a:defRPr sz="1425" b="0">
+                <a:solidFill>
+                  <a:srgbClr val="646464"/>
                 </a:solidFill>
               </a:defRPr>
             </a:lvl6pPr>
             <a:lvl7pPr>
-              <a:defRPr sz="1800" b="0">
-                <a:solidFill>
-                  <a:srgbClr val="FFFFFF"/>
+              <a:defRPr sz="1425" b="0">
+                <a:solidFill>
+                  <a:srgbClr val="646464"/>
                 </a:solidFill>
               </a:defRPr>
             </a:lvl7pPr>
             <a:lvl8pPr>
-              <a:defRPr sz="1800" b="0">
-                <a:solidFill>
-                  <a:srgbClr val="FFFFFF"/>
+              <a:defRPr sz="1425" b="0">
+                <a:solidFill>
+                  <a:srgbClr val="646464"/>
                 </a:solidFill>
               </a:defRPr>
             </a:lvl8pPr>
             <a:lvl9pPr>
-              <a:defRPr sz="1800" b="0">
-                <a:solidFill>
-                  <a:srgbClr val="FFFFFF"/>
+              <a:defRPr sz="1425" b="0">
+                <a:solidFill>
+                  <a:srgbClr val="646464"/>
                 </a:solidFill>
               </a:defRPr>
             </a:lvl9pPr>
           </a:lstStyle>
           <a:p xmlns:a="http://schemas.openxmlformats.org/drawingml/2006/main">
             <a:pPr>
-              <a:defRPr sz="1800" b="0">
-                <a:solidFill>
-                  <a:srgbClr val="FFFFFF"/>
+              <a:defRPr sz="1425" b="0">
+                <a:solidFill>
+                  <a:srgbClr val="646464"/>
                 </a:solidFill>
               </a:defRPr>
             </a:pPr>
             <a:r>
-              <a:rPr sz="1800" b="0">
-                <a:solidFill>
-                  <a:srgbClr val="FFFFFF"/>
+              <a:rPr sz="1425" b="0">
+                <a:solidFill>
+                  <a:srgbClr val="646464"/>
                 </a:solidFill>
               </a:rPr>
-              <a:t>planned capability types in one agent</a:t>
+              <a:t>Cost index (baseline = 100)</a:t>
             </a:r>
           </a:p>
         </p:txBody>
@@ -17536,7 +17623,7 @@
           <p:cNvPr id="12" name="Chart">
             <a:extLst xmlns:a="http://schemas.openxmlformats.org/drawingml/2006/main">
               <a:ext uri="{FF2B5EF4-FFF2-40B4-BE49-F238E27FC236}">
-                <a16:creationId xmlns:a16="http://schemas.microsoft.com/office/drawing/2014/main" id="{CC40CFDB-4E00-4D4E-B66F-7E43421D38CB}"/>
+                <a16:creationId xmlns:a16="http://schemas.microsoft.com/office/drawing/2014/main" id="{8199D5EB-FC74-4D87-8836-CDE7783A4008}"/>
               </a:ext>
             </a:extLst>
           </p:cNvPr>
@@ -17544,21 +17631,21 @@
           <p:nvPr/>
         </p:nvGraphicFramePr>
         <p:xfrm>
-          <a:off xmlns:a="http://schemas.openxmlformats.org/drawingml/2006/main" x="609600" y="4152900"/>
-          <a:ext xmlns:a="http://schemas.openxmlformats.org/drawingml/2006/main" cx="5143500" cy="1314450"/>
+          <a:off xmlns:a="http://schemas.openxmlformats.org/drawingml/2006/main" x="609600" y="4257675"/>
+          <a:ext xmlns:a="http://schemas.openxmlformats.org/drawingml/2006/main" cx="5143500" cy="1352550"/>
         </p:xfrm>
         <a:graphic xmlns:a="http://schemas.openxmlformats.org/drawingml/2006/main">
           <a:graphicData uri="http://schemas.openxmlformats.org/drawingml/2006/chart">
-            <c:chart xmlns:r="http://schemas.openxmlformats.org/officeDocument/2006/relationships" xmlns:c="http://schemas.openxmlformats.org/drawingml/2006/chart" r:id="R6fc960617f8e4897"/>
+            <c:chart xmlns:r="http://schemas.openxmlformats.org/officeDocument/2006/relationships" xmlns:c="http://schemas.openxmlformats.org/drawingml/2006/chart" r:id="R1780d114c5ad465e"/>
           </a:graphicData>
         </a:graphic>
       </p:graphicFrame>
       <p:sp>
         <p:nvSpPr>
-          <p:cNvPr id="13" name="interpret">
+          <p:cNvPr id="13" name="capability-label">
             <a:extLst xmlns:a="http://schemas.openxmlformats.org/drawingml/2006/main">
               <a:ext uri="{FF2B5EF4-FFF2-40B4-BE49-F238E27FC236}">
-                <a16:creationId xmlns:a16="http://schemas.microsoft.com/office/drawing/2014/main" id="{C6E65349-AE87-4A02-98A6-02B3B2EED41B}"/>
+                <a16:creationId xmlns:a16="http://schemas.microsoft.com/office/drawing/2014/main" id="{B5A2DD90-98F0-4DD5-9559-4FCF31B8479D}"/>
               </a:ext>
             </a:extLst>
           </p:cNvPr>
@@ -17569,39 +17656,8 @@
         </p:nvSpPr>
         <p:spPr>
           <a:xfrm xmlns:a="http://schemas.openxmlformats.org/drawingml/2006/main">
-            <a:off x="6762750" y="4524375"/>
-            <a:ext cx="1619250" cy="542925"/>
-          </a:xfrm>
-          <a:prstGeom xmlns:a="http://schemas.openxmlformats.org/drawingml/2006/main" prst="rect">
-            <a:avLst/>
-          </a:prstGeom>
-          <a:noFill xmlns:a="http://schemas.openxmlformats.org/drawingml/2006/main"/>
-          <a:ln xmlns:a="http://schemas.openxmlformats.org/drawingml/2006/main" w="14288">
-            <a:solidFill>
-              <a:srgbClr val="FFFFFF"/>
-            </a:solidFill>
-            <a:prstDash val="solid"/>
-          </a:ln>
-        </p:spPr>
-      </p:sp>
-      <p:sp>
-        <p:nvSpPr>
-          <p:cNvPr id="14" name="interpret-label">
-            <a:extLst xmlns:a="http://schemas.openxmlformats.org/drawingml/2006/main">
-              <a:ext uri="{FF2B5EF4-FFF2-40B4-BE49-F238E27FC236}">
-                <a16:creationId xmlns:a16="http://schemas.microsoft.com/office/drawing/2014/main" id="{F48FD354-5AEB-4397-9489-C1734CDF9A24}"/>
-              </a:ext>
-            </a:extLst>
-          </p:cNvPr>
-          <p:cNvSpPr>
-            <a:spLocks xmlns:a="http://schemas.openxmlformats.org/drawingml/2006/main" noGrp="1"/>
-          </p:cNvSpPr>
-          <p:nvPr/>
-        </p:nvSpPr>
-        <p:spPr>
-          <a:xfrm xmlns:a="http://schemas.openxmlformats.org/drawingml/2006/main">
-            <a:off x="6896100" y="4629150"/>
-            <a:ext cx="1371600" cy="409575"/>
+            <a:off x="6362700" y="2495550"/>
+            <a:ext cx="5219700" cy="266700"/>
           </a:xfrm>
           <a:prstGeom xmlns:a="http://schemas.openxmlformats.org/drawingml/2006/main" prst="rect">
             <a:avLst/>
@@ -17616,101 +17672,101 @@
           <a:bodyPr xmlns:a="http://schemas.openxmlformats.org/drawingml/2006/main" lIns="0" tIns="0" rIns="0" bIns="0"/>
           <a:lstStyle xmlns:a="http://schemas.openxmlformats.org/drawingml/2006/main">
             <a:defPPr>
-              <a:defRPr sz="1650" b="0">
-                <a:solidFill>
-                  <a:srgbClr val="FFFFFF"/>
+              <a:defRPr sz="1275" b="1">
+                <a:solidFill>
+                  <a:srgbClr val="F25037"/>
                 </a:solidFill>
               </a:defRPr>
             </a:defPPr>
             <a:lvl1pPr>
-              <a:defRPr sz="1650" b="0">
-                <a:solidFill>
-                  <a:srgbClr val="FFFFFF"/>
+              <a:defRPr sz="1275" b="1">
+                <a:solidFill>
+                  <a:srgbClr val="F25037"/>
                 </a:solidFill>
               </a:defRPr>
             </a:lvl1pPr>
             <a:lvl2pPr>
-              <a:defRPr sz="1650" b="0">
-                <a:solidFill>
-                  <a:srgbClr val="FFFFFF"/>
+              <a:defRPr sz="1275" b="1">
+                <a:solidFill>
+                  <a:srgbClr val="F25037"/>
                 </a:solidFill>
               </a:defRPr>
             </a:lvl2pPr>
             <a:lvl3pPr>
-              <a:defRPr sz="1650" b="0">
-                <a:solidFill>
-                  <a:srgbClr val="FFFFFF"/>
+              <a:defRPr sz="1275" b="1">
+                <a:solidFill>
+                  <a:srgbClr val="F25037"/>
                 </a:solidFill>
               </a:defRPr>
             </a:lvl3pPr>
             <a:lvl4pPr>
-              <a:defRPr sz="1650" b="0">
-                <a:solidFill>
-                  <a:srgbClr val="FFFFFF"/>
+              <a:defRPr sz="1275" b="1">
+                <a:solidFill>
+                  <a:srgbClr val="F25037"/>
                 </a:solidFill>
               </a:defRPr>
             </a:lvl4pPr>
             <a:lvl5pPr>
-              <a:defRPr sz="1650" b="0">
-                <a:solidFill>
-                  <a:srgbClr val="FFFFFF"/>
+              <a:defRPr sz="1275" b="1">
+                <a:solidFill>
+                  <a:srgbClr val="F25037"/>
                 </a:solidFill>
               </a:defRPr>
             </a:lvl5pPr>
             <a:lvl6pPr>
-              <a:defRPr sz="1650" b="0">
-                <a:solidFill>
-                  <a:srgbClr val="FFFFFF"/>
+              <a:defRPr sz="1275" b="1">
+                <a:solidFill>
+                  <a:srgbClr val="F25037"/>
                 </a:solidFill>
               </a:defRPr>
             </a:lvl6pPr>
             <a:lvl7pPr>
-              <a:defRPr sz="1650" b="0">
-                <a:solidFill>
-                  <a:srgbClr val="FFFFFF"/>
+              <a:defRPr sz="1275" b="1">
+                <a:solidFill>
+                  <a:srgbClr val="F25037"/>
                 </a:solidFill>
               </a:defRPr>
             </a:lvl7pPr>
             <a:lvl8pPr>
-              <a:defRPr sz="1650" b="0">
-                <a:solidFill>
-                  <a:srgbClr val="FFFFFF"/>
+              <a:defRPr sz="1275" b="1">
+                <a:solidFill>
+                  <a:srgbClr val="F25037"/>
                 </a:solidFill>
               </a:defRPr>
             </a:lvl8pPr>
             <a:lvl9pPr>
-              <a:defRPr sz="1650" b="0">
-                <a:solidFill>
-                  <a:srgbClr val="FFFFFF"/>
+              <a:defRPr sz="1275" b="1">
+                <a:solidFill>
+                  <a:srgbClr val="F25037"/>
                 </a:solidFill>
               </a:defRPr>
             </a:lvl9pPr>
           </a:lstStyle>
           <a:p xmlns:a="http://schemas.openxmlformats.org/drawingml/2006/main">
             <a:pPr>
-              <a:defRPr sz="1650" b="0">
-                <a:solidFill>
-                  <a:srgbClr val="FFFFFF"/>
+              <a:defRPr sz="1275" b="1">
+                <a:solidFill>
+                  <a:srgbClr val="F25037"/>
                 </a:solidFill>
               </a:defRPr>
             </a:pPr>
             <a:r>
-              <a:rPr sz="1650" b="0">
-                <a:solidFill>
-                  <a:srgbClr val="FFFFFF"/>
+              <a:rPr sz="1275" b="1">
+                <a:solidFill>
+                  <a:srgbClr val="F25037"/>
                 </a:solidFill>
               </a:rPr>
-              <a:t>Interpret</a:t>
+              <a:t>FOUR TYPES OF EXECUTABLE CAPABILITY</a:t>
             </a:r>
           </a:p>
         </p:txBody>
       </p:sp>
       <p:sp>
         <p:nvSpPr>
-          <p:cNvPr id="15" name="cap-Calculate">
+          <p:cNvPr id="14" name="capability-0">
             <a:extLst xmlns:a="http://schemas.openxmlformats.org/drawingml/2006/main">
               <a:ext uri="{FF2B5EF4-FFF2-40B4-BE49-F238E27FC236}">
-                <a16:creationId xmlns:a16="http://schemas.microsoft.com/office/drawing/2014/main" id="{452C676C-FD3F-43A3-8C3F-D5F67492422E}"/>
+                <a16:creationId xmlns:a16="http://schemas.microsoft.com/office/drawing/2014/main" id="{ED01A2E8-E194-4229-B408-B7C4625603F5}"/>
               </a:ext>
             </a:extLst>
           </p:cNvPr>
@@ -17721,16 +17777,16 @@
         </p:nvSpPr>
         <p:spPr>
           <a:xfrm xmlns:a="http://schemas.openxmlformats.org/drawingml/2006/main">
-            <a:off x="9525000" y="4143375"/>
-            <a:ext cx="2057400" cy="457200"/>
+            <a:off x="6362700" y="2952750"/>
+            <a:ext cx="1085850" cy="476250"/>
           </a:xfrm>
           <a:prstGeom xmlns:a="http://schemas.openxmlformats.org/drawingml/2006/main" prst="rect">
             <a:avLst/>
           </a:prstGeom>
           <a:noFill xmlns:a="http://schemas.openxmlformats.org/drawingml/2006/main"/>
-          <a:ln xmlns:a="http://schemas.openxmlformats.org/drawingml/2006/main" w="14288">
+          <a:ln xmlns:a="http://schemas.openxmlformats.org/drawingml/2006/main" w="11430">
             <a:solidFill>
-              <a:srgbClr val="FFFFFF"/>
+              <a:srgbClr val="AAA69D"/>
             </a:solidFill>
             <a:prstDash val="solid"/>
           </a:ln>
@@ -17738,10 +17794,10 @@
       </p:sp>
       <p:sp>
         <p:nvSpPr>
-          <p:cNvPr id="16" name="cap-Calculate-label">
+          <p:cNvPr id="15" name="capability-title-0">
             <a:extLst xmlns:a="http://schemas.openxmlformats.org/drawingml/2006/main">
               <a:ext uri="{FF2B5EF4-FFF2-40B4-BE49-F238E27FC236}">
-                <a16:creationId xmlns:a16="http://schemas.microsoft.com/office/drawing/2014/main" id="{05021095-FEE8-45AF-AFFA-8CEE1BBBBDF4}"/>
+                <a16:creationId xmlns:a16="http://schemas.microsoft.com/office/drawing/2014/main" id="{D3779EA4-FFE3-442D-BB10-8A5428231D19}"/>
               </a:ext>
             </a:extLst>
           </p:cNvPr>
@@ -17752,8 +17808,8 @@
         </p:nvSpPr>
         <p:spPr>
           <a:xfrm xmlns:a="http://schemas.openxmlformats.org/drawingml/2006/main">
-            <a:off x="9658350" y="4248150"/>
-            <a:ext cx="1809750" cy="323850"/>
+            <a:off x="6448425" y="3086100"/>
+            <a:ext cx="952500" cy="276225"/>
           </a:xfrm>
           <a:prstGeom xmlns:a="http://schemas.openxmlformats.org/drawingml/2006/main" prst="rect">
             <a:avLst/>
@@ -17768,101 +17824,101 @@
           <a:bodyPr xmlns:a="http://schemas.openxmlformats.org/drawingml/2006/main" lIns="0" tIns="0" rIns="0" bIns="0"/>
           <a:lstStyle xmlns:a="http://schemas.openxmlformats.org/drawingml/2006/main">
             <a:defPPr>
-              <a:defRPr sz="1650" b="0">
-                <a:solidFill>
-                  <a:srgbClr val="FFFFFF"/>
+              <a:defRPr sz="1425" b="1">
+                <a:solidFill>
+                  <a:srgbClr val="111111"/>
                 </a:solidFill>
               </a:defRPr>
             </a:defPPr>
             <a:lvl1pPr>
-              <a:defRPr sz="1650" b="0">
-                <a:solidFill>
-                  <a:srgbClr val="FFFFFF"/>
+              <a:defRPr sz="1425" b="1">
+                <a:solidFill>
+                  <a:srgbClr val="111111"/>
                 </a:solidFill>
               </a:defRPr>
             </a:lvl1pPr>
             <a:lvl2pPr>
-              <a:defRPr sz="1650" b="0">
-                <a:solidFill>
-                  <a:srgbClr val="FFFFFF"/>
+              <a:defRPr sz="1425" b="1">
+                <a:solidFill>
+                  <a:srgbClr val="111111"/>
                 </a:solidFill>
               </a:defRPr>
             </a:lvl2pPr>
             <a:lvl3pPr>
-              <a:defRPr sz="1650" b="0">
-                <a:solidFill>
-                  <a:srgbClr val="FFFFFF"/>
+              <a:defRPr sz="1425" b="1">
+                <a:solidFill>
+                  <a:srgbClr val="111111"/>
                 </a:solidFill>
               </a:defRPr>
             </a:lvl3pPr>
             <a:lvl4pPr>
-              <a:defRPr sz="1650" b="0">
-                <a:solidFill>
-                  <a:srgbClr val="FFFFFF"/>
+              <a:defRPr sz="1425" b="1">
+                <a:solidFill>
+                  <a:srgbClr val="111111"/>
                 </a:solidFill>
               </a:defRPr>
             </a:lvl4pPr>
             <a:lvl5pPr>
-              <a:defRPr sz="1650" b="0">
-                <a:solidFill>
-                  <a:srgbClr val="FFFFFF"/>
+              <a:defRPr sz="1425" b="1">
+                <a:solidFill>
+                  <a:srgbClr val="111111"/>
                 </a:solidFill>
               </a:defRPr>
             </a:lvl5pPr>
             <a:lvl6pPr>
-              <a:defRPr sz="1650" b="0">
-                <a:solidFill>
-                  <a:srgbClr val="FFFFFF"/>
+              <a:defRPr sz="1425" b="1">
+                <a:solidFill>
+                  <a:srgbClr val="111111"/>
                 </a:solidFill>
               </a:defRPr>
             </a:lvl6pPr>
             <a:lvl7pPr>
-              <a:defRPr sz="1650" b="0">
-                <a:solidFill>
-                  <a:srgbClr val="FFFFFF"/>
+              <a:defRPr sz="1425" b="1">
+                <a:solidFill>
+                  <a:srgbClr val="111111"/>
                 </a:solidFill>
               </a:defRPr>
             </a:lvl7pPr>
             <a:lvl8pPr>
-              <a:defRPr sz="1650" b="0">
-                <a:solidFill>
-                  <a:srgbClr val="FFFFFF"/>
+              <a:defRPr sz="1425" b="1">
+                <a:solidFill>
+                  <a:srgbClr val="111111"/>
                 </a:solidFill>
               </a:defRPr>
             </a:lvl8pPr>
             <a:lvl9pPr>
-              <a:defRPr sz="1650" b="0">
-                <a:solidFill>
-                  <a:srgbClr val="FFFFFF"/>
+              <a:defRPr sz="1425" b="1">
+                <a:solidFill>
+                  <a:srgbClr val="111111"/>
                 </a:solidFill>
               </a:defRPr>
             </a:lvl9pPr>
           </a:lstStyle>
           <a:p xmlns:a="http://schemas.openxmlformats.org/drawingml/2006/main">
             <a:pPr>
-              <a:defRPr sz="1650" b="0">
-                <a:solidFill>
-                  <a:srgbClr val="FFFFFF"/>
+              <a:defRPr sz="1425" b="1">
+                <a:solidFill>
+                  <a:srgbClr val="111111"/>
                 </a:solidFill>
               </a:defRPr>
             </a:pPr>
             <a:r>
-              <a:rPr sz="1650" b="0">
-                <a:solidFill>
-                  <a:srgbClr val="FFFFFF"/>
+              <a:rPr sz="1425" b="1">
+                <a:solidFill>
+                  <a:srgbClr val="111111"/>
                 </a:solidFill>
               </a:rPr>
-              <a:t>Calculate</a:t>
+              <a:t>Interpret</a:t>
             </a:r>
           </a:p>
         </p:txBody>
       </p:sp>
       <p:sp>
         <p:nvSpPr>
-          <p:cNvPr id="17" name="cap-Validate">
+          <p:cNvPr id="16" name="capability-description-0">
             <a:extLst xmlns:a="http://schemas.openxmlformats.org/drawingml/2006/main">
               <a:ext uri="{FF2B5EF4-FFF2-40B4-BE49-F238E27FC236}">
-                <a16:creationId xmlns:a16="http://schemas.microsoft.com/office/drawing/2014/main" id="{EF0ED873-1CC6-4DD9-96DA-4A058809C909}"/>
+                <a16:creationId xmlns:a16="http://schemas.microsoft.com/office/drawing/2014/main" id="{4E98623B-EDA4-4B46-9854-DF903EBA19D1}"/>
               </a:ext>
             </a:extLst>
           </p:cNvPr>
@@ -17873,39 +17929,8 @@
         </p:nvSpPr>
         <p:spPr>
           <a:xfrm xmlns:a="http://schemas.openxmlformats.org/drawingml/2006/main">
-            <a:off x="9525000" y="4752975"/>
-            <a:ext cx="2057400" cy="457200"/>
-          </a:xfrm>
-          <a:prstGeom xmlns:a="http://schemas.openxmlformats.org/drawingml/2006/main" prst="rect">
-            <a:avLst/>
-          </a:prstGeom>
-          <a:noFill xmlns:a="http://schemas.openxmlformats.org/drawingml/2006/main"/>
-          <a:ln xmlns:a="http://schemas.openxmlformats.org/drawingml/2006/main" w="14288">
-            <a:solidFill>
-              <a:srgbClr val="FFFFFF"/>
-            </a:solidFill>
-            <a:prstDash val="solid"/>
-          </a:ln>
-        </p:spPr>
-      </p:sp>
-      <p:sp>
-        <p:nvSpPr>
-          <p:cNvPr id="18" name="cap-Validate-label">
-            <a:extLst xmlns:a="http://schemas.openxmlformats.org/drawingml/2006/main">
-              <a:ext uri="{FF2B5EF4-FFF2-40B4-BE49-F238E27FC236}">
-                <a16:creationId xmlns:a16="http://schemas.microsoft.com/office/drawing/2014/main" id="{D245CA7F-FEC3-4D9D-8226-3A3FFD46F2DD}"/>
-              </a:ext>
-            </a:extLst>
-          </p:cNvPr>
-          <p:cNvSpPr>
-            <a:spLocks xmlns:a="http://schemas.openxmlformats.org/drawingml/2006/main" noGrp="1"/>
-          </p:cNvSpPr>
-          <p:nvPr/>
-        </p:nvSpPr>
-        <p:spPr>
-          <a:xfrm xmlns:a="http://schemas.openxmlformats.org/drawingml/2006/main">
-            <a:off x="9658350" y="4857750"/>
-            <a:ext cx="1809750" cy="323850"/>
+            <a:off x="6362700" y="3590925"/>
+            <a:ext cx="1209675" cy="514350"/>
           </a:xfrm>
           <a:prstGeom xmlns:a="http://schemas.openxmlformats.org/drawingml/2006/main" prst="rect">
             <a:avLst/>
@@ -17920,101 +17945,118 @@
           <a:bodyPr xmlns:a="http://schemas.openxmlformats.org/drawingml/2006/main" lIns="0" tIns="0" rIns="0" bIns="0"/>
           <a:lstStyle xmlns:a="http://schemas.openxmlformats.org/drawingml/2006/main">
             <a:defPPr>
-              <a:defRPr sz="1650" b="0">
-                <a:solidFill>
-                  <a:srgbClr val="FFFFFF"/>
+              <a:defRPr sz="1350" b="0">
+                <a:solidFill>
+                  <a:srgbClr val="646464"/>
                 </a:solidFill>
               </a:defRPr>
             </a:defPPr>
             <a:lvl1pPr>
-              <a:defRPr sz="1650" b="0">
-                <a:solidFill>
-                  <a:srgbClr val="FFFFFF"/>
+              <a:defRPr sz="1350" b="0">
+                <a:solidFill>
+                  <a:srgbClr val="646464"/>
                 </a:solidFill>
               </a:defRPr>
             </a:lvl1pPr>
             <a:lvl2pPr>
-              <a:defRPr sz="1650" b="0">
-                <a:solidFill>
-                  <a:srgbClr val="FFFFFF"/>
+              <a:defRPr sz="1350" b="0">
+                <a:solidFill>
+                  <a:srgbClr val="646464"/>
                 </a:solidFill>
               </a:defRPr>
             </a:lvl2pPr>
             <a:lvl3pPr>
-              <a:defRPr sz="1650" b="0">
-                <a:solidFill>
-                  <a:srgbClr val="FFFFFF"/>
+              <a:defRPr sz="1350" b="0">
+                <a:solidFill>
+                  <a:srgbClr val="646464"/>
                 </a:solidFill>
               </a:defRPr>
             </a:lvl3pPr>
             <a:lvl4pPr>
-              <a:defRPr sz="1650" b="0">
-                <a:solidFill>
-                  <a:srgbClr val="FFFFFF"/>
+              <a:defRPr sz="1350" b="0">
+                <a:solidFill>
+                  <a:srgbClr val="646464"/>
                 </a:solidFill>
               </a:defRPr>
             </a:lvl4pPr>
             <a:lvl5pPr>
-              <a:defRPr sz="1650" b="0">
-                <a:solidFill>
-                  <a:srgbClr val="FFFFFF"/>
+              <a:defRPr sz="1350" b="0">
+                <a:solidFill>
+                  <a:srgbClr val="646464"/>
                 </a:solidFill>
               </a:defRPr>
             </a:lvl5pPr>
             <a:lvl6pPr>
-              <a:defRPr sz="1650" b="0">
-                <a:solidFill>
-                  <a:srgbClr val="FFFFFF"/>
+              <a:defRPr sz="1350" b="0">
+                <a:solidFill>
+                  <a:srgbClr val="646464"/>
                 </a:solidFill>
               </a:defRPr>
             </a:lvl6pPr>
             <a:lvl7pPr>
-              <a:defRPr sz="1650" b="0">
-                <a:solidFill>
-                  <a:srgbClr val="FFFFFF"/>
+              <a:defRPr sz="1350" b="0">
+                <a:solidFill>
+                  <a:srgbClr val="646464"/>
                 </a:solidFill>
               </a:defRPr>
             </a:lvl7pPr>
             <a:lvl8pPr>
-              <a:defRPr sz="1650" b="0">
-                <a:solidFill>
-                  <a:srgbClr val="FFFFFF"/>
+              <a:defRPr sz="1350" b="0">
+                <a:solidFill>
+                  <a:srgbClr val="646464"/>
                 </a:solidFill>
               </a:defRPr>
             </a:lvl8pPr>
             <a:lvl9pPr>
-              <a:defRPr sz="1650" b="0">
-                <a:solidFill>
-                  <a:srgbClr val="FFFFFF"/>
+              <a:defRPr sz="1350" b="0">
+                <a:solidFill>
+                  <a:srgbClr val="646464"/>
                 </a:solidFill>
               </a:defRPr>
             </a:lvl9pPr>
           </a:lstStyle>
           <a:p xmlns:a="http://schemas.openxmlformats.org/drawingml/2006/main">
             <a:pPr>
-              <a:defRPr sz="1650" b="0">
-                <a:solidFill>
-                  <a:srgbClr val="FFFFFF"/>
+              <a:defRPr sz="1350" b="0">
+                <a:solidFill>
+                  <a:srgbClr val="646464"/>
                 </a:solidFill>
               </a:defRPr>
             </a:pPr>
             <a:r>
-              <a:rPr sz="1650" b="0">
-                <a:solidFill>
-                  <a:srgbClr val="FFFFFF"/>
+              <a:rPr sz="1350" b="0">
+                <a:solidFill>
+                  <a:srgbClr val="646464"/>
                 </a:solidFill>
               </a:rPr>
-              <a:t>Validate</a:t>
+              <a:t>Request</a:t>
+            </a:r>
+          </a:p>
+          <a:p xmlns:a="http://schemas.openxmlformats.org/drawingml/2006/main">
+            <a:pPr>
+              <a:defRPr sz="1350" b="0">
+                <a:solidFill>
+                  <a:srgbClr val="646464"/>
+                </a:solidFill>
+              </a:defRPr>
+            </a:pPr>
+            <a:r>
+              <a:rPr sz="1350" b="0">
+                <a:solidFill>
+                  <a:srgbClr val="646464"/>
+                </a:solidFill>
+              </a:rPr>
+              <a:t>and context</a:t>
             </a:r>
           </a:p>
         </p:txBody>
       </p:sp>
       <p:sp>
         <p:nvSpPr>
-          <p:cNvPr id="19" name="cap-Act">
+          <p:cNvPr id="17" name="capability-1">
             <a:extLst xmlns:a="http://schemas.openxmlformats.org/drawingml/2006/main">
               <a:ext uri="{FF2B5EF4-FFF2-40B4-BE49-F238E27FC236}">
-                <a16:creationId xmlns:a16="http://schemas.microsoft.com/office/drawing/2014/main" id="{A99D0E92-D87B-4AFB-A994-D6E440C1BBED}"/>
+                <a16:creationId xmlns:a16="http://schemas.microsoft.com/office/drawing/2014/main" id="{69B2EAD7-0563-4C1E-809A-2153C510F32F}"/>
               </a:ext>
             </a:extLst>
           </p:cNvPr>
@@ -18025,16 +18067,18 @@
         </p:nvSpPr>
         <p:spPr>
           <a:xfrm xmlns:a="http://schemas.openxmlformats.org/drawingml/2006/main">
-            <a:off x="9525000" y="5362575"/>
-            <a:ext cx="2057400" cy="457200"/>
+            <a:off x="7734300" y="2952750"/>
+            <a:ext cx="1085850" cy="476250"/>
           </a:xfrm>
           <a:prstGeom xmlns:a="http://schemas.openxmlformats.org/drawingml/2006/main" prst="rect">
             <a:avLst/>
           </a:prstGeom>
-          <a:noFill xmlns:a="http://schemas.openxmlformats.org/drawingml/2006/main"/>
-          <a:ln xmlns:a="http://schemas.openxmlformats.org/drawingml/2006/main" w="14288">
+          <a:solidFill xmlns:a="http://schemas.openxmlformats.org/drawingml/2006/main">
+            <a:srgbClr val="F25037"/>
+          </a:solidFill>
+          <a:ln xmlns:a="http://schemas.openxmlformats.org/drawingml/2006/main" w="11430">
             <a:solidFill>
-              <a:srgbClr val="FFFFFF"/>
+              <a:srgbClr val="F25037"/>
             </a:solidFill>
             <a:prstDash val="solid"/>
           </a:ln>
@@ -18042,10 +18086,10 @@
       </p:sp>
       <p:sp>
         <p:nvSpPr>
-          <p:cNvPr id="20" name="cap-Act-label">
+          <p:cNvPr id="18" name="capability-title-1">
             <a:extLst xmlns:a="http://schemas.openxmlformats.org/drawingml/2006/main">
               <a:ext uri="{FF2B5EF4-FFF2-40B4-BE49-F238E27FC236}">
-                <a16:creationId xmlns:a16="http://schemas.microsoft.com/office/drawing/2014/main" id="{7DD5D875-33A3-4CFB-A9AD-9FB01D2A7BA6}"/>
+                <a16:creationId xmlns:a16="http://schemas.microsoft.com/office/drawing/2014/main" id="{D2CD4AE7-2109-47C2-B50C-6FD630B6A652}"/>
               </a:ext>
             </a:extLst>
           </p:cNvPr>
@@ -18056,8 +18100,8 @@
         </p:nvSpPr>
         <p:spPr>
           <a:xfrm xmlns:a="http://schemas.openxmlformats.org/drawingml/2006/main">
-            <a:off x="9658350" y="5467350"/>
-            <a:ext cx="1809750" cy="323850"/>
+            <a:off x="7820025" y="3086100"/>
+            <a:ext cx="952500" cy="276225"/>
           </a:xfrm>
           <a:prstGeom xmlns:a="http://schemas.openxmlformats.org/drawingml/2006/main" prst="rect">
             <a:avLst/>
@@ -18072,70 +18116,70 @@
           <a:bodyPr xmlns:a="http://schemas.openxmlformats.org/drawingml/2006/main" lIns="0" tIns="0" rIns="0" bIns="0"/>
           <a:lstStyle xmlns:a="http://schemas.openxmlformats.org/drawingml/2006/main">
             <a:defPPr>
-              <a:defRPr sz="1650" b="0">
+              <a:defRPr sz="1425" b="1">
                 <a:solidFill>
                   <a:srgbClr val="FFFFFF"/>
                 </a:solidFill>
               </a:defRPr>
             </a:defPPr>
             <a:lvl1pPr>
-              <a:defRPr sz="1650" b="0">
+              <a:defRPr sz="1425" b="1">
                 <a:solidFill>
                   <a:srgbClr val="FFFFFF"/>
                 </a:solidFill>
               </a:defRPr>
             </a:lvl1pPr>
             <a:lvl2pPr>
-              <a:defRPr sz="1650" b="0">
+              <a:defRPr sz="1425" b="1">
                 <a:solidFill>
                   <a:srgbClr val="FFFFFF"/>
                 </a:solidFill>
               </a:defRPr>
             </a:lvl2pPr>
             <a:lvl3pPr>
-              <a:defRPr sz="1650" b="0">
+              <a:defRPr sz="1425" b="1">
                 <a:solidFill>
                   <a:srgbClr val="FFFFFF"/>
                 </a:solidFill>
               </a:defRPr>
             </a:lvl3pPr>
             <a:lvl4pPr>
-              <a:defRPr sz="1650" b="0">
+              <a:defRPr sz="1425" b="1">
                 <a:solidFill>
                   <a:srgbClr val="FFFFFF"/>
                 </a:solidFill>
               </a:defRPr>
             </a:lvl4pPr>
             <a:lvl5pPr>
-              <a:defRPr sz="1650" b="0">
+              <a:defRPr sz="1425" b="1">
                 <a:solidFill>
                   <a:srgbClr val="FFFFFF"/>
                 </a:solidFill>
               </a:defRPr>
             </a:lvl5pPr>
             <a:lvl6pPr>
-              <a:defRPr sz="1650" b="0">
+              <a:defRPr sz="1425" b="1">
                 <a:solidFill>
                   <a:srgbClr val="FFFFFF"/>
                 </a:solidFill>
               </a:defRPr>
             </a:lvl6pPr>
             <a:lvl7pPr>
-              <a:defRPr sz="1650" b="0">
+              <a:defRPr sz="1425" b="1">
                 <a:solidFill>
                   <a:srgbClr val="FFFFFF"/>
                 </a:solidFill>
               </a:defRPr>
             </a:lvl7pPr>
             <a:lvl8pPr>
-              <a:defRPr sz="1650" b="0">
+              <a:defRPr sz="1425" b="1">
                 <a:solidFill>
                   <a:srgbClr val="FFFFFF"/>
                 </a:solidFill>
               </a:defRPr>
             </a:lvl8pPr>
             <a:lvl9pPr>
-              <a:defRPr sz="1650" b="0">
+              <a:defRPr sz="1425" b="1">
                 <a:solidFill>
                   <a:srgbClr val="FFFFFF"/>
                 </a:solidFill>
@@ -18144,29 +18188,29 @@
           </a:lstStyle>
           <a:p xmlns:a="http://schemas.openxmlformats.org/drawingml/2006/main">
             <a:pPr>
-              <a:defRPr sz="1650" b="0">
+              <a:defRPr sz="1425" b="1">
                 <a:solidFill>
                   <a:srgbClr val="FFFFFF"/>
                 </a:solidFill>
               </a:defRPr>
             </a:pPr>
             <a:r>
-              <a:rPr sz="1650" b="0">
+              <a:rPr sz="1425" b="1">
                 <a:solidFill>
                   <a:srgbClr val="FFFFFF"/>
                 </a:solidFill>
               </a:rPr>
-              <a:t>Act</a:t>
+              <a:t>Compute</a:t>
             </a:r>
           </a:p>
         </p:txBody>
       </p:sp>
       <p:sp>
         <p:nvSpPr>
-          <p:cNvPr id="21" name="reliability">
+          <p:cNvPr id="19" name="capability-description-1">
             <a:extLst xmlns:a="http://schemas.openxmlformats.org/drawingml/2006/main">
               <a:ext uri="{FF2B5EF4-FFF2-40B4-BE49-F238E27FC236}">
-                <a16:creationId xmlns:a16="http://schemas.microsoft.com/office/drawing/2014/main" id="{6C22A9F8-ADBE-4745-A33B-08F4D4DC74F2}"/>
+                <a16:creationId xmlns:a16="http://schemas.microsoft.com/office/drawing/2014/main" id="{0199106A-CFF0-47CE-AD99-551F3DC6C0EA}"/>
               </a:ext>
             </a:extLst>
           </p:cNvPr>
@@ -18177,8 +18221,8 @@
         </p:nvSpPr>
         <p:spPr>
           <a:xfrm xmlns:a="http://schemas.openxmlformats.org/drawingml/2006/main">
-            <a:off x="609600" y="5800725"/>
-            <a:ext cx="10972800" cy="323850"/>
+            <a:off x="7734300" y="3590925"/>
+            <a:ext cx="1209675" cy="514350"/>
           </a:xfrm>
           <a:prstGeom xmlns:a="http://schemas.openxmlformats.org/drawingml/2006/main" prst="rect">
             <a:avLst/>
@@ -18193,101 +18237,118 @@
           <a:bodyPr xmlns:a="http://schemas.openxmlformats.org/drawingml/2006/main" lIns="0" tIns="0" rIns="0" bIns="0"/>
           <a:lstStyle xmlns:a="http://schemas.openxmlformats.org/drawingml/2006/main">
             <a:defPPr>
-              <a:defRPr sz="1650" b="1">
-                <a:solidFill>
-                  <a:srgbClr val="FFFFFF"/>
+              <a:defRPr sz="1350" b="0">
+                <a:solidFill>
+                  <a:srgbClr val="646464"/>
                 </a:solidFill>
               </a:defRPr>
             </a:defPPr>
             <a:lvl1pPr>
-              <a:defRPr sz="1650" b="1">
-                <a:solidFill>
-                  <a:srgbClr val="FFFFFF"/>
+              <a:defRPr sz="1350" b="0">
+                <a:solidFill>
+                  <a:srgbClr val="646464"/>
                 </a:solidFill>
               </a:defRPr>
             </a:lvl1pPr>
             <a:lvl2pPr>
-              <a:defRPr sz="1650" b="1">
-                <a:solidFill>
-                  <a:srgbClr val="FFFFFF"/>
+              <a:defRPr sz="1350" b="0">
+                <a:solidFill>
+                  <a:srgbClr val="646464"/>
                 </a:solidFill>
               </a:defRPr>
             </a:lvl2pPr>
             <a:lvl3pPr>
-              <a:defRPr sz="1650" b="1">
-                <a:solidFill>
-                  <a:srgbClr val="FFFFFF"/>
+              <a:defRPr sz="1350" b="0">
+                <a:solidFill>
+                  <a:srgbClr val="646464"/>
                 </a:solidFill>
               </a:defRPr>
             </a:lvl3pPr>
             <a:lvl4pPr>
-              <a:defRPr sz="1650" b="1">
-                <a:solidFill>
-                  <a:srgbClr val="FFFFFF"/>
+              <a:defRPr sz="1350" b="0">
+                <a:solidFill>
+                  <a:srgbClr val="646464"/>
                 </a:solidFill>
               </a:defRPr>
             </a:lvl4pPr>
             <a:lvl5pPr>
-              <a:defRPr sz="1650" b="1">
-                <a:solidFill>
-                  <a:srgbClr val="FFFFFF"/>
+              <a:defRPr sz="1350" b="0">
+                <a:solidFill>
+                  <a:srgbClr val="646464"/>
                 </a:solidFill>
               </a:defRPr>
             </a:lvl5pPr>
             <a:lvl6pPr>
-              <a:defRPr sz="1650" b="1">
-                <a:solidFill>
-                  <a:srgbClr val="FFFFFF"/>
+              <a:defRPr sz="1350" b="0">
+                <a:solidFill>
+                  <a:srgbClr val="646464"/>
                 </a:solidFill>
               </a:defRPr>
             </a:lvl6pPr>
             <a:lvl7pPr>
-              <a:defRPr sz="1650" b="1">
-                <a:solidFill>
-                  <a:srgbClr val="FFFFFF"/>
+              <a:defRPr sz="1350" b="0">
+                <a:solidFill>
+                  <a:srgbClr val="646464"/>
                 </a:solidFill>
               </a:defRPr>
             </a:lvl7pPr>
             <a:lvl8pPr>
-              <a:defRPr sz="1650" b="1">
-                <a:solidFill>
-                  <a:srgbClr val="FFFFFF"/>
+              <a:defRPr sz="1350" b="0">
+                <a:solidFill>
+                  <a:srgbClr val="646464"/>
                 </a:solidFill>
               </a:defRPr>
             </a:lvl8pPr>
             <a:lvl9pPr>
-              <a:defRPr sz="1650" b="1">
-                <a:solidFill>
-                  <a:srgbClr val="FFFFFF"/>
+              <a:defRPr sz="1350" b="0">
+                <a:solidFill>
+                  <a:srgbClr val="646464"/>
                 </a:solidFill>
               </a:defRPr>
             </a:lvl9pPr>
           </a:lstStyle>
           <a:p xmlns:a="http://schemas.openxmlformats.org/drawingml/2006/main">
             <a:pPr>
-              <a:defRPr sz="1650" b="1">
-                <a:solidFill>
-                  <a:srgbClr val="FFFFFF"/>
+              <a:defRPr sz="1350" b="0">
+                <a:solidFill>
+                  <a:srgbClr val="646464"/>
                 </a:solidFill>
               </a:defRPr>
             </a:pPr>
             <a:r>
-              <a:rPr sz="1650" b="1">
-                <a:solidFill>
-                  <a:srgbClr val="FFFFFF"/>
+              <a:rPr sz="1350" b="0">
+                <a:solidFill>
+                  <a:srgbClr val="646464"/>
                 </a:solidFill>
               </a:rPr>
-              <a:t>Tested rules support repeatability. Predictable results and costs can build trust.</a:t>
+              <a:t>Deterministic</a:t>
+            </a:r>
+          </a:p>
+          <a:p xmlns:a="http://schemas.openxmlformats.org/drawingml/2006/main">
+            <a:pPr>
+              <a:defRPr sz="1350" b="0">
+                <a:solidFill>
+                  <a:srgbClr val="646464"/>
+                </a:solidFill>
+              </a:defRPr>
+            </a:pPr>
+            <a:r>
+              <a:rPr sz="1350" b="0">
+                <a:solidFill>
+                  <a:srgbClr val="646464"/>
+                </a:solidFill>
+              </a:rPr>
+              <a:t>operations</a:t>
             </a:r>
           </a:p>
         </p:txBody>
       </p:sp>
       <p:sp>
         <p:nvSpPr>
-          <p:cNvPr id="22" name="assumptions">
+          <p:cNvPr id="20" name="capability-2">
             <a:extLst xmlns:a="http://schemas.openxmlformats.org/drawingml/2006/main">
               <a:ext uri="{FF2B5EF4-FFF2-40B4-BE49-F238E27FC236}">
-                <a16:creationId xmlns:a16="http://schemas.microsoft.com/office/drawing/2014/main" id="{C0603458-AD87-4615-8964-C926EEC51CD5}"/>
+                <a16:creationId xmlns:a16="http://schemas.microsoft.com/office/drawing/2014/main" id="{FEE97252-C7B7-4B62-9596-9BE8B601FC40}"/>
               </a:ext>
             </a:extLst>
           </p:cNvPr>
@@ -18298,8 +18359,39 @@
         </p:nvSpPr>
         <p:spPr>
           <a:xfrm xmlns:a="http://schemas.openxmlformats.org/drawingml/2006/main">
-            <a:off x="609600" y="6257925"/>
-            <a:ext cx="10572750" cy="238125"/>
+            <a:off x="9105900" y="2952750"/>
+            <a:ext cx="1085850" cy="476250"/>
+          </a:xfrm>
+          <a:prstGeom xmlns:a="http://schemas.openxmlformats.org/drawingml/2006/main" prst="rect">
+            <a:avLst/>
+          </a:prstGeom>
+          <a:noFill xmlns:a="http://schemas.openxmlformats.org/drawingml/2006/main"/>
+          <a:ln xmlns:a="http://schemas.openxmlformats.org/drawingml/2006/main" w="11430">
+            <a:solidFill>
+              <a:srgbClr val="AAA69D"/>
+            </a:solidFill>
+            <a:prstDash val="solid"/>
+          </a:ln>
+        </p:spPr>
+      </p:sp>
+      <p:sp>
+        <p:nvSpPr>
+          <p:cNvPr id="21" name="capability-title-2">
+            <a:extLst xmlns:a="http://schemas.openxmlformats.org/drawingml/2006/main">
+              <a:ext uri="{FF2B5EF4-FFF2-40B4-BE49-F238E27FC236}">
+                <a16:creationId xmlns:a16="http://schemas.microsoft.com/office/drawing/2014/main" id="{5F50448F-4851-472D-903C-10745D28A83C}"/>
+              </a:ext>
+            </a:extLst>
+          </p:cNvPr>
+          <p:cNvSpPr>
+            <a:spLocks xmlns:a="http://schemas.openxmlformats.org/drawingml/2006/main" noGrp="1"/>
+          </p:cNvSpPr>
+          <p:nvPr/>
+        </p:nvSpPr>
+        <p:spPr>
+          <a:xfrm xmlns:a="http://schemas.openxmlformats.org/drawingml/2006/main">
+            <a:off x="9191625" y="3086100"/>
+            <a:ext cx="952500" cy="276225"/>
           </a:xfrm>
           <a:prstGeom xmlns:a="http://schemas.openxmlformats.org/drawingml/2006/main" prst="rect">
             <a:avLst/>
@@ -18314,101 +18406,101 @@
           <a:bodyPr xmlns:a="http://schemas.openxmlformats.org/drawingml/2006/main" lIns="0" tIns="0" rIns="0" bIns="0"/>
           <a:lstStyle xmlns:a="http://schemas.openxmlformats.org/drawingml/2006/main">
             <a:defPPr>
-              <a:defRPr sz="1275" b="0">
-                <a:solidFill>
-                  <a:srgbClr val="FFFFFF"/>
+              <a:defRPr sz="1425" b="1">
+                <a:solidFill>
+                  <a:srgbClr val="111111"/>
                 </a:solidFill>
               </a:defRPr>
             </a:defPPr>
             <a:lvl1pPr>
-              <a:defRPr sz="1275" b="0">
-                <a:solidFill>
-                  <a:srgbClr val="FFFFFF"/>
+              <a:defRPr sz="1425" b="1">
+                <a:solidFill>
+                  <a:srgbClr val="111111"/>
                 </a:solidFill>
               </a:defRPr>
             </a:lvl1pPr>
             <a:lvl2pPr>
-              <a:defRPr sz="1275" b="0">
-                <a:solidFill>
-                  <a:srgbClr val="FFFFFF"/>
+              <a:defRPr sz="1425" b="1">
+                <a:solidFill>
+                  <a:srgbClr val="111111"/>
                 </a:solidFill>
               </a:defRPr>
             </a:lvl2pPr>
             <a:lvl3pPr>
-              <a:defRPr sz="1275" b="0">
-                <a:solidFill>
-                  <a:srgbClr val="FFFFFF"/>
+              <a:defRPr sz="1425" b="1">
+                <a:solidFill>
+                  <a:srgbClr val="111111"/>
                 </a:solidFill>
               </a:defRPr>
             </a:lvl3pPr>
             <a:lvl4pPr>
-              <a:defRPr sz="1275" b="0">
-                <a:solidFill>
-                  <a:srgbClr val="FFFFFF"/>
+              <a:defRPr sz="1425" b="1">
+                <a:solidFill>
+                  <a:srgbClr val="111111"/>
                 </a:solidFill>
               </a:defRPr>
             </a:lvl4pPr>
             <a:lvl5pPr>
-              <a:defRPr sz="1275" b="0">
-                <a:solidFill>
-                  <a:srgbClr val="FFFFFF"/>
+              <a:defRPr sz="1425" b="1">
+                <a:solidFill>
+                  <a:srgbClr val="111111"/>
                 </a:solidFill>
               </a:defRPr>
             </a:lvl5pPr>
             <a:lvl6pPr>
-              <a:defRPr sz="1275" b="0">
-                <a:solidFill>
-                  <a:srgbClr val="FFFFFF"/>
+              <a:defRPr sz="1425" b="1">
+                <a:solidFill>
+                  <a:srgbClr val="111111"/>
                 </a:solidFill>
               </a:defRPr>
             </a:lvl6pPr>
             <a:lvl7pPr>
-              <a:defRPr sz="1275" b="0">
-                <a:solidFill>
-                  <a:srgbClr val="FFFFFF"/>
+              <a:defRPr sz="1425" b="1">
+                <a:solidFill>
+                  <a:srgbClr val="111111"/>
                 </a:solidFill>
               </a:defRPr>
             </a:lvl7pPr>
             <a:lvl8pPr>
-              <a:defRPr sz="1275" b="0">
-                <a:solidFill>
-                  <a:srgbClr val="FFFFFF"/>
+              <a:defRPr sz="1425" b="1">
+                <a:solidFill>
+                  <a:srgbClr val="111111"/>
                 </a:solidFill>
               </a:defRPr>
             </a:lvl8pPr>
             <a:lvl9pPr>
-              <a:defRPr sz="1275" b="0">
-                <a:solidFill>
-                  <a:srgbClr val="FFFFFF"/>
+              <a:defRPr sz="1425" b="1">
+                <a:solidFill>
+                  <a:srgbClr val="111111"/>
                 </a:solidFill>
               </a:defRPr>
             </a:lvl9pPr>
           </a:lstStyle>
           <a:p xmlns:a="http://schemas.openxmlformats.org/drawingml/2006/main">
             <a:pPr>
-              <a:defRPr sz="1275" b="0">
-                <a:solidFill>
-                  <a:srgbClr val="FFFFFF"/>
+              <a:defRPr sz="1425" b="1">
+                <a:solidFill>
+                  <a:srgbClr val="111111"/>
                 </a:solidFill>
               </a:defRPr>
             </a:pPr>
             <a:r>
-              <a:rPr sz="1275" b="0">
-                <a:solidFill>
-                  <a:srgbClr val="FFFFFF"/>
+              <a:rPr sz="1425" b="1">
+                <a:solidFill>
+                  <a:srgbClr val="111111"/>
                 </a:solidFill>
               </a:rPr>
-              <a:t>Cost model: 100 = 70 fixed + 30 LLM. Replace 60% of LLM spend, add 3 execution units: total 85.</a:t>
+              <a:t>Validate</a:t>
             </a:r>
           </a:p>
         </p:txBody>
       </p:sp>
       <p:sp>
         <p:nvSpPr>
-          <p:cNvPr id="23" name="disclosure">
+          <p:cNvPr id="22" name="capability-description-2">
             <a:extLst xmlns:a="http://schemas.openxmlformats.org/drawingml/2006/main">
               <a:ext uri="{FF2B5EF4-FFF2-40B4-BE49-F238E27FC236}">
-                <a16:creationId xmlns:a16="http://schemas.microsoft.com/office/drawing/2014/main" id="{EB829550-C1EF-446A-9ECE-C8D47EE0B513}"/>
+                <a16:creationId xmlns:a16="http://schemas.microsoft.com/office/drawing/2014/main" id="{90D6ABC2-CAFD-4F01-AA03-04E66A517C71}"/>
               </a:ext>
             </a:extLst>
           </p:cNvPr>
@@ -18419,8 +18511,8 @@
         </p:nvSpPr>
         <p:spPr>
           <a:xfrm xmlns:a="http://schemas.openxmlformats.org/drawingml/2006/main">
-            <a:off x="609600" y="6534150"/>
-            <a:ext cx="10572750" cy="228600"/>
+            <a:off x="9105900" y="3590925"/>
+            <a:ext cx="1209675" cy="514350"/>
           </a:xfrm>
           <a:prstGeom xmlns:a="http://schemas.openxmlformats.org/drawingml/2006/main" prst="rect">
             <a:avLst/>
@@ -18435,91 +18527,1293 @@
           <a:bodyPr xmlns:a="http://schemas.openxmlformats.org/drawingml/2006/main" lIns="0" tIns="0" rIns="0" bIns="0"/>
           <a:lstStyle xmlns:a="http://schemas.openxmlformats.org/drawingml/2006/main">
             <a:defPPr>
-              <a:defRPr sz="1200" b="0">
-                <a:solidFill>
-                  <a:srgbClr val="FFFFFF"/>
+              <a:defRPr sz="1350" b="0">
+                <a:solidFill>
+                  <a:srgbClr val="646464"/>
                 </a:solidFill>
               </a:defRPr>
             </a:defPPr>
             <a:lvl1pPr>
-              <a:defRPr sz="1200" b="0">
-                <a:solidFill>
-                  <a:srgbClr val="FFFFFF"/>
+              <a:defRPr sz="1350" b="0">
+                <a:solidFill>
+                  <a:srgbClr val="646464"/>
                 </a:solidFill>
               </a:defRPr>
             </a:lvl1pPr>
             <a:lvl2pPr>
-              <a:defRPr sz="1200" b="0">
-                <a:solidFill>
-                  <a:srgbClr val="FFFFFF"/>
+              <a:defRPr sz="1350" b="0">
+                <a:solidFill>
+                  <a:srgbClr val="646464"/>
                 </a:solidFill>
               </a:defRPr>
             </a:lvl2pPr>
             <a:lvl3pPr>
-              <a:defRPr sz="1200" b="0">
-                <a:solidFill>
-                  <a:srgbClr val="FFFFFF"/>
+              <a:defRPr sz="1350" b="0">
+                <a:solidFill>
+                  <a:srgbClr val="646464"/>
                 </a:solidFill>
               </a:defRPr>
             </a:lvl3pPr>
             <a:lvl4pPr>
-              <a:defRPr sz="1200" b="0">
-                <a:solidFill>
-                  <a:srgbClr val="FFFFFF"/>
+              <a:defRPr sz="1350" b="0">
+                <a:solidFill>
+                  <a:srgbClr val="646464"/>
                 </a:solidFill>
               </a:defRPr>
             </a:lvl4pPr>
             <a:lvl5pPr>
-              <a:defRPr sz="1200" b="0">
-                <a:solidFill>
-                  <a:srgbClr val="FFFFFF"/>
+              <a:defRPr sz="1350" b="0">
+                <a:solidFill>
+                  <a:srgbClr val="646464"/>
                 </a:solidFill>
               </a:defRPr>
             </a:lvl5pPr>
             <a:lvl6pPr>
-              <a:defRPr sz="1200" b="0">
-                <a:solidFill>
-                  <a:srgbClr val="FFFFFF"/>
+              <a:defRPr sz="1350" b="0">
+                <a:solidFill>
+                  <a:srgbClr val="646464"/>
                 </a:solidFill>
               </a:defRPr>
             </a:lvl6pPr>
             <a:lvl7pPr>
-              <a:defRPr sz="1200" b="0">
-                <a:solidFill>
-                  <a:srgbClr val="FFFFFF"/>
+              <a:defRPr sz="1350" b="0">
+                <a:solidFill>
+                  <a:srgbClr val="646464"/>
                 </a:solidFill>
               </a:defRPr>
             </a:lvl7pPr>
             <a:lvl8pPr>
-              <a:defRPr sz="1200" b="0">
-                <a:solidFill>
-                  <a:srgbClr val="FFFFFF"/>
+              <a:defRPr sz="1350" b="0">
+                <a:solidFill>
+                  <a:srgbClr val="646464"/>
                 </a:solidFill>
               </a:defRPr>
             </a:lvl8pPr>
             <a:lvl9pPr>
-              <a:defRPr sz="1200" b="0">
-                <a:solidFill>
-                  <a:srgbClr val="FFFFFF"/>
+              <a:defRPr sz="1350" b="0">
+                <a:solidFill>
+                  <a:srgbClr val="646464"/>
                 </a:solidFill>
               </a:defRPr>
             </a:lvl9pPr>
           </a:lstStyle>
           <a:p xmlns:a="http://schemas.openxmlformats.org/drawingml/2006/main">
             <a:pPr>
-              <a:defRPr sz="1200" b="0">
-                <a:solidFill>
-                  <a:srgbClr val="FFFFFF"/>
+              <a:defRPr sz="1350" b="0">
+                <a:solidFill>
+                  <a:srgbClr val="646464"/>
                 </a:solidFill>
               </a:defRPr>
             </a:pPr>
             <a:r>
-              <a:rPr sz="1200" b="0">
-                <a:solidFill>
-                  <a:srgbClr val="FFFFFF"/>
+              <a:rPr sz="1350" b="0">
+                <a:solidFill>
+                  <a:srgbClr val="646464"/>
                 </a:solidFill>
               </a:rPr>
-              <a:t>Illustrative assumptions, not measured results. Capability count describes scope, not an intelligence score.</a:t>
+              <a:t>Configured</a:t>
+            </a:r>
+          </a:p>
+          <a:p xmlns:a="http://schemas.openxmlformats.org/drawingml/2006/main">
+            <a:pPr>
+              <a:defRPr sz="1350" b="0">
+                <a:solidFill>
+                  <a:srgbClr val="646464"/>
+                </a:solidFill>
+              </a:defRPr>
+            </a:pPr>
+            <a:r>
+              <a:rPr sz="1350" b="0">
+                <a:solidFill>
+                  <a:srgbClr val="646464"/>
+                </a:solidFill>
+              </a:rPr>
+              <a:t>rules</a:t>
+            </a:r>
+          </a:p>
+        </p:txBody>
+      </p:sp>
+      <p:sp>
+        <p:nvSpPr>
+          <p:cNvPr id="23" name="capability-3">
+            <a:extLst xmlns:a="http://schemas.openxmlformats.org/drawingml/2006/main">
+              <a:ext uri="{FF2B5EF4-FFF2-40B4-BE49-F238E27FC236}">
+                <a16:creationId xmlns:a16="http://schemas.microsoft.com/office/drawing/2014/main" id="{EA47E73B-1B1E-4E3E-81C4-FBC64DF27AEE}"/>
+              </a:ext>
+            </a:extLst>
+          </p:cNvPr>
+          <p:cNvSpPr>
+            <a:spLocks xmlns:a="http://schemas.openxmlformats.org/drawingml/2006/main" noGrp="1"/>
+          </p:cNvSpPr>
+          <p:nvPr/>
+        </p:nvSpPr>
+        <p:spPr>
+          <a:xfrm xmlns:a="http://schemas.openxmlformats.org/drawingml/2006/main">
+            <a:off x="10477500" y="2952750"/>
+            <a:ext cx="1085850" cy="476250"/>
+          </a:xfrm>
+          <a:prstGeom xmlns:a="http://schemas.openxmlformats.org/drawingml/2006/main" prst="rect">
+            <a:avLst/>
+          </a:prstGeom>
+          <a:noFill xmlns:a="http://schemas.openxmlformats.org/drawingml/2006/main"/>
+          <a:ln xmlns:a="http://schemas.openxmlformats.org/drawingml/2006/main" w="11430">
+            <a:solidFill>
+              <a:srgbClr val="AAA69D"/>
+            </a:solidFill>
+            <a:prstDash val="solid"/>
+          </a:ln>
+        </p:spPr>
+      </p:sp>
+      <p:sp>
+        <p:nvSpPr>
+          <p:cNvPr id="24" name="capability-title-3">
+            <a:extLst xmlns:a="http://schemas.openxmlformats.org/drawingml/2006/main">
+              <a:ext uri="{FF2B5EF4-FFF2-40B4-BE49-F238E27FC236}">
+                <a16:creationId xmlns:a16="http://schemas.microsoft.com/office/drawing/2014/main" id="{A946F897-3927-450E-94BE-F9CECD30AA05}"/>
+              </a:ext>
+            </a:extLst>
+          </p:cNvPr>
+          <p:cNvSpPr>
+            <a:spLocks xmlns:a="http://schemas.openxmlformats.org/drawingml/2006/main" noGrp="1"/>
+          </p:cNvSpPr>
+          <p:nvPr/>
+        </p:nvSpPr>
+        <p:spPr>
+          <a:xfrm xmlns:a="http://schemas.openxmlformats.org/drawingml/2006/main">
+            <a:off x="10563225" y="3086100"/>
+            <a:ext cx="952500" cy="276225"/>
+          </a:xfrm>
+          <a:prstGeom xmlns:a="http://schemas.openxmlformats.org/drawingml/2006/main" prst="rect">
+            <a:avLst/>
+          </a:prstGeom>
+          <a:noFill xmlns:a="http://schemas.openxmlformats.org/drawingml/2006/main"/>
+          <a:ln xmlns:a="http://schemas.openxmlformats.org/drawingml/2006/main" w="0">
+            <a:noFill/>
+            <a:prstDash val="solid"/>
+          </a:ln>
+        </p:spPr>
+        <p:txBody>
+          <a:bodyPr xmlns:a="http://schemas.openxmlformats.org/drawingml/2006/main" lIns="0" tIns="0" rIns="0" bIns="0"/>
+          <a:lstStyle xmlns:a="http://schemas.openxmlformats.org/drawingml/2006/main">
+            <a:defPPr>
+              <a:defRPr sz="1425" b="1">
+                <a:solidFill>
+                  <a:srgbClr val="111111"/>
+                </a:solidFill>
+              </a:defRPr>
+            </a:defPPr>
+            <a:lvl1pPr>
+              <a:defRPr sz="1425" b="1">
+                <a:solidFill>
+                  <a:srgbClr val="111111"/>
+                </a:solidFill>
+              </a:defRPr>
+            </a:lvl1pPr>
+            <a:lvl2pPr>
+              <a:defRPr sz="1425" b="1">
+                <a:solidFill>
+                  <a:srgbClr val="111111"/>
+                </a:solidFill>
+              </a:defRPr>
+            </a:lvl2pPr>
+            <a:lvl3pPr>
+              <a:defRPr sz="1425" b="1">
+                <a:solidFill>
+                  <a:srgbClr val="111111"/>
+                </a:solidFill>
+              </a:defRPr>
+            </a:lvl3pPr>
+            <a:lvl4pPr>
+              <a:defRPr sz="1425" b="1">
+                <a:solidFill>
+                  <a:srgbClr val="111111"/>
+                </a:solidFill>
+              </a:defRPr>
+            </a:lvl4pPr>
+            <a:lvl5pPr>
+              <a:defRPr sz="1425" b="1">
+                <a:solidFill>
+                  <a:srgbClr val="111111"/>
+                </a:solidFill>
+              </a:defRPr>
+            </a:lvl5pPr>
+            <a:lvl6pPr>
+              <a:defRPr sz="1425" b="1">
+                <a:solidFill>
+                  <a:srgbClr val="111111"/>
+                </a:solidFill>
+              </a:defRPr>
+            </a:lvl6pPr>
+            <a:lvl7pPr>
+              <a:defRPr sz="1425" b="1">
+                <a:solidFill>
+                  <a:srgbClr val="111111"/>
+                </a:solidFill>
+              </a:defRPr>
+            </a:lvl7pPr>
+            <a:lvl8pPr>
+              <a:defRPr sz="1425" b="1">
+                <a:solidFill>
+                  <a:srgbClr val="111111"/>
+                </a:solidFill>
+              </a:defRPr>
+            </a:lvl8pPr>
+            <a:lvl9pPr>
+              <a:defRPr sz="1425" b="1">
+                <a:solidFill>
+                  <a:srgbClr val="111111"/>
+                </a:solidFill>
+              </a:defRPr>
+            </a:lvl9pPr>
+          </a:lstStyle>
+          <a:p xmlns:a="http://schemas.openxmlformats.org/drawingml/2006/main">
+            <a:pPr>
+              <a:defRPr sz="1425" b="1">
+                <a:solidFill>
+                  <a:srgbClr val="111111"/>
+                </a:solidFill>
+              </a:defRPr>
+            </a:pPr>
+            <a:r>
+              <a:rPr sz="1425" b="1">
+                <a:solidFill>
+                  <a:srgbClr val="111111"/>
+                </a:solidFill>
+              </a:rPr>
+              <a:t>Act</a:t>
+            </a:r>
+          </a:p>
+        </p:txBody>
+      </p:sp>
+      <p:sp>
+        <p:nvSpPr>
+          <p:cNvPr id="25" name="capability-description-3">
+            <a:extLst xmlns:a="http://schemas.openxmlformats.org/drawingml/2006/main">
+              <a:ext uri="{FF2B5EF4-FFF2-40B4-BE49-F238E27FC236}">
+                <a16:creationId xmlns:a16="http://schemas.microsoft.com/office/drawing/2014/main" id="{EFDA62D1-DF3E-4BD3-BD6C-F142101B78E2}"/>
+              </a:ext>
+            </a:extLst>
+          </p:cNvPr>
+          <p:cNvSpPr>
+            <a:spLocks xmlns:a="http://schemas.openxmlformats.org/drawingml/2006/main" noGrp="1"/>
+          </p:cNvSpPr>
+          <p:nvPr/>
+        </p:nvSpPr>
+        <p:spPr>
+          <a:xfrm xmlns:a="http://schemas.openxmlformats.org/drawingml/2006/main">
+            <a:off x="10477500" y="3590925"/>
+            <a:ext cx="1209675" cy="514350"/>
+          </a:xfrm>
+          <a:prstGeom xmlns:a="http://schemas.openxmlformats.org/drawingml/2006/main" prst="rect">
+            <a:avLst/>
+          </a:prstGeom>
+          <a:noFill xmlns:a="http://schemas.openxmlformats.org/drawingml/2006/main"/>
+          <a:ln xmlns:a="http://schemas.openxmlformats.org/drawingml/2006/main" w="0">
+            <a:noFill/>
+            <a:prstDash val="solid"/>
+          </a:ln>
+        </p:spPr>
+        <p:txBody>
+          <a:bodyPr xmlns:a="http://schemas.openxmlformats.org/drawingml/2006/main" lIns="0" tIns="0" rIns="0" bIns="0"/>
+          <a:lstStyle xmlns:a="http://schemas.openxmlformats.org/drawingml/2006/main">
+            <a:defPPr>
+              <a:defRPr sz="1350" b="0">
+                <a:solidFill>
+                  <a:srgbClr val="646464"/>
+                </a:solidFill>
+              </a:defRPr>
+            </a:defPPr>
+            <a:lvl1pPr>
+              <a:defRPr sz="1350" b="0">
+                <a:solidFill>
+                  <a:srgbClr val="646464"/>
+                </a:solidFill>
+              </a:defRPr>
+            </a:lvl1pPr>
+            <a:lvl2pPr>
+              <a:defRPr sz="1350" b="0">
+                <a:solidFill>
+                  <a:srgbClr val="646464"/>
+                </a:solidFill>
+              </a:defRPr>
+            </a:lvl2pPr>
+            <a:lvl3pPr>
+              <a:defRPr sz="1350" b="0">
+                <a:solidFill>
+                  <a:srgbClr val="646464"/>
+                </a:solidFill>
+              </a:defRPr>
+            </a:lvl3pPr>
+            <a:lvl4pPr>
+              <a:defRPr sz="1350" b="0">
+                <a:solidFill>
+                  <a:srgbClr val="646464"/>
+                </a:solidFill>
+              </a:defRPr>
+            </a:lvl4pPr>
+            <a:lvl5pPr>
+              <a:defRPr sz="1350" b="0">
+                <a:solidFill>
+                  <a:srgbClr val="646464"/>
+                </a:solidFill>
+              </a:defRPr>
+            </a:lvl5pPr>
+            <a:lvl6pPr>
+              <a:defRPr sz="1350" b="0">
+                <a:solidFill>
+                  <a:srgbClr val="646464"/>
+                </a:solidFill>
+              </a:defRPr>
+            </a:lvl6pPr>
+            <a:lvl7pPr>
+              <a:defRPr sz="1350" b="0">
+                <a:solidFill>
+                  <a:srgbClr val="646464"/>
+                </a:solidFill>
+              </a:defRPr>
+            </a:lvl7pPr>
+            <a:lvl8pPr>
+              <a:defRPr sz="1350" b="0">
+                <a:solidFill>
+                  <a:srgbClr val="646464"/>
+                </a:solidFill>
+              </a:defRPr>
+            </a:lvl8pPr>
+            <a:lvl9pPr>
+              <a:defRPr sz="1350" b="0">
+                <a:solidFill>
+                  <a:srgbClr val="646464"/>
+                </a:solidFill>
+              </a:defRPr>
+            </a:lvl9pPr>
+          </a:lstStyle>
+          <a:p xmlns:a="http://schemas.openxmlformats.org/drawingml/2006/main">
+            <a:pPr>
+              <a:defRPr sz="1350" b="0">
+                <a:solidFill>
+                  <a:srgbClr val="646464"/>
+                </a:solidFill>
+              </a:defRPr>
+            </a:pPr>
+            <a:r>
+              <a:rPr sz="1350" b="0">
+                <a:solidFill>
+                  <a:srgbClr val="646464"/>
+                </a:solidFill>
+              </a:rPr>
+              <a:t>Authorized</a:t>
+            </a:r>
+          </a:p>
+          <a:p xmlns:a="http://schemas.openxmlformats.org/drawingml/2006/main">
+            <a:pPr>
+              <a:defRPr sz="1350" b="0">
+                <a:solidFill>
+                  <a:srgbClr val="646464"/>
+                </a:solidFill>
+              </a:defRPr>
+            </a:pPr>
+            <a:r>
+              <a:rPr sz="1350" b="0">
+                <a:solidFill>
+                  <a:srgbClr val="646464"/>
+                </a:solidFill>
+              </a:rPr>
+              <a:t>integrations</a:t>
+            </a:r>
+          </a:p>
+        </p:txBody>
+      </p:sp>
+      <p:sp>
+        <p:nvSpPr>
+          <p:cNvPr id="26" name="reliability-title">
+            <a:extLst xmlns:a="http://schemas.openxmlformats.org/drawingml/2006/main">
+              <a:ext uri="{FF2B5EF4-FFF2-40B4-BE49-F238E27FC236}">
+                <a16:creationId xmlns:a16="http://schemas.microsoft.com/office/drawing/2014/main" id="{027DF81C-C21A-476C-91F7-C1FCF9648CD8}"/>
+              </a:ext>
+            </a:extLst>
+          </p:cNvPr>
+          <p:cNvSpPr>
+            <a:spLocks xmlns:a="http://schemas.openxmlformats.org/drawingml/2006/main" noGrp="1"/>
+          </p:cNvSpPr>
+          <p:nvPr/>
+        </p:nvSpPr>
+        <p:spPr>
+          <a:xfrm xmlns:a="http://schemas.openxmlformats.org/drawingml/2006/main">
+            <a:off x="6362700" y="4371975"/>
+            <a:ext cx="2457450" cy="333375"/>
+          </a:xfrm>
+          <a:prstGeom xmlns:a="http://schemas.openxmlformats.org/drawingml/2006/main" prst="rect">
+            <a:avLst/>
+          </a:prstGeom>
+          <a:noFill xmlns:a="http://schemas.openxmlformats.org/drawingml/2006/main"/>
+          <a:ln xmlns:a="http://schemas.openxmlformats.org/drawingml/2006/main" w="0">
+            <a:noFill/>
+            <a:prstDash val="solid"/>
+          </a:ln>
+        </p:spPr>
+        <p:txBody>
+          <a:bodyPr xmlns:a="http://schemas.openxmlformats.org/drawingml/2006/main" lIns="0" tIns="0" rIns="0" bIns="0"/>
+          <a:lstStyle xmlns:a="http://schemas.openxmlformats.org/drawingml/2006/main">
+            <a:defPPr>
+              <a:defRPr sz="2025" b="1">
+                <a:solidFill>
+                  <a:srgbClr val="111111"/>
+                </a:solidFill>
+              </a:defRPr>
+            </a:defPPr>
+            <a:lvl1pPr>
+              <a:defRPr sz="2025" b="1">
+                <a:solidFill>
+                  <a:srgbClr val="111111"/>
+                </a:solidFill>
+              </a:defRPr>
+            </a:lvl1pPr>
+            <a:lvl2pPr>
+              <a:defRPr sz="2025" b="1">
+                <a:solidFill>
+                  <a:srgbClr val="111111"/>
+                </a:solidFill>
+              </a:defRPr>
+            </a:lvl2pPr>
+            <a:lvl3pPr>
+              <a:defRPr sz="2025" b="1">
+                <a:solidFill>
+                  <a:srgbClr val="111111"/>
+                </a:solidFill>
+              </a:defRPr>
+            </a:lvl3pPr>
+            <a:lvl4pPr>
+              <a:defRPr sz="2025" b="1">
+                <a:solidFill>
+                  <a:srgbClr val="111111"/>
+                </a:solidFill>
+              </a:defRPr>
+            </a:lvl4pPr>
+            <a:lvl5pPr>
+              <a:defRPr sz="2025" b="1">
+                <a:solidFill>
+                  <a:srgbClr val="111111"/>
+                </a:solidFill>
+              </a:defRPr>
+            </a:lvl5pPr>
+            <a:lvl6pPr>
+              <a:defRPr sz="2025" b="1">
+                <a:solidFill>
+                  <a:srgbClr val="111111"/>
+                </a:solidFill>
+              </a:defRPr>
+            </a:lvl6pPr>
+            <a:lvl7pPr>
+              <a:defRPr sz="2025" b="1">
+                <a:solidFill>
+                  <a:srgbClr val="111111"/>
+                </a:solidFill>
+              </a:defRPr>
+            </a:lvl7pPr>
+            <a:lvl8pPr>
+              <a:defRPr sz="2025" b="1">
+                <a:solidFill>
+                  <a:srgbClr val="111111"/>
+                </a:solidFill>
+              </a:defRPr>
+            </a:lvl8pPr>
+            <a:lvl9pPr>
+              <a:defRPr sz="2025" b="1">
+                <a:solidFill>
+                  <a:srgbClr val="111111"/>
+                </a:solidFill>
+              </a:defRPr>
+            </a:lvl9pPr>
+          </a:lstStyle>
+          <a:p xmlns:a="http://schemas.openxmlformats.org/drawingml/2006/main">
+            <a:pPr>
+              <a:defRPr sz="2025" b="1">
+                <a:solidFill>
+                  <a:srgbClr val="111111"/>
+                </a:solidFill>
+              </a:defRPr>
+            </a:pPr>
+            <a:r>
+              <a:rPr sz="2025" b="1">
+                <a:solidFill>
+                  <a:srgbClr val="111111"/>
+                </a:solidFill>
+              </a:rPr>
+              <a:t>Reliability</a:t>
+            </a:r>
+          </a:p>
+        </p:txBody>
+      </p:sp>
+      <p:sp>
+        <p:nvSpPr>
+          <p:cNvPr id="27" name="reliability-body">
+            <a:extLst xmlns:a="http://schemas.openxmlformats.org/drawingml/2006/main">
+              <a:ext uri="{FF2B5EF4-FFF2-40B4-BE49-F238E27FC236}">
+                <a16:creationId xmlns:a16="http://schemas.microsoft.com/office/drawing/2014/main" id="{C92C0D5B-9E7A-48DC-9232-8EBF41C64838}"/>
+              </a:ext>
+            </a:extLst>
+          </p:cNvPr>
+          <p:cNvSpPr>
+            <a:spLocks xmlns:a="http://schemas.openxmlformats.org/drawingml/2006/main" noGrp="1"/>
+          </p:cNvSpPr>
+          <p:nvPr/>
+        </p:nvSpPr>
+        <p:spPr>
+          <a:xfrm xmlns:a="http://schemas.openxmlformats.org/drawingml/2006/main">
+            <a:off x="6362700" y="4791075"/>
+            <a:ext cx="2457450" cy="838200"/>
+          </a:xfrm>
+          <a:prstGeom xmlns:a="http://schemas.openxmlformats.org/drawingml/2006/main" prst="rect">
+            <a:avLst/>
+          </a:prstGeom>
+          <a:noFill xmlns:a="http://schemas.openxmlformats.org/drawingml/2006/main"/>
+          <a:ln xmlns:a="http://schemas.openxmlformats.org/drawingml/2006/main" w="0">
+            <a:noFill/>
+            <a:prstDash val="solid"/>
+          </a:ln>
+        </p:spPr>
+        <p:txBody>
+          <a:bodyPr xmlns:a="http://schemas.openxmlformats.org/drawingml/2006/main" lIns="0" tIns="0" rIns="0" bIns="0"/>
+          <a:lstStyle xmlns:a="http://schemas.openxmlformats.org/drawingml/2006/main">
+            <a:defPPr>
+              <a:defRPr sz="1575" b="0">
+                <a:solidFill>
+                  <a:srgbClr val="646464"/>
+                </a:solidFill>
+              </a:defRPr>
+            </a:defPPr>
+            <a:lvl1pPr>
+              <a:defRPr sz="1575" b="0">
+                <a:solidFill>
+                  <a:srgbClr val="646464"/>
+                </a:solidFill>
+              </a:defRPr>
+            </a:lvl1pPr>
+            <a:lvl2pPr>
+              <a:defRPr sz="1575" b="0">
+                <a:solidFill>
+                  <a:srgbClr val="646464"/>
+                </a:solidFill>
+              </a:defRPr>
+            </a:lvl2pPr>
+            <a:lvl3pPr>
+              <a:defRPr sz="1575" b="0">
+                <a:solidFill>
+                  <a:srgbClr val="646464"/>
+                </a:solidFill>
+              </a:defRPr>
+            </a:lvl3pPr>
+            <a:lvl4pPr>
+              <a:defRPr sz="1575" b="0">
+                <a:solidFill>
+                  <a:srgbClr val="646464"/>
+                </a:solidFill>
+              </a:defRPr>
+            </a:lvl4pPr>
+            <a:lvl5pPr>
+              <a:defRPr sz="1575" b="0">
+                <a:solidFill>
+                  <a:srgbClr val="646464"/>
+                </a:solidFill>
+              </a:defRPr>
+            </a:lvl5pPr>
+            <a:lvl6pPr>
+              <a:defRPr sz="1575" b="0">
+                <a:solidFill>
+                  <a:srgbClr val="646464"/>
+                </a:solidFill>
+              </a:defRPr>
+            </a:lvl6pPr>
+            <a:lvl7pPr>
+              <a:defRPr sz="1575" b="0">
+                <a:solidFill>
+                  <a:srgbClr val="646464"/>
+                </a:solidFill>
+              </a:defRPr>
+            </a:lvl7pPr>
+            <a:lvl8pPr>
+              <a:defRPr sz="1575" b="0">
+                <a:solidFill>
+                  <a:srgbClr val="646464"/>
+                </a:solidFill>
+              </a:defRPr>
+            </a:lvl8pPr>
+            <a:lvl9pPr>
+              <a:defRPr sz="1575" b="0">
+                <a:solidFill>
+                  <a:srgbClr val="646464"/>
+                </a:solidFill>
+              </a:defRPr>
+            </a:lvl9pPr>
+          </a:lstStyle>
+          <a:p xmlns:a="http://schemas.openxmlformats.org/drawingml/2006/main">
+            <a:pPr>
+              <a:defRPr sz="1575" b="0">
+                <a:solidFill>
+                  <a:srgbClr val="646464"/>
+                </a:solidFill>
+              </a:defRPr>
+            </a:pPr>
+            <a:r>
+              <a:rPr sz="1575" b="0">
+                <a:solidFill>
+                  <a:srgbClr val="646464"/>
+                </a:solidFill>
+              </a:rPr>
+              <a:t>Tested computations repeat for the same inputs and module version.</a:t>
+            </a:r>
+          </a:p>
+        </p:txBody>
+      </p:sp>
+      <p:sp>
+        <p:nvSpPr>
+          <p:cNvPr id="28" name="adoption-title">
+            <a:extLst xmlns:a="http://schemas.openxmlformats.org/drawingml/2006/main">
+              <a:ext uri="{FF2B5EF4-FFF2-40B4-BE49-F238E27FC236}">
+                <a16:creationId xmlns:a16="http://schemas.microsoft.com/office/drawing/2014/main" id="{50CB9C0B-A80B-4310-A309-DF0A988D21B4}"/>
+              </a:ext>
+            </a:extLst>
+          </p:cNvPr>
+          <p:cNvSpPr>
+            <a:spLocks xmlns:a="http://schemas.openxmlformats.org/drawingml/2006/main" noGrp="1"/>
+          </p:cNvSpPr>
+          <p:nvPr/>
+        </p:nvSpPr>
+        <p:spPr>
+          <a:xfrm xmlns:a="http://schemas.openxmlformats.org/drawingml/2006/main">
+            <a:off x="9105900" y="4371975"/>
+            <a:ext cx="2476500" cy="333375"/>
+          </a:xfrm>
+          <a:prstGeom xmlns:a="http://schemas.openxmlformats.org/drawingml/2006/main" prst="rect">
+            <a:avLst/>
+          </a:prstGeom>
+          <a:noFill xmlns:a="http://schemas.openxmlformats.org/drawingml/2006/main"/>
+          <a:ln xmlns:a="http://schemas.openxmlformats.org/drawingml/2006/main" w="0">
+            <a:noFill/>
+            <a:prstDash val="solid"/>
+          </a:ln>
+        </p:spPr>
+        <p:txBody>
+          <a:bodyPr xmlns:a="http://schemas.openxmlformats.org/drawingml/2006/main" lIns="0" tIns="0" rIns="0" bIns="0"/>
+          <a:lstStyle xmlns:a="http://schemas.openxmlformats.org/drawingml/2006/main">
+            <a:defPPr>
+              <a:defRPr sz="2025" b="1">
+                <a:solidFill>
+                  <a:srgbClr val="111111"/>
+                </a:solidFill>
+              </a:defRPr>
+            </a:defPPr>
+            <a:lvl1pPr>
+              <a:defRPr sz="2025" b="1">
+                <a:solidFill>
+                  <a:srgbClr val="111111"/>
+                </a:solidFill>
+              </a:defRPr>
+            </a:lvl1pPr>
+            <a:lvl2pPr>
+              <a:defRPr sz="2025" b="1">
+                <a:solidFill>
+                  <a:srgbClr val="111111"/>
+                </a:solidFill>
+              </a:defRPr>
+            </a:lvl2pPr>
+            <a:lvl3pPr>
+              <a:defRPr sz="2025" b="1">
+                <a:solidFill>
+                  <a:srgbClr val="111111"/>
+                </a:solidFill>
+              </a:defRPr>
+            </a:lvl3pPr>
+            <a:lvl4pPr>
+              <a:defRPr sz="2025" b="1">
+                <a:solidFill>
+                  <a:srgbClr val="111111"/>
+                </a:solidFill>
+              </a:defRPr>
+            </a:lvl4pPr>
+            <a:lvl5pPr>
+              <a:defRPr sz="2025" b="1">
+                <a:solidFill>
+                  <a:srgbClr val="111111"/>
+                </a:solidFill>
+              </a:defRPr>
+            </a:lvl5pPr>
+            <a:lvl6pPr>
+              <a:defRPr sz="2025" b="1">
+                <a:solidFill>
+                  <a:srgbClr val="111111"/>
+                </a:solidFill>
+              </a:defRPr>
+            </a:lvl6pPr>
+            <a:lvl7pPr>
+              <a:defRPr sz="2025" b="1">
+                <a:solidFill>
+                  <a:srgbClr val="111111"/>
+                </a:solidFill>
+              </a:defRPr>
+            </a:lvl7pPr>
+            <a:lvl8pPr>
+              <a:defRPr sz="2025" b="1">
+                <a:solidFill>
+                  <a:srgbClr val="111111"/>
+                </a:solidFill>
+              </a:defRPr>
+            </a:lvl8pPr>
+            <a:lvl9pPr>
+              <a:defRPr sz="2025" b="1">
+                <a:solidFill>
+                  <a:srgbClr val="111111"/>
+                </a:solidFill>
+              </a:defRPr>
+            </a:lvl9pPr>
+          </a:lstStyle>
+          <a:p xmlns:a="http://schemas.openxmlformats.org/drawingml/2006/main">
+            <a:pPr>
+              <a:defRPr sz="2025" b="1">
+                <a:solidFill>
+                  <a:srgbClr val="111111"/>
+                </a:solidFill>
+              </a:defRPr>
+            </a:pPr>
+            <a:r>
+              <a:rPr sz="2025" b="1">
+                <a:solidFill>
+                  <a:srgbClr val="111111"/>
+                </a:solidFill>
+              </a:rPr>
+              <a:t>Easier adoption</a:t>
+            </a:r>
+          </a:p>
+        </p:txBody>
+      </p:sp>
+      <p:sp>
+        <p:nvSpPr>
+          <p:cNvPr id="29" name="adoption-body">
+            <a:extLst xmlns:a="http://schemas.openxmlformats.org/drawingml/2006/main">
+              <a:ext uri="{FF2B5EF4-FFF2-40B4-BE49-F238E27FC236}">
+                <a16:creationId xmlns:a16="http://schemas.microsoft.com/office/drawing/2014/main" id="{DC137878-A080-4B73-B5CB-8AD2F583F31C}"/>
+              </a:ext>
+            </a:extLst>
+          </p:cNvPr>
+          <p:cNvSpPr>
+            <a:spLocks xmlns:a="http://schemas.openxmlformats.org/drawingml/2006/main" noGrp="1"/>
+          </p:cNvSpPr>
+          <p:nvPr/>
+        </p:nvSpPr>
+        <p:spPr>
+          <a:xfrm xmlns:a="http://schemas.openxmlformats.org/drawingml/2006/main">
+            <a:off x="9105900" y="4791075"/>
+            <a:ext cx="2476500" cy="838200"/>
+          </a:xfrm>
+          <a:prstGeom xmlns:a="http://schemas.openxmlformats.org/drawingml/2006/main" prst="rect">
+            <a:avLst/>
+          </a:prstGeom>
+          <a:noFill xmlns:a="http://schemas.openxmlformats.org/drawingml/2006/main"/>
+          <a:ln xmlns:a="http://schemas.openxmlformats.org/drawingml/2006/main" w="0">
+            <a:noFill/>
+            <a:prstDash val="solid"/>
+          </a:ln>
+        </p:spPr>
+        <p:txBody>
+          <a:bodyPr xmlns:a="http://schemas.openxmlformats.org/drawingml/2006/main" lIns="0" tIns="0" rIns="0" bIns="0"/>
+          <a:lstStyle xmlns:a="http://schemas.openxmlformats.org/drawingml/2006/main">
+            <a:defPPr>
+              <a:defRPr sz="1575" b="0">
+                <a:solidFill>
+                  <a:srgbClr val="646464"/>
+                </a:solidFill>
+              </a:defRPr>
+            </a:defPPr>
+            <a:lvl1pPr>
+              <a:defRPr sz="1575" b="0">
+                <a:solidFill>
+                  <a:srgbClr val="646464"/>
+                </a:solidFill>
+              </a:defRPr>
+            </a:lvl1pPr>
+            <a:lvl2pPr>
+              <a:defRPr sz="1575" b="0">
+                <a:solidFill>
+                  <a:srgbClr val="646464"/>
+                </a:solidFill>
+              </a:defRPr>
+            </a:lvl2pPr>
+            <a:lvl3pPr>
+              <a:defRPr sz="1575" b="0">
+                <a:solidFill>
+                  <a:srgbClr val="646464"/>
+                </a:solidFill>
+              </a:defRPr>
+            </a:lvl3pPr>
+            <a:lvl4pPr>
+              <a:defRPr sz="1575" b="0">
+                <a:solidFill>
+                  <a:srgbClr val="646464"/>
+                </a:solidFill>
+              </a:defRPr>
+            </a:lvl4pPr>
+            <a:lvl5pPr>
+              <a:defRPr sz="1575" b="0">
+                <a:solidFill>
+                  <a:srgbClr val="646464"/>
+                </a:solidFill>
+              </a:defRPr>
+            </a:lvl5pPr>
+            <a:lvl6pPr>
+              <a:defRPr sz="1575" b="0">
+                <a:solidFill>
+                  <a:srgbClr val="646464"/>
+                </a:solidFill>
+              </a:defRPr>
+            </a:lvl6pPr>
+            <a:lvl7pPr>
+              <a:defRPr sz="1575" b="0">
+                <a:solidFill>
+                  <a:srgbClr val="646464"/>
+                </a:solidFill>
+              </a:defRPr>
+            </a:lvl7pPr>
+            <a:lvl8pPr>
+              <a:defRPr sz="1575" b="0">
+                <a:solidFill>
+                  <a:srgbClr val="646464"/>
+                </a:solidFill>
+              </a:defRPr>
+            </a:lvl8pPr>
+            <a:lvl9pPr>
+              <a:defRPr sz="1575" b="0">
+                <a:solidFill>
+                  <a:srgbClr val="646464"/>
+                </a:solidFill>
+              </a:defRPr>
+            </a:lvl9pPr>
+          </a:lstStyle>
+          <a:p xmlns:a="http://schemas.openxmlformats.org/drawingml/2006/main">
+            <a:pPr>
+              <a:defRPr sz="1575" b="0">
+                <a:solidFill>
+                  <a:srgbClr val="646464"/>
+                </a:solidFill>
+              </a:defRPr>
+            </a:pPr>
+            <a:r>
+              <a:rPr sz="1575" b="0">
+                <a:solidFill>
+                  <a:srgbClr val="646464"/>
+                </a:solidFill>
+              </a:rPr>
+              <a:t>Predictable results and visible execution traces can build trust.</a:t>
+            </a:r>
+          </a:p>
+        </p:txBody>
+      </p:sp>
+      <p:sp>
+        <p:nvSpPr>
+          <p:cNvPr id="30" name="feasibility-rule">
+            <a:extLst xmlns:a="http://schemas.openxmlformats.org/drawingml/2006/main">
+              <a:ext uri="{FF2B5EF4-FFF2-40B4-BE49-F238E27FC236}">
+                <a16:creationId xmlns:a16="http://schemas.microsoft.com/office/drawing/2014/main" id="{58478EE3-BEFE-4D13-AB34-30855F03CDB6}"/>
+              </a:ext>
+            </a:extLst>
+          </p:cNvPr>
+          <p:cNvSpPr>
+            <a:spLocks xmlns:a="http://schemas.openxmlformats.org/drawingml/2006/main" noGrp="1"/>
+          </p:cNvSpPr>
+          <p:nvPr/>
+        </p:nvSpPr>
+        <p:spPr>
+          <a:xfrm xmlns:a="http://schemas.openxmlformats.org/drawingml/2006/main">
+            <a:off x="609600" y="5800725"/>
+            <a:ext cx="10972800" cy="0"/>
+          </a:xfrm>
+          <a:prstGeom xmlns:a="http://schemas.openxmlformats.org/drawingml/2006/main" prst="line">
+            <a:avLst/>
+          </a:prstGeom>
+          <a:noFill xmlns:a="http://schemas.openxmlformats.org/drawingml/2006/main"/>
+          <a:ln xmlns:a="http://schemas.openxmlformats.org/drawingml/2006/main" w="9525">
+            <a:solidFill>
+              <a:srgbClr val="D6D2C9"/>
+            </a:solidFill>
+            <a:prstDash val="solid"/>
+          </a:ln>
+        </p:spPr>
+      </p:sp>
+      <p:sp>
+        <p:nvSpPr>
+          <p:cNvPr id="31" name="feasibility-label">
+            <a:extLst xmlns:a="http://schemas.openxmlformats.org/drawingml/2006/main">
+              <a:ext uri="{FF2B5EF4-FFF2-40B4-BE49-F238E27FC236}">
+                <a16:creationId xmlns:a16="http://schemas.microsoft.com/office/drawing/2014/main" id="{46CE523F-C18E-4F15-82B7-2DF0959FE8BE}"/>
+              </a:ext>
+            </a:extLst>
+          </p:cNvPr>
+          <p:cNvSpPr>
+            <a:spLocks xmlns:a="http://schemas.openxmlformats.org/drawingml/2006/main" noGrp="1"/>
+          </p:cNvSpPr>
+          <p:nvPr/>
+        </p:nvSpPr>
+        <p:spPr>
+          <a:xfrm xmlns:a="http://schemas.openxmlformats.org/drawingml/2006/main">
+            <a:off x="609600" y="6010275"/>
+            <a:ext cx="1714500" cy="285750"/>
+          </a:xfrm>
+          <a:prstGeom xmlns:a="http://schemas.openxmlformats.org/drawingml/2006/main" prst="rect">
+            <a:avLst/>
+          </a:prstGeom>
+          <a:noFill xmlns:a="http://schemas.openxmlformats.org/drawingml/2006/main"/>
+          <a:ln xmlns:a="http://schemas.openxmlformats.org/drawingml/2006/main" w="0">
+            <a:noFill/>
+            <a:prstDash val="solid"/>
+          </a:ln>
+        </p:spPr>
+        <p:txBody>
+          <a:bodyPr xmlns:a="http://schemas.openxmlformats.org/drawingml/2006/main" lIns="0" tIns="0" rIns="0" bIns="0"/>
+          <a:lstStyle xmlns:a="http://schemas.openxmlformats.org/drawingml/2006/main">
+            <a:defPPr>
+              <a:defRPr sz="1275" b="1">
+                <a:solidFill>
+                  <a:srgbClr val="F25037"/>
+                </a:solidFill>
+              </a:defRPr>
+            </a:defPPr>
+            <a:lvl1pPr>
+              <a:defRPr sz="1275" b="1">
+                <a:solidFill>
+                  <a:srgbClr val="F25037"/>
+                </a:solidFill>
+              </a:defRPr>
+            </a:lvl1pPr>
+            <a:lvl2pPr>
+              <a:defRPr sz="1275" b="1">
+                <a:solidFill>
+                  <a:srgbClr val="F25037"/>
+                </a:solidFill>
+              </a:defRPr>
+            </a:lvl2pPr>
+            <a:lvl3pPr>
+              <a:defRPr sz="1275" b="1">
+                <a:solidFill>
+                  <a:srgbClr val="F25037"/>
+                </a:solidFill>
+              </a:defRPr>
+            </a:lvl3pPr>
+            <a:lvl4pPr>
+              <a:defRPr sz="1275" b="1">
+                <a:solidFill>
+                  <a:srgbClr val="F25037"/>
+                </a:solidFill>
+              </a:defRPr>
+            </a:lvl4pPr>
+            <a:lvl5pPr>
+              <a:defRPr sz="1275" b="1">
+                <a:solidFill>
+                  <a:srgbClr val="F25037"/>
+                </a:solidFill>
+              </a:defRPr>
+            </a:lvl5pPr>
+            <a:lvl6pPr>
+              <a:defRPr sz="1275" b="1">
+                <a:solidFill>
+                  <a:srgbClr val="F25037"/>
+                </a:solidFill>
+              </a:defRPr>
+            </a:lvl6pPr>
+            <a:lvl7pPr>
+              <a:defRPr sz="1275" b="1">
+                <a:solidFill>
+                  <a:srgbClr val="F25037"/>
+                </a:solidFill>
+              </a:defRPr>
+            </a:lvl7pPr>
+            <a:lvl8pPr>
+              <a:defRPr sz="1275" b="1">
+                <a:solidFill>
+                  <a:srgbClr val="F25037"/>
+                </a:solidFill>
+              </a:defRPr>
+            </a:lvl8pPr>
+            <a:lvl9pPr>
+              <a:defRPr sz="1275" b="1">
+                <a:solidFill>
+                  <a:srgbClr val="F25037"/>
+                </a:solidFill>
+              </a:defRPr>
+            </a:lvl9pPr>
+          </a:lstStyle>
+          <a:p xmlns:a="http://schemas.openxmlformats.org/drawingml/2006/main">
+            <a:pPr>
+              <a:defRPr sz="1275" b="1">
+                <a:solidFill>
+                  <a:srgbClr val="F25037"/>
+                </a:solidFill>
+              </a:defRPr>
+            </a:pPr>
+            <a:r>
+              <a:rPr sz="1275" b="1">
+                <a:solidFill>
+                  <a:srgbClr val="F25037"/>
+                </a:solidFill>
+              </a:rPr>
+              <a:t>FEASIBLE MVP</a:t>
+            </a:r>
+          </a:p>
+        </p:txBody>
+      </p:sp>
+      <p:sp>
+        <p:nvSpPr>
+          <p:cNvPr id="32" name="feasibility-body">
+            <a:extLst xmlns:a="http://schemas.openxmlformats.org/drawingml/2006/main">
+              <a:ext uri="{FF2B5EF4-FFF2-40B4-BE49-F238E27FC236}">
+                <a16:creationId xmlns:a16="http://schemas.microsoft.com/office/drawing/2014/main" id="{D9BF5634-F1AA-44A0-BCF8-DC999A4BCEA7}"/>
+              </a:ext>
+            </a:extLst>
+          </p:cNvPr>
+          <p:cNvSpPr>
+            <a:spLocks xmlns:a="http://schemas.openxmlformats.org/drawingml/2006/main" noGrp="1"/>
+          </p:cNvSpPr>
+          <p:nvPr/>
+        </p:nvSpPr>
+        <p:spPr>
+          <a:xfrm xmlns:a="http://schemas.openxmlformats.org/drawingml/2006/main">
+            <a:off x="2381250" y="5953125"/>
+            <a:ext cx="9201150" cy="581025"/>
+          </a:xfrm>
+          <a:prstGeom xmlns:a="http://schemas.openxmlformats.org/drawingml/2006/main" prst="rect">
+            <a:avLst/>
+          </a:prstGeom>
+          <a:noFill xmlns:a="http://schemas.openxmlformats.org/drawingml/2006/main"/>
+          <a:ln xmlns:a="http://schemas.openxmlformats.org/drawingml/2006/main" w="0">
+            <a:noFill/>
+            <a:prstDash val="solid"/>
+          </a:ln>
+        </p:spPr>
+        <p:txBody>
+          <a:bodyPr xmlns:a="http://schemas.openxmlformats.org/drawingml/2006/main" lIns="0" tIns="0" rIns="0" bIns="0"/>
+          <a:lstStyle xmlns:a="http://schemas.openxmlformats.org/drawingml/2006/main">
+            <a:defPPr>
+              <a:defRPr sz="1725" b="0">
+                <a:solidFill>
+                  <a:srgbClr val="111111"/>
+                </a:solidFill>
+              </a:defRPr>
+            </a:defPPr>
+            <a:lvl1pPr>
+              <a:defRPr sz="1725" b="0">
+                <a:solidFill>
+                  <a:srgbClr val="111111"/>
+                </a:solidFill>
+              </a:defRPr>
+            </a:lvl1pPr>
+            <a:lvl2pPr>
+              <a:defRPr sz="1725" b="0">
+                <a:solidFill>
+                  <a:srgbClr val="111111"/>
+                </a:solidFill>
+              </a:defRPr>
+            </a:lvl2pPr>
+            <a:lvl3pPr>
+              <a:defRPr sz="1725" b="0">
+                <a:solidFill>
+                  <a:srgbClr val="111111"/>
+                </a:solidFill>
+              </a:defRPr>
+            </a:lvl3pPr>
+            <a:lvl4pPr>
+              <a:defRPr sz="1725" b="0">
+                <a:solidFill>
+                  <a:srgbClr val="111111"/>
+                </a:solidFill>
+              </a:defRPr>
+            </a:lvl4pPr>
+            <a:lvl5pPr>
+              <a:defRPr sz="1725" b="0">
+                <a:solidFill>
+                  <a:srgbClr val="111111"/>
+                </a:solidFill>
+              </a:defRPr>
+            </a:lvl5pPr>
+            <a:lvl6pPr>
+              <a:defRPr sz="1725" b="0">
+                <a:solidFill>
+                  <a:srgbClr val="111111"/>
+                </a:solidFill>
+              </a:defRPr>
+            </a:lvl6pPr>
+            <a:lvl7pPr>
+              <a:defRPr sz="1725" b="0">
+                <a:solidFill>
+                  <a:srgbClr val="111111"/>
+                </a:solidFill>
+              </a:defRPr>
+            </a:lvl7pPr>
+            <a:lvl8pPr>
+              <a:defRPr sz="1725" b="0">
+                <a:solidFill>
+                  <a:srgbClr val="111111"/>
+                </a:solidFill>
+              </a:defRPr>
+            </a:lvl8pPr>
+            <a:lvl9pPr>
+              <a:defRPr sz="1725" b="0">
+                <a:solidFill>
+                  <a:srgbClr val="111111"/>
+                </a:solidFill>
+              </a:defRPr>
+            </a:lvl9pPr>
+          </a:lstStyle>
+          <a:p xmlns:a="http://schemas.openxmlformats.org/drawingml/2006/main">
+            <a:pPr>
+              <a:defRPr sz="1725" b="0">
+                <a:solidFill>
+                  <a:srgbClr val="111111"/>
+                </a:solidFill>
+              </a:defRPr>
+            </a:pPr>
+            <a:r>
+              <a:rPr sz="1725" b="0">
+                <a:solidFill>
+                  <a:srgbClr val="111111"/>
+                </a:solidFill>
+              </a:rPr>
+              <a:t>A bounded module catalog, typed inputs and outputs, and reference tests</a:t>
+            </a:r>
+          </a:p>
+          <a:p xmlns:a="http://schemas.openxmlformats.org/drawingml/2006/main">
+            <a:pPr>
+              <a:defRPr sz="1725" b="0">
+                <a:solidFill>
+                  <a:srgbClr val="111111"/>
+                </a:solidFill>
+              </a:defRPr>
+            </a:pPr>
+            <a:r>
+              <a:rPr sz="1725" b="0">
+                <a:solidFill>
+                  <a:srgbClr val="111111"/>
+                </a:solidFill>
+              </a:rPr>
+              <a:t>run on one shared execution runtime.</a:t>
+            </a:r>
+          </a:p>
+        </p:txBody>
+      </p:sp>
+      <p:sp>
+        <p:nvSpPr>
+          <p:cNvPr id="33" name="assumptions">
+            <a:extLst xmlns:a="http://schemas.openxmlformats.org/drawingml/2006/main">
+              <a:ext uri="{FF2B5EF4-FFF2-40B4-BE49-F238E27FC236}">
+                <a16:creationId xmlns:a16="http://schemas.microsoft.com/office/drawing/2014/main" id="{6A3F0434-B2E9-4F43-95C9-058814FB1738}"/>
+              </a:ext>
+            </a:extLst>
+          </p:cNvPr>
+          <p:cNvSpPr>
+            <a:spLocks xmlns:a="http://schemas.openxmlformats.org/drawingml/2006/main" noGrp="1"/>
+          </p:cNvSpPr>
+          <p:nvPr/>
+        </p:nvSpPr>
+        <p:spPr>
+          <a:xfrm xmlns:a="http://schemas.openxmlformats.org/drawingml/2006/main">
+            <a:off x="609600" y="6581775"/>
+            <a:ext cx="10648950" cy="219075"/>
+          </a:xfrm>
+          <a:prstGeom xmlns:a="http://schemas.openxmlformats.org/drawingml/2006/main" prst="rect">
+            <a:avLst/>
+          </a:prstGeom>
+          <a:noFill xmlns:a="http://schemas.openxmlformats.org/drawingml/2006/main"/>
+          <a:ln xmlns:a="http://schemas.openxmlformats.org/drawingml/2006/main" w="0">
+            <a:noFill/>
+            <a:prstDash val="solid"/>
+          </a:ln>
+        </p:spPr>
+        <p:txBody>
+          <a:bodyPr xmlns:a="http://schemas.openxmlformats.org/drawingml/2006/main" lIns="0" tIns="0" rIns="0" bIns="0"/>
+          <a:lstStyle xmlns:a="http://schemas.openxmlformats.org/drawingml/2006/main">
+            <a:defPPr>
+              <a:defRPr sz="1125" b="0">
+                <a:solidFill>
+                  <a:srgbClr val="646464"/>
+                </a:solidFill>
+              </a:defRPr>
+            </a:defPPr>
+            <a:lvl1pPr>
+              <a:defRPr sz="1125" b="0">
+                <a:solidFill>
+                  <a:srgbClr val="646464"/>
+                </a:solidFill>
+              </a:defRPr>
+            </a:lvl1pPr>
+            <a:lvl2pPr>
+              <a:defRPr sz="1125" b="0">
+                <a:solidFill>
+                  <a:srgbClr val="646464"/>
+                </a:solidFill>
+              </a:defRPr>
+            </a:lvl2pPr>
+            <a:lvl3pPr>
+              <a:defRPr sz="1125" b="0">
+                <a:solidFill>
+                  <a:srgbClr val="646464"/>
+                </a:solidFill>
+              </a:defRPr>
+            </a:lvl3pPr>
+            <a:lvl4pPr>
+              <a:defRPr sz="1125" b="0">
+                <a:solidFill>
+                  <a:srgbClr val="646464"/>
+                </a:solidFill>
+              </a:defRPr>
+            </a:lvl4pPr>
+            <a:lvl5pPr>
+              <a:defRPr sz="1125" b="0">
+                <a:solidFill>
+                  <a:srgbClr val="646464"/>
+                </a:solidFill>
+              </a:defRPr>
+            </a:lvl5pPr>
+            <a:lvl6pPr>
+              <a:defRPr sz="1125" b="0">
+                <a:solidFill>
+                  <a:srgbClr val="646464"/>
+                </a:solidFill>
+              </a:defRPr>
+            </a:lvl6pPr>
+            <a:lvl7pPr>
+              <a:defRPr sz="1125" b="0">
+                <a:solidFill>
+                  <a:srgbClr val="646464"/>
+                </a:solidFill>
+              </a:defRPr>
+            </a:lvl7pPr>
+            <a:lvl8pPr>
+              <a:defRPr sz="1125" b="0">
+                <a:solidFill>
+                  <a:srgbClr val="646464"/>
+                </a:solidFill>
+              </a:defRPr>
+            </a:lvl8pPr>
+            <a:lvl9pPr>
+              <a:defRPr sz="1125" b="0">
+                <a:solidFill>
+                  <a:srgbClr val="646464"/>
+                </a:solidFill>
+              </a:defRPr>
+            </a:lvl9pPr>
+          </a:lstStyle>
+          <a:p xmlns:a="http://schemas.openxmlformats.org/drawingml/2006/main">
+            <a:pPr>
+              <a:defRPr sz="1125" b="0">
+                <a:solidFill>
+                  <a:srgbClr val="646464"/>
+                </a:solidFill>
+              </a:defRPr>
+            </a:pPr>
+            <a:r>
+              <a:rPr sz="1125" b="0">
+                <a:solidFill>
+                  <a:srgbClr val="646464"/>
+                </a:solidFill>
+              </a:rPr>
+              <a:t>Model: 70 fixed + 30 LLM. 60% less LLM spend + 3 execution = 85 total. Illustrative assumptions, not measured.</a:t>
             </a:r>
           </a:p>
         </p:txBody>

</xml_diff>